<commit_message>
Records: option A final; options file and alternate slides retired
Co-Authored-By: Claude Opus 5.5 <noreply@anthropic.com>
Claude-Session: https://claude.ai/code/session_01Xa4nFVxuQGXmHARGph9WhS
</commit_message>
<xml_diff>
--- a/day2-deck/decks/Store Records - Opening.pptx
+++ b/day2-deck/decks/Store Records - Opening.pptx
@@ -7,11 +7,9 @@
   <p:sldIdLst>
     <p:sldId id="256" r:id="rId2"/>
     <p:sldId id="257" r:id="rId3"/>
-    <p:sldId id="258" r:id="rId4"/>
-    <p:sldId id="259" r:id="rId5"/>
   </p:sldIdLst>
   <p:notesMasterIdLst>
-    <p:notesMasterId r:id="rId6"/>
+    <p:notesMasterId r:id="rId4"/>
   </p:notesMasterIdLst>
   <p:sldSz cx="12192000" cy="6858000"/>
   <p:notesSz cx="6858000" cy="12192000"/>
@@ -593,7 +591,7 @@
           <a:p>
             <a:r>
               <a:rPr lang="en-US" dirty="0"/>
-              <a:t>Source: Qlik - Fixed Ops Accounting TB, fixed gross (service and parts), monthly by store, January 2021 - September 2026. A record = the store's highest month on file; months before a store opened are ignored. GMC Prescott service on the TB includes body shop gross. Records = each month a store beat its best-ever service, parts or combined month; one month can count up to three.OPTION A. Records by store (month: service / parts / combined, with the record it beat):
+              <a:t>Source: Qlik - Fixed Ops Accounting TB, fixed gross (service and parts), monthly by store, January 2021 - September 2026. A record = the store's highest month on file; months before a store opened are ignored. GMC Prescott service on the TB includes body shop gross. Records = each month a store beat its best-ever service, parts or combined month; one month can count up to three.Records by store (month: service / parts / combined, with the record it beat):
 Toyota Henderson: service Apr 2026 $1.86M (beat $1.78M, Apr 2025); service Jul 2026 $1.98M (beat $1.86M, Apr 2026); parts Jun 2026 $747K (beat $734K, Dec 2024); parts Aug 2026 $748K (beat $747K, Jun 2026); parts Sep 2026 $803K (beat $748K, Aug 2026); combined Apr 2026 $2.52M (beat $2.45M, Apr 2025); combined Jun 2026 $2.55M (beat $2.52M, Apr 2026); combined Jul 2026 $2.72M (beat $2.55M, Jun 2026)
 Honda Spokane: service Mar 2026 $309K (beat $290K, May 2025); service Apr 2026 $316K (beat $309K, Mar 2026); service Jun 2026 $343K (beat $316K, Apr 2026); service Jul 2026 $360K (beat $343K, Jun 2026); parts Jul 2026 $182K (beat $168K, Aug 2025); combined Mar 2026 $457K (beat $448K, May 2025); combined Apr 2026 $473K (beat $457K, Mar 2026); combined Jun 2026 $503K (beat $473K, Apr 2026); combined Jul 2026 $542K (beat $503K, Jun 2026)
 Nissan: service Mar 2026 $374K (beat $374K, May 2025); service Jun 2026 $379K (beat $374K, Mar 2026); service Sep 2026 $393K (beat $379K, Jun 2026); parts Jun 2026 $191K (beat $187K, Aug 2024); parts Jul 2026 $210K (beat $191K, Jun 2026); combined Mar 2026 $546K (beat $535K, May 2025); combined Jun 2026 $570K (beat $546K, Mar 2026); combined Jul 2026 $580K (beat $570K, Jun 2026); combined Sep 2026 $593K (beat $580K, Jul 2026)
@@ -640,182 +638,6 @@
             <a:fld id="{F7021451-1387-4CA6-816F-3879F97B5CBC}" type="slidenum">
               <a:rPr lang="en-US"/>
               <a:t>2</a:t>
-            </a:fld>
-            <a:endParaRPr lang="en-US"/>
-          </a:p>
-        </p:txBody>
-      </p:sp>
-    </p:spTree>
-    <p:extLst>
-      <p:ext uri="{BB962C8B-B14F-4D97-AF65-F5344CB8AC3E}">
-        <p14:creationId xmlns:p14="http://schemas.microsoft.com/office/powerpoint/2010/main" val="1024086991"/>
-      </p:ext>
-    </p:extLst>
-  </p:cSld>
-  <p:clrMapOvr>
-    <a:masterClrMapping/>
-  </p:clrMapOvr>
-</p:notes>
-</file>
-
-<file path=ppt/notesSlides/notesSlide3.xml><?xml version="1.0" encoding="utf-8"?>
-<p:notes xmlns:a="http://schemas.openxmlformats.org/drawingml/2006/main" xmlns:r="http://schemas.openxmlformats.org/officeDocument/2006/relationships" xmlns:p="http://schemas.openxmlformats.org/presentationml/2006/main">
-  <p:cSld>
-    <p:spTree>
-      <p:nvGrpSpPr>
-        <p:cNvPr id="1" name=""/>
-        <p:cNvGrpSpPr/>
-        <p:nvPr/>
-      </p:nvGrpSpPr>
-      <p:grpSpPr>
-        <a:xfrm>
-          <a:off x="0" y="0"/>
-          <a:ext cx="0" cy="0"/>
-          <a:chOff x="0" y="0"/>
-          <a:chExt cx="0" cy="0"/>
-        </a:xfrm>
-      </p:grpSpPr>
-      <p:sp>
-        <p:nvSpPr>
-          <p:cNvPr id="2" name="Slide Image Placeholder 1"/>
-          <p:cNvSpPr>
-            <a:spLocks noGrp="1" noRot="1" noChangeAspect="1"/>
-          </p:cNvSpPr>
-          <p:nvPr>
-            <p:ph type="sldImg"/>
-          </p:nvPr>
-        </p:nvSpPr>
-        <p:spPr/>
-      </p:sp>
-      <p:sp>
-        <p:nvSpPr>
-          <p:cNvPr id="3" name="Notes Placeholder 2"/>
-          <p:cNvSpPr>
-            <a:spLocks noGrp="1"/>
-          </p:cNvSpPr>
-          <p:nvPr>
-            <p:ph type="body" idx="1"/>
-          </p:nvPr>
-        </p:nvSpPr>
-        <p:spPr/>
-        <p:txBody>
-          <a:bodyPr/>
-          <a:lstStyle/>
-          <a:p>
-            <a:r>
-              <a:rPr lang="en-US" dirty="0"/>
-              <a:t>Source: Qlik - Fixed Ops Accounting TB, fixed gross (service and parts), monthly by store, January 2021 - September 2026. A record = the store's highest month on file; months before a store opened are ignored. GMC Prescott service on the TB includes body shop gross. Count = every record set: service, parts and combined counted separately. Months listed are the months each record was set.OPTION B: one line per store, how many records and which months.</a:t>
-            </a:r>
-            <a:endParaRPr lang="en-US" dirty="0"/>
-          </a:p>
-        </p:txBody>
-      </p:sp>
-      <p:sp>
-        <p:nvSpPr>
-          <p:cNvPr id="4" name="Slide Number Placeholder 3"/>
-          <p:cNvSpPr>
-            <a:spLocks noGrp="1"/>
-          </p:cNvSpPr>
-          <p:nvPr>
-            <p:ph type="sldNum" sz="quarter" idx="10"/>
-          </p:nvPr>
-        </p:nvSpPr>
-        <p:spPr/>
-        <p:txBody>
-          <a:bodyPr/>
-          <a:lstStyle/>
-          <a:p>
-            <a:fld id="{F7021451-1387-4CA6-816F-3879F97B5CBC}" type="slidenum">
-              <a:rPr lang="en-US"/>
-              <a:t>3</a:t>
-            </a:fld>
-            <a:endParaRPr lang="en-US"/>
-          </a:p>
-        </p:txBody>
-      </p:sp>
-    </p:spTree>
-    <p:extLst>
-      <p:ext uri="{BB962C8B-B14F-4D97-AF65-F5344CB8AC3E}">
-        <p14:creationId xmlns:p14="http://schemas.microsoft.com/office/powerpoint/2010/main" val="1024086991"/>
-      </p:ext>
-    </p:extLst>
-  </p:cSld>
-  <p:clrMapOvr>
-    <a:masterClrMapping/>
-  </p:clrMapOvr>
-</p:notes>
-</file>
-
-<file path=ppt/notesSlides/notesSlide4.xml><?xml version="1.0" encoding="utf-8"?>
-<p:notes xmlns:a="http://schemas.openxmlformats.org/drawingml/2006/main" xmlns:r="http://schemas.openxmlformats.org/officeDocument/2006/relationships" xmlns:p="http://schemas.openxmlformats.org/presentationml/2006/main">
-  <p:cSld>
-    <p:spTree>
-      <p:nvGrpSpPr>
-        <p:cNvPr id="1" name=""/>
-        <p:cNvGrpSpPr/>
-        <p:nvPr/>
-      </p:nvGrpSpPr>
-      <p:grpSpPr>
-        <a:xfrm>
-          <a:off x="0" y="0"/>
-          <a:ext cx="0" cy="0"/>
-          <a:chOff x="0" y="0"/>
-          <a:chExt cx="0" cy="0"/>
-        </a:xfrm>
-      </p:grpSpPr>
-      <p:sp>
-        <p:nvSpPr>
-          <p:cNvPr id="2" name="Slide Image Placeholder 1"/>
-          <p:cNvSpPr>
-            <a:spLocks noGrp="1" noRot="1" noChangeAspect="1"/>
-          </p:cNvSpPr>
-          <p:nvPr>
-            <p:ph type="sldImg"/>
-          </p:nvPr>
-        </p:nvSpPr>
-        <p:spPr/>
-      </p:sp>
-      <p:sp>
-        <p:nvSpPr>
-          <p:cNvPr id="3" name="Notes Placeholder 2"/>
-          <p:cNvSpPr>
-            <a:spLocks noGrp="1"/>
-          </p:cNvSpPr>
-          <p:nvPr>
-            <p:ph type="body" idx="1"/>
-          </p:nvPr>
-        </p:nvSpPr>
-        <p:spPr/>
-        <p:txBody>
-          <a:bodyPr/>
-          <a:lstStyle/>
-          <a:p>
-            <a:r>
-              <a:rPr lang="en-US" dirty="0"/>
-              <a:t>Source: Qlik - Fixed Ops Accounting TB, fixed gross (service and parts), monthly by store, January 2021 - September 2026. A record = the store's highest month on file; months before a store opened are ignored. GMC Prescott service on the TB includes body shop gross. Records counted separately for service, parts and combined.OPTION C: the six stores with the most records in words; everyone else on one line.</a:t>
-            </a:r>
-            <a:endParaRPr lang="en-US" dirty="0"/>
-          </a:p>
-        </p:txBody>
-      </p:sp>
-      <p:sp>
-        <p:nvSpPr>
-          <p:cNvPr id="4" name="Slide Number Placeholder 3"/>
-          <p:cNvSpPr>
-            <a:spLocks noGrp="1"/>
-          </p:cNvSpPr>
-          <p:nvPr>
-            <p:ph type="sldNum" sz="quarter" idx="10"/>
-          </p:nvPr>
-        </p:nvSpPr>
-        <p:spPr/>
-        <p:txBody>
-          <a:bodyPr/>
-          <a:lstStyle/>
-          <a:p>
-            <a:fld id="{F7021451-1387-4CA6-816F-3879F97B5CBC}" type="slidenum">
-              <a:rPr lang="en-US"/>
-              <a:t>4</a:t>
             </a:fld>
             <a:endParaRPr lang="en-US"/>
           </a:p>
@@ -8408,4200 +8230,6 @@
 </p:sld>
 </file>
 
-<file path=ppt/slides/slide3.xml><?xml version="1.0" encoding="utf-8"?>
-<p:sld xmlns:a="http://schemas.openxmlformats.org/drawingml/2006/main" xmlns:r="http://schemas.openxmlformats.org/officeDocument/2006/relationships" xmlns:p="http://schemas.openxmlformats.org/presentationml/2006/main">
-  <p:cSld name="Slide 3">
-    <p:bg>
-      <p:bgPr>
-        <a:solidFill>
-          <a:srgbClr val="EDEDED"/>
-        </a:solidFill>
-      </p:bgPr>
-    </p:bg>
-    <p:spTree>
-      <p:nvGrpSpPr>
-        <p:cNvPr id="1" name=""/>
-        <p:cNvGrpSpPr/>
-        <p:nvPr/>
-      </p:nvGrpSpPr>
-      <p:grpSpPr>
-        <a:xfrm>
-          <a:off x="0" y="0"/>
-          <a:ext cx="0" cy="0"/>
-          <a:chOff x="0" y="0"/>
-          <a:chExt cx="0" cy="0"/>
-        </a:xfrm>
-      </p:grpSpPr>
-      <p:sp>
-        <p:nvSpPr>
-          <p:cNvPr id="2" name="Shape 0"/>
-          <p:cNvSpPr/>
-          <p:nvPr/>
-        </p:nvSpPr>
-        <p:spPr>
-          <a:xfrm>
-            <a:off x="457200" y="402336"/>
-            <a:ext cx="50292" cy="192024"/>
-          </a:xfrm>
-          <a:prstGeom prst="rect">
-            <a:avLst/>
-          </a:prstGeom>
-          <a:solidFill>
-            <a:srgbClr val="2587C5"/>
-          </a:solidFill>
-          <a:ln/>
-        </p:spPr>
-      </p:sp>
-      <p:sp>
-        <p:nvSpPr>
-          <p:cNvPr id="3" name="Text 1"/>
-          <p:cNvSpPr txBox="1"/>
-          <p:nvPr/>
-        </p:nvSpPr>
-        <p:spPr>
-          <a:xfrm>
-            <a:off x="621792" y="338328"/>
-            <a:ext cx="8229600" cy="274320"/>
-          </a:xfrm>
-          <a:prstGeom prst="rect">
-            <a:avLst/>
-          </a:prstGeom>
-          <a:noFill/>
-          <a:ln/>
-        </p:spPr>
-        <p:txBody>
-          <a:bodyPr wrap="square" lIns="0" tIns="0" rIns="0" bIns="0" rtlCol="0" anchor="ctr"/>
-          <a:lstStyle/>
-          <a:p>
-            <a:pPr indent="0" marL="0">
-              <a:buNone/>
-            </a:pPr>
-            <a:r>
-              <a:rPr lang="en-US" sz="1400" b="1" spc="110" kern="0" dirty="0">
-                <a:solidFill>
-                  <a:srgbClr val="595959"/>
-                </a:solidFill>
-                <a:latin typeface="Inter" pitchFamily="34" charset="0"/>
-                <a:ea typeface="Inter" pitchFamily="34" charset="-122"/>
-                <a:cs typeface="Inter" pitchFamily="34" charset="-120"/>
-              </a:rPr>
-              <a:t>FIXED OPS RECORDS</a:t>
-            </a:r>
-            <a:endParaRPr lang="en-US" sz="1400" dirty="0"/>
-          </a:p>
-        </p:txBody>
-      </p:sp>
-      <p:sp>
-        <p:nvSpPr>
-          <p:cNvPr id="4" name="Text 2"/>
-          <p:cNvSpPr txBox="1"/>
-          <p:nvPr/>
-        </p:nvSpPr>
-        <p:spPr>
-          <a:xfrm>
-            <a:off x="457200" y="640080"/>
-            <a:ext cx="11338560" cy="502920"/>
-          </a:xfrm>
-          <a:prstGeom prst="rect">
-            <a:avLst/>
-          </a:prstGeom>
-          <a:noFill/>
-          <a:ln/>
-        </p:spPr>
-        <p:txBody>
-          <a:bodyPr wrap="square" lIns="0" tIns="0" rIns="0" bIns="0" rtlCol="0" anchor="ctr"/>
-          <a:lstStyle/>
-          <a:p>
-            <a:pPr indent="0" marL="0">
-              <a:buNone/>
-            </a:pPr>
-            <a:r>
-              <a:rPr lang="en-US" sz="2800" dirty="0">
-                <a:solidFill>
-                  <a:srgbClr val="1A1A1A"/>
-                </a:solidFill>
-                <a:latin typeface="Inter" pitchFamily="34" charset="0"/>
-                <a:ea typeface="Inter" pitchFamily="34" charset="-122"/>
-                <a:cs typeface="Inter" pitchFamily="34" charset="-120"/>
-              </a:rPr>
-              <a:t>Who Set Records in 2026</a:t>
-            </a:r>
-            <a:endParaRPr lang="en-US" sz="2800" dirty="0"/>
-          </a:p>
-        </p:txBody>
-      </p:sp>
-      <p:sp>
-        <p:nvSpPr>
-          <p:cNvPr id="5" name="Shape 3"/>
-          <p:cNvSpPr/>
-          <p:nvPr/>
-        </p:nvSpPr>
-        <p:spPr>
-          <a:xfrm>
-            <a:off x="457200" y="1207008"/>
-            <a:ext cx="11274552" cy="4782312"/>
-          </a:xfrm>
-          <a:prstGeom prst="rect">
-            <a:avLst/>
-          </a:prstGeom>
-          <a:solidFill>
-            <a:srgbClr val="FFFFFF"/>
-          </a:solidFill>
-          <a:ln/>
-        </p:spPr>
-      </p:sp>
-      <p:sp>
-        <p:nvSpPr>
-          <p:cNvPr id="6" name="Shape 4"/>
-          <p:cNvSpPr/>
-          <p:nvPr/>
-        </p:nvSpPr>
-        <p:spPr>
-          <a:xfrm>
-            <a:off x="585216" y="1316736"/>
-            <a:ext cx="5440680" cy="379476"/>
-          </a:xfrm>
-          <a:prstGeom prst="rect">
-            <a:avLst/>
-          </a:prstGeom>
-          <a:solidFill>
-            <a:srgbClr val="F7F7F7"/>
-          </a:solidFill>
-          <a:ln/>
-        </p:spPr>
-      </p:sp>
-      <p:sp>
-        <p:nvSpPr>
-          <p:cNvPr id="7" name="Text 5"/>
-          <p:cNvSpPr txBox="1"/>
-          <p:nvPr/>
-        </p:nvSpPr>
-        <p:spPr>
-          <a:xfrm>
-            <a:off x="658368" y="1316736"/>
-            <a:ext cx="365760" cy="379476"/>
-          </a:xfrm>
-          <a:prstGeom prst="rect">
-            <a:avLst/>
-          </a:prstGeom>
-          <a:noFill/>
-          <a:ln/>
-        </p:spPr>
-        <p:txBody>
-          <a:bodyPr wrap="square" lIns="0" tIns="0" rIns="0" bIns="0" rtlCol="0" anchor="ctr"/>
-          <a:lstStyle/>
-          <a:p>
-            <a:pPr algn="r" indent="0" marL="0">
-              <a:buNone/>
-            </a:pPr>
-            <a:r>
-              <a:rPr lang="en-US" sz="1400" b="1" dirty="0">
-                <a:solidFill>
-                  <a:srgbClr val="0B7A4A"/>
-                </a:solidFill>
-                <a:latin typeface="Inter" pitchFamily="34" charset="0"/>
-                <a:ea typeface="Inter" pitchFamily="34" charset="-122"/>
-                <a:cs typeface="Inter" pitchFamily="34" charset="-120"/>
-              </a:rPr>
-              <a:t>9</a:t>
-            </a:r>
-            <a:endParaRPr lang="en-US" sz="1400" dirty="0"/>
-          </a:p>
-        </p:txBody>
-      </p:sp>
-      <p:sp>
-        <p:nvSpPr>
-          <p:cNvPr id="8" name="Text 6"/>
-          <p:cNvSpPr txBox="1"/>
-          <p:nvPr/>
-        </p:nvSpPr>
-        <p:spPr>
-          <a:xfrm>
-            <a:off x="1115568" y="1316736"/>
-            <a:ext cx="1783080" cy="379476"/>
-          </a:xfrm>
-          <a:prstGeom prst="rect">
-            <a:avLst/>
-          </a:prstGeom>
-          <a:noFill/>
-          <a:ln/>
-        </p:spPr>
-        <p:txBody>
-          <a:bodyPr wrap="square" lIns="0" tIns="0" rIns="0" bIns="0" rtlCol="0" anchor="ctr"/>
-          <a:lstStyle/>
-          <a:p>
-            <a:pPr indent="0" marL="0">
-              <a:buNone/>
-            </a:pPr>
-            <a:r>
-              <a:rPr lang="en-US" sz="1200" b="1" dirty="0">
-                <a:solidFill>
-                  <a:srgbClr val="1A1A1A"/>
-                </a:solidFill>
-                <a:latin typeface="Inter" pitchFamily="34" charset="0"/>
-                <a:ea typeface="Inter" pitchFamily="34" charset="-122"/>
-                <a:cs typeface="Inter" pitchFamily="34" charset="-120"/>
-              </a:rPr>
-              <a:t>HONDA SPOKANE</a:t>
-            </a:r>
-            <a:endParaRPr lang="en-US" sz="1200" dirty="0"/>
-          </a:p>
-        </p:txBody>
-      </p:sp>
-      <p:sp>
-        <p:nvSpPr>
-          <p:cNvPr id="9" name="Text 7"/>
-          <p:cNvSpPr txBox="1"/>
-          <p:nvPr/>
-        </p:nvSpPr>
-        <p:spPr>
-          <a:xfrm>
-            <a:off x="2898648" y="1316736"/>
-            <a:ext cx="3108960" cy="379476"/>
-          </a:xfrm>
-          <a:prstGeom prst="rect">
-            <a:avLst/>
-          </a:prstGeom>
-          <a:noFill/>
-          <a:ln/>
-        </p:spPr>
-        <p:txBody>
-          <a:bodyPr wrap="square" lIns="0" tIns="0" rIns="0" bIns="0" rtlCol="0" anchor="ctr"/>
-          <a:lstStyle/>
-          <a:p>
-            <a:pPr indent="0" marL="0">
-              <a:buNone/>
-            </a:pPr>
-            <a:r>
-              <a:rPr lang="en-US" sz="1200" dirty="0">
-                <a:solidFill>
-                  <a:srgbClr val="595959"/>
-                </a:solidFill>
-                <a:latin typeface="Inter" pitchFamily="34" charset="0"/>
-                <a:ea typeface="Inter" pitchFamily="34" charset="-122"/>
-                <a:cs typeface="Inter" pitchFamily="34" charset="-120"/>
-              </a:rPr>
-              <a:t>Service: Mar, Apr, Jun, Jul  ·  Parts: Jul  ·  Combined: Mar, Apr, Jun, Jul</a:t>
-            </a:r>
-            <a:endParaRPr lang="en-US" sz="1200" dirty="0"/>
-          </a:p>
-        </p:txBody>
-      </p:sp>
-      <p:sp>
-        <p:nvSpPr>
-          <p:cNvPr id="10" name="Text 8"/>
-          <p:cNvSpPr txBox="1"/>
-          <p:nvPr/>
-        </p:nvSpPr>
-        <p:spPr>
-          <a:xfrm>
-            <a:off x="658368" y="1696212"/>
-            <a:ext cx="365760" cy="379476"/>
-          </a:xfrm>
-          <a:prstGeom prst="rect">
-            <a:avLst/>
-          </a:prstGeom>
-          <a:noFill/>
-          <a:ln/>
-        </p:spPr>
-        <p:txBody>
-          <a:bodyPr wrap="square" lIns="0" tIns="0" rIns="0" bIns="0" rtlCol="0" anchor="ctr"/>
-          <a:lstStyle/>
-          <a:p>
-            <a:pPr algn="r" indent="0" marL="0">
-              <a:buNone/>
-            </a:pPr>
-            <a:r>
-              <a:rPr lang="en-US" sz="1400" b="1" dirty="0">
-                <a:solidFill>
-                  <a:srgbClr val="0B7A4A"/>
-                </a:solidFill>
-                <a:latin typeface="Inter" pitchFamily="34" charset="0"/>
-                <a:ea typeface="Inter" pitchFamily="34" charset="-122"/>
-                <a:cs typeface="Inter" pitchFamily="34" charset="-120"/>
-              </a:rPr>
-              <a:t>9</a:t>
-            </a:r>
-            <a:endParaRPr lang="en-US" sz="1400" dirty="0"/>
-          </a:p>
-        </p:txBody>
-      </p:sp>
-      <p:sp>
-        <p:nvSpPr>
-          <p:cNvPr id="11" name="Text 9"/>
-          <p:cNvSpPr txBox="1"/>
-          <p:nvPr/>
-        </p:nvSpPr>
-        <p:spPr>
-          <a:xfrm>
-            <a:off x="1115568" y="1696212"/>
-            <a:ext cx="1783080" cy="379476"/>
-          </a:xfrm>
-          <a:prstGeom prst="rect">
-            <a:avLst/>
-          </a:prstGeom>
-          <a:noFill/>
-          <a:ln/>
-        </p:spPr>
-        <p:txBody>
-          <a:bodyPr wrap="square" lIns="0" tIns="0" rIns="0" bIns="0" rtlCol="0" anchor="ctr"/>
-          <a:lstStyle/>
-          <a:p>
-            <a:pPr indent="0" marL="0">
-              <a:buNone/>
-            </a:pPr>
-            <a:r>
-              <a:rPr lang="en-US" sz="1200" b="1" dirty="0">
-                <a:solidFill>
-                  <a:srgbClr val="1A1A1A"/>
-                </a:solidFill>
-                <a:latin typeface="Inter" pitchFamily="34" charset="0"/>
-                <a:ea typeface="Inter" pitchFamily="34" charset="-122"/>
-                <a:cs typeface="Inter" pitchFamily="34" charset="-120"/>
-              </a:rPr>
-              <a:t>NISSAN</a:t>
-            </a:r>
-            <a:endParaRPr lang="en-US" sz="1200" dirty="0"/>
-          </a:p>
-        </p:txBody>
-      </p:sp>
-      <p:sp>
-        <p:nvSpPr>
-          <p:cNvPr id="12" name="Text 10"/>
-          <p:cNvSpPr txBox="1"/>
-          <p:nvPr/>
-        </p:nvSpPr>
-        <p:spPr>
-          <a:xfrm>
-            <a:off x="2898648" y="1696212"/>
-            <a:ext cx="3108960" cy="379476"/>
-          </a:xfrm>
-          <a:prstGeom prst="rect">
-            <a:avLst/>
-          </a:prstGeom>
-          <a:noFill/>
-          <a:ln/>
-        </p:spPr>
-        <p:txBody>
-          <a:bodyPr wrap="square" lIns="0" tIns="0" rIns="0" bIns="0" rtlCol="0" anchor="ctr"/>
-          <a:lstStyle/>
-          <a:p>
-            <a:pPr indent="0" marL="0">
-              <a:buNone/>
-            </a:pPr>
-            <a:r>
-              <a:rPr lang="en-US" sz="1200" dirty="0">
-                <a:solidFill>
-                  <a:srgbClr val="595959"/>
-                </a:solidFill>
-                <a:latin typeface="Inter" pitchFamily="34" charset="0"/>
-                <a:ea typeface="Inter" pitchFamily="34" charset="-122"/>
-                <a:cs typeface="Inter" pitchFamily="34" charset="-120"/>
-              </a:rPr>
-              <a:t>Service: Mar, Jun, Sep  ·  Parts: Jun, Jul  ·  Combined: Mar, Jun, Jul, Sep</a:t>
-            </a:r>
-            <a:endParaRPr lang="en-US" sz="1200" dirty="0"/>
-          </a:p>
-        </p:txBody>
-      </p:sp>
-      <p:sp>
-        <p:nvSpPr>
-          <p:cNvPr id="13" name="Shape 11"/>
-          <p:cNvSpPr/>
-          <p:nvPr/>
-        </p:nvSpPr>
-        <p:spPr>
-          <a:xfrm>
-            <a:off x="585216" y="2075688"/>
-            <a:ext cx="5440680" cy="379476"/>
-          </a:xfrm>
-          <a:prstGeom prst="rect">
-            <a:avLst/>
-          </a:prstGeom>
-          <a:solidFill>
-            <a:srgbClr val="F7F7F7"/>
-          </a:solidFill>
-          <a:ln/>
-        </p:spPr>
-      </p:sp>
-      <p:sp>
-        <p:nvSpPr>
-          <p:cNvPr id="14" name="Text 12"/>
-          <p:cNvSpPr txBox="1"/>
-          <p:nvPr/>
-        </p:nvSpPr>
-        <p:spPr>
-          <a:xfrm>
-            <a:off x="658368" y="2075688"/>
-            <a:ext cx="365760" cy="379476"/>
-          </a:xfrm>
-          <a:prstGeom prst="rect">
-            <a:avLst/>
-          </a:prstGeom>
-          <a:noFill/>
-          <a:ln/>
-        </p:spPr>
-        <p:txBody>
-          <a:bodyPr wrap="square" lIns="0" tIns="0" rIns="0" bIns="0" rtlCol="0" anchor="ctr"/>
-          <a:lstStyle/>
-          <a:p>
-            <a:pPr algn="r" indent="0" marL="0">
-              <a:buNone/>
-            </a:pPr>
-            <a:r>
-              <a:rPr lang="en-US" sz="1400" b="1" dirty="0">
-                <a:solidFill>
-                  <a:srgbClr val="0B7A4A"/>
-                </a:solidFill>
-                <a:latin typeface="Inter" pitchFamily="34" charset="0"/>
-                <a:ea typeface="Inter" pitchFamily="34" charset="-122"/>
-                <a:cs typeface="Inter" pitchFamily="34" charset="-120"/>
-              </a:rPr>
-              <a:t>8</a:t>
-            </a:r>
-            <a:endParaRPr lang="en-US" sz="1400" dirty="0"/>
-          </a:p>
-        </p:txBody>
-      </p:sp>
-      <p:sp>
-        <p:nvSpPr>
-          <p:cNvPr id="15" name="Text 13"/>
-          <p:cNvSpPr txBox="1"/>
-          <p:nvPr/>
-        </p:nvSpPr>
-        <p:spPr>
-          <a:xfrm>
-            <a:off x="1115568" y="2075688"/>
-            <a:ext cx="1783080" cy="379476"/>
-          </a:xfrm>
-          <a:prstGeom prst="rect">
-            <a:avLst/>
-          </a:prstGeom>
-          <a:noFill/>
-          <a:ln/>
-        </p:spPr>
-        <p:txBody>
-          <a:bodyPr wrap="square" lIns="0" tIns="0" rIns="0" bIns="0" rtlCol="0" anchor="ctr"/>
-          <a:lstStyle/>
-          <a:p>
-            <a:pPr indent="0" marL="0">
-              <a:buNone/>
-            </a:pPr>
-            <a:r>
-              <a:rPr lang="en-US" sz="1200" b="1" dirty="0">
-                <a:solidFill>
-                  <a:srgbClr val="1A1A1A"/>
-                </a:solidFill>
-                <a:latin typeface="Inter" pitchFamily="34" charset="0"/>
-                <a:ea typeface="Inter" pitchFamily="34" charset="-122"/>
-                <a:cs typeface="Inter" pitchFamily="34" charset="-120"/>
-              </a:rPr>
-              <a:t>TOYOTA HENDERSON</a:t>
-            </a:r>
-            <a:endParaRPr lang="en-US" sz="1200" dirty="0"/>
-          </a:p>
-        </p:txBody>
-      </p:sp>
-      <p:sp>
-        <p:nvSpPr>
-          <p:cNvPr id="16" name="Text 14"/>
-          <p:cNvSpPr txBox="1"/>
-          <p:nvPr/>
-        </p:nvSpPr>
-        <p:spPr>
-          <a:xfrm>
-            <a:off x="2898648" y="2075688"/>
-            <a:ext cx="3108960" cy="379476"/>
-          </a:xfrm>
-          <a:prstGeom prst="rect">
-            <a:avLst/>
-          </a:prstGeom>
-          <a:noFill/>
-          <a:ln/>
-        </p:spPr>
-        <p:txBody>
-          <a:bodyPr wrap="square" lIns="0" tIns="0" rIns="0" bIns="0" rtlCol="0" anchor="ctr"/>
-          <a:lstStyle/>
-          <a:p>
-            <a:pPr indent="0" marL="0">
-              <a:buNone/>
-            </a:pPr>
-            <a:r>
-              <a:rPr lang="en-US" sz="1200" dirty="0">
-                <a:solidFill>
-                  <a:srgbClr val="595959"/>
-                </a:solidFill>
-                <a:latin typeface="Inter" pitchFamily="34" charset="0"/>
-                <a:ea typeface="Inter" pitchFamily="34" charset="-122"/>
-                <a:cs typeface="Inter" pitchFamily="34" charset="-120"/>
-              </a:rPr>
-              <a:t>Service: Apr, Jul  ·  Parts: Jun, Aug, Sep  ·  Combined: Apr, Jun, Jul</a:t>
-            </a:r>
-            <a:endParaRPr lang="en-US" sz="1200" dirty="0"/>
-          </a:p>
-        </p:txBody>
-      </p:sp>
-      <p:sp>
-        <p:nvSpPr>
-          <p:cNvPr id="17" name="Text 15"/>
-          <p:cNvSpPr txBox="1"/>
-          <p:nvPr/>
-        </p:nvSpPr>
-        <p:spPr>
-          <a:xfrm>
-            <a:off x="658368" y="2455164"/>
-            <a:ext cx="365760" cy="379476"/>
-          </a:xfrm>
-          <a:prstGeom prst="rect">
-            <a:avLst/>
-          </a:prstGeom>
-          <a:noFill/>
-          <a:ln/>
-        </p:spPr>
-        <p:txBody>
-          <a:bodyPr wrap="square" lIns="0" tIns="0" rIns="0" bIns="0" rtlCol="0" anchor="ctr"/>
-          <a:lstStyle/>
-          <a:p>
-            <a:pPr algn="r" indent="0" marL="0">
-              <a:buNone/>
-            </a:pPr>
-            <a:r>
-              <a:rPr lang="en-US" sz="1400" b="1" dirty="0">
-                <a:solidFill>
-                  <a:srgbClr val="0B7A4A"/>
-                </a:solidFill>
-                <a:latin typeface="Inter" pitchFamily="34" charset="0"/>
-                <a:ea typeface="Inter" pitchFamily="34" charset="-122"/>
-                <a:cs typeface="Inter" pitchFamily="34" charset="-120"/>
-              </a:rPr>
-              <a:t>7</a:t>
-            </a:r>
-            <a:endParaRPr lang="en-US" sz="1400" dirty="0"/>
-          </a:p>
-        </p:txBody>
-      </p:sp>
-      <p:sp>
-        <p:nvSpPr>
-          <p:cNvPr id="18" name="Text 16"/>
-          <p:cNvSpPr txBox="1"/>
-          <p:nvPr/>
-        </p:nvSpPr>
-        <p:spPr>
-          <a:xfrm>
-            <a:off x="1115568" y="2455164"/>
-            <a:ext cx="1783080" cy="379476"/>
-          </a:xfrm>
-          <a:prstGeom prst="rect">
-            <a:avLst/>
-          </a:prstGeom>
-          <a:noFill/>
-          <a:ln/>
-        </p:spPr>
-        <p:txBody>
-          <a:bodyPr wrap="square" lIns="0" tIns="0" rIns="0" bIns="0" rtlCol="0" anchor="ctr"/>
-          <a:lstStyle/>
-          <a:p>
-            <a:pPr indent="0" marL="0">
-              <a:buNone/>
-            </a:pPr>
-            <a:r>
-              <a:rPr lang="en-US" sz="1200" b="1" dirty="0">
-                <a:solidFill>
-                  <a:srgbClr val="1A1A1A"/>
-                </a:solidFill>
-                <a:latin typeface="Inter" pitchFamily="34" charset="0"/>
-                <a:ea typeface="Inter" pitchFamily="34" charset="-122"/>
-                <a:cs typeface="Inter" pitchFamily="34" charset="-120"/>
-              </a:rPr>
-              <a:t>HONDA HENDERSON</a:t>
-            </a:r>
-            <a:endParaRPr lang="en-US" sz="1200" dirty="0"/>
-          </a:p>
-        </p:txBody>
-      </p:sp>
-      <p:sp>
-        <p:nvSpPr>
-          <p:cNvPr id="19" name="Text 17"/>
-          <p:cNvSpPr txBox="1"/>
-          <p:nvPr/>
-        </p:nvSpPr>
-        <p:spPr>
-          <a:xfrm>
-            <a:off x="2898648" y="2455164"/>
-            <a:ext cx="3108960" cy="379476"/>
-          </a:xfrm>
-          <a:prstGeom prst="rect">
-            <a:avLst/>
-          </a:prstGeom>
-          <a:noFill/>
-          <a:ln/>
-        </p:spPr>
-        <p:txBody>
-          <a:bodyPr wrap="square" lIns="0" tIns="0" rIns="0" bIns="0" rtlCol="0" anchor="ctr"/>
-          <a:lstStyle/>
-          <a:p>
-            <a:pPr indent="0" marL="0">
-              <a:buNone/>
-            </a:pPr>
-            <a:r>
-              <a:rPr lang="en-US" sz="1200" dirty="0">
-                <a:solidFill>
-                  <a:srgbClr val="595959"/>
-                </a:solidFill>
-                <a:latin typeface="Inter" pitchFamily="34" charset="0"/>
-                <a:ea typeface="Inter" pitchFamily="34" charset="-122"/>
-                <a:cs typeface="Inter" pitchFamily="34" charset="-120"/>
-              </a:rPr>
-              <a:t>Service: Mar, Jun, Jul  ·  Parts: Jul  ·  Combined: Mar, Jun, Jul</a:t>
-            </a:r>
-            <a:endParaRPr lang="en-US" sz="1200" dirty="0"/>
-          </a:p>
-        </p:txBody>
-      </p:sp>
-      <p:sp>
-        <p:nvSpPr>
-          <p:cNvPr id="20" name="Shape 18"/>
-          <p:cNvSpPr/>
-          <p:nvPr/>
-        </p:nvSpPr>
-        <p:spPr>
-          <a:xfrm>
-            <a:off x="585216" y="2834640"/>
-            <a:ext cx="5440680" cy="379476"/>
-          </a:xfrm>
-          <a:prstGeom prst="rect">
-            <a:avLst/>
-          </a:prstGeom>
-          <a:solidFill>
-            <a:srgbClr val="F7F7F7"/>
-          </a:solidFill>
-          <a:ln/>
-        </p:spPr>
-      </p:sp>
-      <p:sp>
-        <p:nvSpPr>
-          <p:cNvPr id="21" name="Text 19"/>
-          <p:cNvSpPr txBox="1"/>
-          <p:nvPr/>
-        </p:nvSpPr>
-        <p:spPr>
-          <a:xfrm>
-            <a:off x="658368" y="2834640"/>
-            <a:ext cx="365760" cy="379476"/>
-          </a:xfrm>
-          <a:prstGeom prst="rect">
-            <a:avLst/>
-          </a:prstGeom>
-          <a:noFill/>
-          <a:ln/>
-        </p:spPr>
-        <p:txBody>
-          <a:bodyPr wrap="square" lIns="0" tIns="0" rIns="0" bIns="0" rtlCol="0" anchor="ctr"/>
-          <a:lstStyle/>
-          <a:p>
-            <a:pPr algn="r" indent="0" marL="0">
-              <a:buNone/>
-            </a:pPr>
-            <a:r>
-              <a:rPr lang="en-US" sz="1400" b="1" dirty="0">
-                <a:solidFill>
-                  <a:srgbClr val="0B7A4A"/>
-                </a:solidFill>
-                <a:latin typeface="Inter" pitchFamily="34" charset="0"/>
-                <a:ea typeface="Inter" pitchFamily="34" charset="-122"/>
-                <a:cs typeface="Inter" pitchFamily="34" charset="-120"/>
-              </a:rPr>
-              <a:t>7</a:t>
-            </a:r>
-            <a:endParaRPr lang="en-US" sz="1400" dirty="0"/>
-          </a:p>
-        </p:txBody>
-      </p:sp>
-      <p:sp>
-        <p:nvSpPr>
-          <p:cNvPr id="22" name="Text 20"/>
-          <p:cNvSpPr txBox="1"/>
-          <p:nvPr/>
-        </p:nvSpPr>
-        <p:spPr>
-          <a:xfrm>
-            <a:off x="1115568" y="2834640"/>
-            <a:ext cx="1783080" cy="379476"/>
-          </a:xfrm>
-          <a:prstGeom prst="rect">
-            <a:avLst/>
-          </a:prstGeom>
-          <a:noFill/>
-          <a:ln/>
-        </p:spPr>
-        <p:txBody>
-          <a:bodyPr wrap="square" lIns="0" tIns="0" rIns="0" bIns="0" rtlCol="0" anchor="ctr"/>
-          <a:lstStyle/>
-          <a:p>
-            <a:pPr indent="0" marL="0">
-              <a:buNone/>
-            </a:pPr>
-            <a:r>
-              <a:rPr lang="en-US" sz="1200" b="1" dirty="0">
-                <a:solidFill>
-                  <a:srgbClr val="1A1A1A"/>
-                </a:solidFill>
-                <a:latin typeface="Inter" pitchFamily="34" charset="0"/>
-                <a:ea typeface="Inter" pitchFamily="34" charset="-122"/>
-                <a:cs typeface="Inter" pitchFamily="34" charset="-120"/>
-              </a:rPr>
-              <a:t>SUBARU ST GEORGE</a:t>
-            </a:r>
-            <a:endParaRPr lang="en-US" sz="1200" dirty="0"/>
-          </a:p>
-        </p:txBody>
-      </p:sp>
-      <p:sp>
-        <p:nvSpPr>
-          <p:cNvPr id="23" name="Text 21"/>
-          <p:cNvSpPr txBox="1"/>
-          <p:nvPr/>
-        </p:nvSpPr>
-        <p:spPr>
-          <a:xfrm>
-            <a:off x="2898648" y="2834640"/>
-            <a:ext cx="3108960" cy="379476"/>
-          </a:xfrm>
-          <a:prstGeom prst="rect">
-            <a:avLst/>
-          </a:prstGeom>
-          <a:noFill/>
-          <a:ln/>
-        </p:spPr>
-        <p:txBody>
-          <a:bodyPr wrap="square" lIns="0" tIns="0" rIns="0" bIns="0" rtlCol="0" anchor="ctr"/>
-          <a:lstStyle/>
-          <a:p>
-            <a:pPr indent="0" marL="0">
-              <a:buNone/>
-            </a:pPr>
-            <a:r>
-              <a:rPr lang="en-US" sz="1200" dirty="0">
-                <a:solidFill>
-                  <a:srgbClr val="595959"/>
-                </a:solidFill>
-                <a:latin typeface="Inter" pitchFamily="34" charset="0"/>
-                <a:ea typeface="Inter" pitchFamily="34" charset="-122"/>
-                <a:cs typeface="Inter" pitchFamily="34" charset="-120"/>
-              </a:rPr>
-              <a:t>Service: Jan, Mar  ·  Parts: Mar, Apr, Jun  ·  Combined: Mar, Jun</a:t>
-            </a:r>
-            <a:endParaRPr lang="en-US" sz="1200" dirty="0"/>
-          </a:p>
-        </p:txBody>
-      </p:sp>
-      <p:sp>
-        <p:nvSpPr>
-          <p:cNvPr id="24" name="Text 22"/>
-          <p:cNvSpPr txBox="1"/>
-          <p:nvPr/>
-        </p:nvSpPr>
-        <p:spPr>
-          <a:xfrm>
-            <a:off x="658368" y="3214116"/>
-            <a:ext cx="365760" cy="379476"/>
-          </a:xfrm>
-          <a:prstGeom prst="rect">
-            <a:avLst/>
-          </a:prstGeom>
-          <a:noFill/>
-          <a:ln/>
-        </p:spPr>
-        <p:txBody>
-          <a:bodyPr wrap="square" lIns="0" tIns="0" rIns="0" bIns="0" rtlCol="0" anchor="ctr"/>
-          <a:lstStyle/>
-          <a:p>
-            <a:pPr algn="r" indent="0" marL="0">
-              <a:buNone/>
-            </a:pPr>
-            <a:r>
-              <a:rPr lang="en-US" sz="1400" b="1" dirty="0">
-                <a:solidFill>
-                  <a:srgbClr val="0B7A4A"/>
-                </a:solidFill>
-                <a:latin typeface="Inter" pitchFamily="34" charset="0"/>
-                <a:ea typeface="Inter" pitchFamily="34" charset="-122"/>
-                <a:cs typeface="Inter" pitchFamily="34" charset="-120"/>
-              </a:rPr>
-              <a:t>6</a:t>
-            </a:r>
-            <a:endParaRPr lang="en-US" sz="1400" dirty="0"/>
-          </a:p>
-        </p:txBody>
-      </p:sp>
-      <p:sp>
-        <p:nvSpPr>
-          <p:cNvPr id="25" name="Text 23"/>
-          <p:cNvSpPr txBox="1"/>
-          <p:nvPr/>
-        </p:nvSpPr>
-        <p:spPr>
-          <a:xfrm>
-            <a:off x="1115568" y="3214116"/>
-            <a:ext cx="1783080" cy="379476"/>
-          </a:xfrm>
-          <a:prstGeom prst="rect">
-            <a:avLst/>
-          </a:prstGeom>
-          <a:noFill/>
-          <a:ln/>
-        </p:spPr>
-        <p:txBody>
-          <a:bodyPr wrap="square" lIns="0" tIns="0" rIns="0" bIns="0" rtlCol="0" anchor="ctr"/>
-          <a:lstStyle/>
-          <a:p>
-            <a:pPr indent="0" marL="0">
-              <a:buNone/>
-            </a:pPr>
-            <a:r>
-              <a:rPr lang="en-US" sz="1200" b="1" dirty="0">
-                <a:solidFill>
-                  <a:srgbClr val="1A1A1A"/>
-                </a:solidFill>
-                <a:latin typeface="Inter" pitchFamily="34" charset="0"/>
-                <a:ea typeface="Inter" pitchFamily="34" charset="-122"/>
-                <a:cs typeface="Inter" pitchFamily="34" charset="-120"/>
-              </a:rPr>
-              <a:t>HYUNDAI PRESCOTT</a:t>
-            </a:r>
-            <a:endParaRPr lang="en-US" sz="1200" dirty="0"/>
-          </a:p>
-        </p:txBody>
-      </p:sp>
-      <p:sp>
-        <p:nvSpPr>
-          <p:cNvPr id="26" name="Text 24"/>
-          <p:cNvSpPr txBox="1"/>
-          <p:nvPr/>
-        </p:nvSpPr>
-        <p:spPr>
-          <a:xfrm>
-            <a:off x="2898648" y="3214116"/>
-            <a:ext cx="3108960" cy="379476"/>
-          </a:xfrm>
-          <a:prstGeom prst="rect">
-            <a:avLst/>
-          </a:prstGeom>
-          <a:noFill/>
-          <a:ln/>
-        </p:spPr>
-        <p:txBody>
-          <a:bodyPr wrap="square" lIns="0" tIns="0" rIns="0" bIns="0" rtlCol="0" anchor="ctr"/>
-          <a:lstStyle/>
-          <a:p>
-            <a:pPr indent="0" marL="0">
-              <a:buNone/>
-            </a:pPr>
-            <a:r>
-              <a:rPr lang="en-US" sz="1200" dirty="0">
-                <a:solidFill>
-                  <a:srgbClr val="595959"/>
-                </a:solidFill>
-                <a:latin typeface="Inter" pitchFamily="34" charset="0"/>
-                <a:ea typeface="Inter" pitchFamily="34" charset="-122"/>
-                <a:cs typeface="Inter" pitchFamily="34" charset="-120"/>
-              </a:rPr>
-              <a:t>Service: Mar, Jul  ·  Parts: Feb  ·  Combined: Feb, Mar, Jul</a:t>
-            </a:r>
-            <a:endParaRPr lang="en-US" sz="1200" dirty="0"/>
-          </a:p>
-        </p:txBody>
-      </p:sp>
-      <p:sp>
-        <p:nvSpPr>
-          <p:cNvPr id="27" name="Shape 25"/>
-          <p:cNvSpPr/>
-          <p:nvPr/>
-        </p:nvSpPr>
-        <p:spPr>
-          <a:xfrm>
-            <a:off x="585216" y="3593592"/>
-            <a:ext cx="5440680" cy="379476"/>
-          </a:xfrm>
-          <a:prstGeom prst="rect">
-            <a:avLst/>
-          </a:prstGeom>
-          <a:solidFill>
-            <a:srgbClr val="F7F7F7"/>
-          </a:solidFill>
-          <a:ln/>
-        </p:spPr>
-      </p:sp>
-      <p:sp>
-        <p:nvSpPr>
-          <p:cNvPr id="28" name="Text 26"/>
-          <p:cNvSpPr txBox="1"/>
-          <p:nvPr/>
-        </p:nvSpPr>
-        <p:spPr>
-          <a:xfrm>
-            <a:off x="658368" y="3593592"/>
-            <a:ext cx="365760" cy="379476"/>
-          </a:xfrm>
-          <a:prstGeom prst="rect">
-            <a:avLst/>
-          </a:prstGeom>
-          <a:noFill/>
-          <a:ln/>
-        </p:spPr>
-        <p:txBody>
-          <a:bodyPr wrap="square" lIns="0" tIns="0" rIns="0" bIns="0" rtlCol="0" anchor="ctr"/>
-          <a:lstStyle/>
-          <a:p>
-            <a:pPr algn="r" indent="0" marL="0">
-              <a:buNone/>
-            </a:pPr>
-            <a:r>
-              <a:rPr lang="en-US" sz="1400" b="1" dirty="0">
-                <a:solidFill>
-                  <a:srgbClr val="0B7A4A"/>
-                </a:solidFill>
-                <a:latin typeface="Inter" pitchFamily="34" charset="0"/>
-                <a:ea typeface="Inter" pitchFamily="34" charset="-122"/>
-                <a:cs typeface="Inter" pitchFamily="34" charset="-120"/>
-              </a:rPr>
-              <a:t>6</a:t>
-            </a:r>
-            <a:endParaRPr lang="en-US" sz="1400" dirty="0"/>
-          </a:p>
-        </p:txBody>
-      </p:sp>
-      <p:sp>
-        <p:nvSpPr>
-          <p:cNvPr id="29" name="Text 27"/>
-          <p:cNvSpPr txBox="1"/>
-          <p:nvPr/>
-        </p:nvSpPr>
-        <p:spPr>
-          <a:xfrm>
-            <a:off x="1115568" y="3593592"/>
-            <a:ext cx="1783080" cy="379476"/>
-          </a:xfrm>
-          <a:prstGeom prst="rect">
-            <a:avLst/>
-          </a:prstGeom>
-          <a:noFill/>
-          <a:ln/>
-        </p:spPr>
-        <p:txBody>
-          <a:bodyPr wrap="square" lIns="0" tIns="0" rIns="0" bIns="0" rtlCol="0" anchor="ctr"/>
-          <a:lstStyle/>
-          <a:p>
-            <a:pPr indent="0" marL="0">
-              <a:buNone/>
-            </a:pPr>
-            <a:r>
-              <a:rPr lang="en-US" sz="1200" b="1" dirty="0">
-                <a:solidFill>
-                  <a:srgbClr val="1A1A1A"/>
-                </a:solidFill>
-                <a:latin typeface="Inter" pitchFamily="34" charset="0"/>
-                <a:ea typeface="Inter" pitchFamily="34" charset="-122"/>
-                <a:cs typeface="Inter" pitchFamily="34" charset="-120"/>
-              </a:rPr>
-              <a:t>LINCOLN</a:t>
-            </a:r>
-            <a:endParaRPr lang="en-US" sz="1200" dirty="0"/>
-          </a:p>
-        </p:txBody>
-      </p:sp>
-      <p:sp>
-        <p:nvSpPr>
-          <p:cNvPr id="30" name="Text 28"/>
-          <p:cNvSpPr txBox="1"/>
-          <p:nvPr/>
-        </p:nvSpPr>
-        <p:spPr>
-          <a:xfrm>
-            <a:off x="2898648" y="3593592"/>
-            <a:ext cx="3108960" cy="379476"/>
-          </a:xfrm>
-          <a:prstGeom prst="rect">
-            <a:avLst/>
-          </a:prstGeom>
-          <a:noFill/>
-          <a:ln/>
-        </p:spPr>
-        <p:txBody>
-          <a:bodyPr wrap="square" lIns="0" tIns="0" rIns="0" bIns="0" rtlCol="0" anchor="ctr"/>
-          <a:lstStyle/>
-          <a:p>
-            <a:pPr indent="0" marL="0">
-              <a:buNone/>
-            </a:pPr>
-            <a:r>
-              <a:rPr lang="en-US" sz="1200" dirty="0">
-                <a:solidFill>
-                  <a:srgbClr val="595959"/>
-                </a:solidFill>
-                <a:latin typeface="Inter" pitchFamily="34" charset="0"/>
-                <a:ea typeface="Inter" pitchFamily="34" charset="-122"/>
-                <a:cs typeface="Inter" pitchFamily="34" charset="-120"/>
-              </a:rPr>
-              <a:t>Service: Aug, Sep  ·  Parts: Mar  ·  Combined: Mar, Aug, Sep</a:t>
-            </a:r>
-            <a:endParaRPr lang="en-US" sz="1200" dirty="0"/>
-          </a:p>
-        </p:txBody>
-      </p:sp>
-      <p:sp>
-        <p:nvSpPr>
-          <p:cNvPr id="31" name="Text 29"/>
-          <p:cNvSpPr txBox="1"/>
-          <p:nvPr/>
-        </p:nvSpPr>
-        <p:spPr>
-          <a:xfrm>
-            <a:off x="658368" y="3973068"/>
-            <a:ext cx="365760" cy="379476"/>
-          </a:xfrm>
-          <a:prstGeom prst="rect">
-            <a:avLst/>
-          </a:prstGeom>
-          <a:noFill/>
-          <a:ln/>
-        </p:spPr>
-        <p:txBody>
-          <a:bodyPr wrap="square" lIns="0" tIns="0" rIns="0" bIns="0" rtlCol="0" anchor="ctr"/>
-          <a:lstStyle/>
-          <a:p>
-            <a:pPr algn="r" indent="0" marL="0">
-              <a:buNone/>
-            </a:pPr>
-            <a:r>
-              <a:rPr lang="en-US" sz="1400" b="1" dirty="0">
-                <a:solidFill>
-                  <a:srgbClr val="0B7A4A"/>
-                </a:solidFill>
-                <a:latin typeface="Inter" pitchFamily="34" charset="0"/>
-                <a:ea typeface="Inter" pitchFamily="34" charset="-122"/>
-                <a:cs typeface="Inter" pitchFamily="34" charset="-120"/>
-              </a:rPr>
-              <a:t>5</a:t>
-            </a:r>
-            <a:endParaRPr lang="en-US" sz="1400" dirty="0"/>
-          </a:p>
-        </p:txBody>
-      </p:sp>
-      <p:sp>
-        <p:nvSpPr>
-          <p:cNvPr id="32" name="Text 30"/>
-          <p:cNvSpPr txBox="1"/>
-          <p:nvPr/>
-        </p:nvSpPr>
-        <p:spPr>
-          <a:xfrm>
-            <a:off x="1115568" y="3973068"/>
-            <a:ext cx="1783080" cy="379476"/>
-          </a:xfrm>
-          <a:prstGeom prst="rect">
-            <a:avLst/>
-          </a:prstGeom>
-          <a:noFill/>
-          <a:ln/>
-        </p:spPr>
-        <p:txBody>
-          <a:bodyPr wrap="square" lIns="0" tIns="0" rIns="0" bIns="0" rtlCol="0" anchor="ctr"/>
-          <a:lstStyle/>
-          <a:p>
-            <a:pPr indent="0" marL="0">
-              <a:buNone/>
-            </a:pPr>
-            <a:r>
-              <a:rPr lang="en-US" sz="1200" b="1" dirty="0">
-                <a:solidFill>
-                  <a:srgbClr val="1A1A1A"/>
-                </a:solidFill>
-                <a:latin typeface="Inter" pitchFamily="34" charset="0"/>
-                <a:ea typeface="Inter" pitchFamily="34" charset="-122"/>
-                <a:cs typeface="Inter" pitchFamily="34" charset="-120"/>
-              </a:rPr>
-              <a:t>MAZDA</a:t>
-            </a:r>
-            <a:endParaRPr lang="en-US" sz="1200" dirty="0"/>
-          </a:p>
-        </p:txBody>
-      </p:sp>
-      <p:sp>
-        <p:nvSpPr>
-          <p:cNvPr id="33" name="Text 31"/>
-          <p:cNvSpPr txBox="1"/>
-          <p:nvPr/>
-        </p:nvSpPr>
-        <p:spPr>
-          <a:xfrm>
-            <a:off x="2898648" y="3973068"/>
-            <a:ext cx="3108960" cy="379476"/>
-          </a:xfrm>
-          <a:prstGeom prst="rect">
-            <a:avLst/>
-          </a:prstGeom>
-          <a:noFill/>
-          <a:ln/>
-        </p:spPr>
-        <p:txBody>
-          <a:bodyPr wrap="square" lIns="0" tIns="0" rIns="0" bIns="0" rtlCol="0" anchor="ctr"/>
-          <a:lstStyle/>
-          <a:p>
-            <a:pPr indent="0" marL="0">
-              <a:buNone/>
-            </a:pPr>
-            <a:r>
-              <a:rPr lang="en-US" sz="1200" dirty="0">
-                <a:solidFill>
-                  <a:srgbClr val="595959"/>
-                </a:solidFill>
-                <a:latin typeface="Inter" pitchFamily="34" charset="0"/>
-                <a:ea typeface="Inter" pitchFamily="34" charset="-122"/>
-                <a:cs typeface="Inter" pitchFamily="34" charset="-120"/>
-              </a:rPr>
-              <a:t>Service: Aug, Sep  ·  Parts: Sep  ·  Combined: Aug, Sep</a:t>
-            </a:r>
-            <a:endParaRPr lang="en-US" sz="1200" dirty="0"/>
-          </a:p>
-        </p:txBody>
-      </p:sp>
-      <p:sp>
-        <p:nvSpPr>
-          <p:cNvPr id="34" name="Shape 32"/>
-          <p:cNvSpPr/>
-          <p:nvPr/>
-        </p:nvSpPr>
-        <p:spPr>
-          <a:xfrm>
-            <a:off x="585216" y="4352544"/>
-            <a:ext cx="5440680" cy="379476"/>
-          </a:xfrm>
-          <a:prstGeom prst="rect">
-            <a:avLst/>
-          </a:prstGeom>
-          <a:solidFill>
-            <a:srgbClr val="F7F7F7"/>
-          </a:solidFill>
-          <a:ln/>
-        </p:spPr>
-      </p:sp>
-      <p:sp>
-        <p:nvSpPr>
-          <p:cNvPr id="35" name="Text 33"/>
-          <p:cNvSpPr txBox="1"/>
-          <p:nvPr/>
-        </p:nvSpPr>
-        <p:spPr>
-          <a:xfrm>
-            <a:off x="658368" y="4352544"/>
-            <a:ext cx="365760" cy="379476"/>
-          </a:xfrm>
-          <a:prstGeom prst="rect">
-            <a:avLst/>
-          </a:prstGeom>
-          <a:noFill/>
-          <a:ln/>
-        </p:spPr>
-        <p:txBody>
-          <a:bodyPr wrap="square" lIns="0" tIns="0" rIns="0" bIns="0" rtlCol="0" anchor="ctr"/>
-          <a:lstStyle/>
-          <a:p>
-            <a:pPr algn="r" indent="0" marL="0">
-              <a:buNone/>
-            </a:pPr>
-            <a:r>
-              <a:rPr lang="en-US" sz="1400" b="1" dirty="0">
-                <a:solidFill>
-                  <a:srgbClr val="0B7A4A"/>
-                </a:solidFill>
-                <a:latin typeface="Inter" pitchFamily="34" charset="0"/>
-                <a:ea typeface="Inter" pitchFamily="34" charset="-122"/>
-                <a:cs typeface="Inter" pitchFamily="34" charset="-120"/>
-              </a:rPr>
-              <a:t>4</a:t>
-            </a:r>
-            <a:endParaRPr lang="en-US" sz="1400" dirty="0"/>
-          </a:p>
-        </p:txBody>
-      </p:sp>
-      <p:sp>
-        <p:nvSpPr>
-          <p:cNvPr id="36" name="Text 34"/>
-          <p:cNvSpPr txBox="1"/>
-          <p:nvPr/>
-        </p:nvSpPr>
-        <p:spPr>
-          <a:xfrm>
-            <a:off x="1115568" y="4352544"/>
-            <a:ext cx="1783080" cy="379476"/>
-          </a:xfrm>
-          <a:prstGeom prst="rect">
-            <a:avLst/>
-          </a:prstGeom>
-          <a:noFill/>
-          <a:ln/>
-        </p:spPr>
-        <p:txBody>
-          <a:bodyPr wrap="square" lIns="0" tIns="0" rIns="0" bIns="0" rtlCol="0" anchor="ctr"/>
-          <a:lstStyle/>
-          <a:p>
-            <a:pPr indent="0" marL="0">
-              <a:buNone/>
-            </a:pPr>
-            <a:r>
-              <a:rPr lang="en-US" sz="1200" b="1" dirty="0">
-                <a:solidFill>
-                  <a:srgbClr val="1A1A1A"/>
-                </a:solidFill>
-                <a:latin typeface="Inter" pitchFamily="34" charset="0"/>
-                <a:ea typeface="Inter" pitchFamily="34" charset="-122"/>
-                <a:cs typeface="Inter" pitchFamily="34" charset="-120"/>
-              </a:rPr>
-              <a:t>KIA ST GEORGE</a:t>
-            </a:r>
-            <a:endParaRPr lang="en-US" sz="1200" dirty="0"/>
-          </a:p>
-        </p:txBody>
-      </p:sp>
-      <p:sp>
-        <p:nvSpPr>
-          <p:cNvPr id="37" name="Text 35"/>
-          <p:cNvSpPr txBox="1"/>
-          <p:nvPr/>
-        </p:nvSpPr>
-        <p:spPr>
-          <a:xfrm>
-            <a:off x="2898648" y="4352544"/>
-            <a:ext cx="3108960" cy="379476"/>
-          </a:xfrm>
-          <a:prstGeom prst="rect">
-            <a:avLst/>
-          </a:prstGeom>
-          <a:noFill/>
-          <a:ln/>
-        </p:spPr>
-        <p:txBody>
-          <a:bodyPr wrap="square" lIns="0" tIns="0" rIns="0" bIns="0" rtlCol="0" anchor="ctr"/>
-          <a:lstStyle/>
-          <a:p>
-            <a:pPr indent="0" marL="0">
-              <a:buNone/>
-            </a:pPr>
-            <a:r>
-              <a:rPr lang="en-US" sz="1200" dirty="0">
-                <a:solidFill>
-                  <a:srgbClr val="595959"/>
-                </a:solidFill>
-                <a:latin typeface="Inter" pitchFamily="34" charset="0"/>
-                <a:ea typeface="Inter" pitchFamily="34" charset="-122"/>
-                <a:cs typeface="Inter" pitchFamily="34" charset="-120"/>
-              </a:rPr>
-              <a:t>Service: Apr, Jul  ·  Parts: Jul  ·  Combined: Jul</a:t>
-            </a:r>
-            <a:endParaRPr lang="en-US" sz="1200" dirty="0"/>
-          </a:p>
-        </p:txBody>
-      </p:sp>
-      <p:sp>
-        <p:nvSpPr>
-          <p:cNvPr id="38" name="Text 36"/>
-          <p:cNvSpPr txBox="1"/>
-          <p:nvPr/>
-        </p:nvSpPr>
-        <p:spPr>
-          <a:xfrm>
-            <a:off x="658368" y="4732020"/>
-            <a:ext cx="365760" cy="379476"/>
-          </a:xfrm>
-          <a:prstGeom prst="rect">
-            <a:avLst/>
-          </a:prstGeom>
-          <a:noFill/>
-          <a:ln/>
-        </p:spPr>
-        <p:txBody>
-          <a:bodyPr wrap="square" lIns="0" tIns="0" rIns="0" bIns="0" rtlCol="0" anchor="ctr"/>
-          <a:lstStyle/>
-          <a:p>
-            <a:pPr algn="r" indent="0" marL="0">
-              <a:buNone/>
-            </a:pPr>
-            <a:r>
-              <a:rPr lang="en-US" sz="1400" b="1" dirty="0">
-                <a:solidFill>
-                  <a:srgbClr val="0B7A4A"/>
-                </a:solidFill>
-                <a:latin typeface="Inter" pitchFamily="34" charset="0"/>
-                <a:ea typeface="Inter" pitchFamily="34" charset="-122"/>
-                <a:cs typeface="Inter" pitchFamily="34" charset="-120"/>
-              </a:rPr>
-              <a:t>4</a:t>
-            </a:r>
-            <a:endParaRPr lang="en-US" sz="1400" dirty="0"/>
-          </a:p>
-        </p:txBody>
-      </p:sp>
-      <p:sp>
-        <p:nvSpPr>
-          <p:cNvPr id="39" name="Text 37"/>
-          <p:cNvSpPr txBox="1"/>
-          <p:nvPr/>
-        </p:nvSpPr>
-        <p:spPr>
-          <a:xfrm>
-            <a:off x="1115568" y="4732020"/>
-            <a:ext cx="1783080" cy="379476"/>
-          </a:xfrm>
-          <a:prstGeom prst="rect">
-            <a:avLst/>
-          </a:prstGeom>
-          <a:noFill/>
-          <a:ln/>
-        </p:spPr>
-        <p:txBody>
-          <a:bodyPr wrap="square" lIns="0" tIns="0" rIns="0" bIns="0" rtlCol="0" anchor="ctr"/>
-          <a:lstStyle/>
-          <a:p>
-            <a:pPr indent="0" marL="0">
-              <a:buNone/>
-            </a:pPr>
-            <a:r>
-              <a:rPr lang="en-US" sz="1200" b="1" dirty="0">
-                <a:solidFill>
-                  <a:srgbClr val="1A1A1A"/>
-                </a:solidFill>
-                <a:latin typeface="Inter" pitchFamily="34" charset="0"/>
-                <a:ea typeface="Inter" pitchFamily="34" charset="-122"/>
-                <a:cs typeface="Inter" pitchFamily="34" charset="-120"/>
-              </a:rPr>
-              <a:t>LEXUS</a:t>
-            </a:r>
-            <a:endParaRPr lang="en-US" sz="1200" dirty="0"/>
-          </a:p>
-        </p:txBody>
-      </p:sp>
-      <p:sp>
-        <p:nvSpPr>
-          <p:cNvPr id="40" name="Text 38"/>
-          <p:cNvSpPr txBox="1"/>
-          <p:nvPr/>
-        </p:nvSpPr>
-        <p:spPr>
-          <a:xfrm>
-            <a:off x="2898648" y="4732020"/>
-            <a:ext cx="3108960" cy="379476"/>
-          </a:xfrm>
-          <a:prstGeom prst="rect">
-            <a:avLst/>
-          </a:prstGeom>
-          <a:noFill/>
-          <a:ln/>
-        </p:spPr>
-        <p:txBody>
-          <a:bodyPr wrap="square" lIns="0" tIns="0" rIns="0" bIns="0" rtlCol="0" anchor="ctr"/>
-          <a:lstStyle/>
-          <a:p>
-            <a:pPr indent="0" marL="0">
-              <a:buNone/>
-            </a:pPr>
-            <a:r>
-              <a:rPr lang="en-US" sz="1200" dirty="0">
-                <a:solidFill>
-                  <a:srgbClr val="595959"/>
-                </a:solidFill>
-                <a:latin typeface="Inter" pitchFamily="34" charset="0"/>
-                <a:ea typeface="Inter" pitchFamily="34" charset="-122"/>
-                <a:cs typeface="Inter" pitchFamily="34" charset="-120"/>
-              </a:rPr>
-              <a:t>Service: Mar, May  ·  Parts: May  ·  Combined: May</a:t>
-            </a:r>
-            <a:endParaRPr lang="en-US" sz="1200" dirty="0"/>
-          </a:p>
-        </p:txBody>
-      </p:sp>
-      <p:sp>
-        <p:nvSpPr>
-          <p:cNvPr id="41" name="Shape 39"/>
-          <p:cNvSpPr/>
-          <p:nvPr/>
-        </p:nvSpPr>
-        <p:spPr>
-          <a:xfrm>
-            <a:off x="585216" y="5111496"/>
-            <a:ext cx="5440680" cy="379476"/>
-          </a:xfrm>
-          <a:prstGeom prst="rect">
-            <a:avLst/>
-          </a:prstGeom>
-          <a:solidFill>
-            <a:srgbClr val="F7F7F7"/>
-          </a:solidFill>
-          <a:ln/>
-        </p:spPr>
-      </p:sp>
-      <p:sp>
-        <p:nvSpPr>
-          <p:cNvPr id="42" name="Text 40"/>
-          <p:cNvSpPr txBox="1"/>
-          <p:nvPr/>
-        </p:nvSpPr>
-        <p:spPr>
-          <a:xfrm>
-            <a:off x="658368" y="5111496"/>
-            <a:ext cx="365760" cy="379476"/>
-          </a:xfrm>
-          <a:prstGeom prst="rect">
-            <a:avLst/>
-          </a:prstGeom>
-          <a:noFill/>
-          <a:ln/>
-        </p:spPr>
-        <p:txBody>
-          <a:bodyPr wrap="square" lIns="0" tIns="0" rIns="0" bIns="0" rtlCol="0" anchor="ctr"/>
-          <a:lstStyle/>
-          <a:p>
-            <a:pPr algn="r" indent="0" marL="0">
-              <a:buNone/>
-            </a:pPr>
-            <a:r>
-              <a:rPr lang="en-US" sz="1400" b="1" dirty="0">
-                <a:solidFill>
-                  <a:srgbClr val="0B7A4A"/>
-                </a:solidFill>
-                <a:latin typeface="Inter" pitchFamily="34" charset="0"/>
-                <a:ea typeface="Inter" pitchFamily="34" charset="-122"/>
-                <a:cs typeface="Inter" pitchFamily="34" charset="-120"/>
-              </a:rPr>
-              <a:t>4</a:t>
-            </a:r>
-            <a:endParaRPr lang="en-US" sz="1400" dirty="0"/>
-          </a:p>
-        </p:txBody>
-      </p:sp>
-      <p:sp>
-        <p:nvSpPr>
-          <p:cNvPr id="43" name="Text 41"/>
-          <p:cNvSpPr txBox="1"/>
-          <p:nvPr/>
-        </p:nvSpPr>
-        <p:spPr>
-          <a:xfrm>
-            <a:off x="1115568" y="5111496"/>
-            <a:ext cx="1783080" cy="379476"/>
-          </a:xfrm>
-          <a:prstGeom prst="rect">
-            <a:avLst/>
-          </a:prstGeom>
-          <a:noFill/>
-          <a:ln/>
-        </p:spPr>
-        <p:txBody>
-          <a:bodyPr wrap="square" lIns="0" tIns="0" rIns="0" bIns="0" rtlCol="0" anchor="ctr"/>
-          <a:lstStyle/>
-          <a:p>
-            <a:pPr indent="0" marL="0">
-              <a:buNone/>
-            </a:pPr>
-            <a:r>
-              <a:rPr lang="en-US" sz="1200" b="1" dirty="0">
-                <a:solidFill>
-                  <a:srgbClr val="1A1A1A"/>
-                </a:solidFill>
-                <a:latin typeface="Inter" pitchFamily="34" charset="0"/>
-                <a:ea typeface="Inter" pitchFamily="34" charset="-122"/>
-                <a:cs typeface="Inter" pitchFamily="34" charset="-120"/>
-              </a:rPr>
-              <a:t>LR HENDERSON</a:t>
-            </a:r>
-            <a:endParaRPr lang="en-US" sz="1200" dirty="0"/>
-          </a:p>
-        </p:txBody>
-      </p:sp>
-      <p:sp>
-        <p:nvSpPr>
-          <p:cNvPr id="44" name="Text 42"/>
-          <p:cNvSpPr txBox="1"/>
-          <p:nvPr/>
-        </p:nvSpPr>
-        <p:spPr>
-          <a:xfrm>
-            <a:off x="2898648" y="5111496"/>
-            <a:ext cx="3108960" cy="379476"/>
-          </a:xfrm>
-          <a:prstGeom prst="rect">
-            <a:avLst/>
-          </a:prstGeom>
-          <a:noFill/>
-          <a:ln/>
-        </p:spPr>
-        <p:txBody>
-          <a:bodyPr wrap="square" lIns="0" tIns="0" rIns="0" bIns="0" rtlCol="0" anchor="ctr"/>
-          <a:lstStyle/>
-          <a:p>
-            <a:pPr indent="0" marL="0">
-              <a:buNone/>
-            </a:pPr>
-            <a:r>
-              <a:rPr lang="en-US" sz="1200" dirty="0">
-                <a:solidFill>
-                  <a:srgbClr val="595959"/>
-                </a:solidFill>
-                <a:latin typeface="Inter" pitchFamily="34" charset="0"/>
-                <a:ea typeface="Inter" pitchFamily="34" charset="-122"/>
-                <a:cs typeface="Inter" pitchFamily="34" charset="-120"/>
-              </a:rPr>
-              <a:t>Service: Aug, Sep  ·  Parts: Jul  ·  Combined: Jul</a:t>
-            </a:r>
-            <a:endParaRPr lang="en-US" sz="1200" dirty="0"/>
-          </a:p>
-        </p:txBody>
-      </p:sp>
-      <p:sp>
-        <p:nvSpPr>
-          <p:cNvPr id="45" name="Text 43"/>
-          <p:cNvSpPr txBox="1"/>
-          <p:nvPr/>
-        </p:nvSpPr>
-        <p:spPr>
-          <a:xfrm>
-            <a:off x="658368" y="5490972"/>
-            <a:ext cx="365760" cy="379476"/>
-          </a:xfrm>
-          <a:prstGeom prst="rect">
-            <a:avLst/>
-          </a:prstGeom>
-          <a:noFill/>
-          <a:ln/>
-        </p:spPr>
-        <p:txBody>
-          <a:bodyPr wrap="square" lIns="0" tIns="0" rIns="0" bIns="0" rtlCol="0" anchor="ctr"/>
-          <a:lstStyle/>
-          <a:p>
-            <a:pPr algn="r" indent="0" marL="0">
-              <a:buNone/>
-            </a:pPr>
-            <a:r>
-              <a:rPr lang="en-US" sz="1400" b="1" dirty="0">
-                <a:solidFill>
-                  <a:srgbClr val="0B7A4A"/>
-                </a:solidFill>
-                <a:latin typeface="Inter" pitchFamily="34" charset="0"/>
-                <a:ea typeface="Inter" pitchFamily="34" charset="-122"/>
-                <a:cs typeface="Inter" pitchFamily="34" charset="-120"/>
-              </a:rPr>
-              <a:t>4</a:t>
-            </a:r>
-            <a:endParaRPr lang="en-US" sz="1400" dirty="0"/>
-          </a:p>
-        </p:txBody>
-      </p:sp>
-      <p:sp>
-        <p:nvSpPr>
-          <p:cNvPr id="46" name="Text 44"/>
-          <p:cNvSpPr txBox="1"/>
-          <p:nvPr/>
-        </p:nvSpPr>
-        <p:spPr>
-          <a:xfrm>
-            <a:off x="1115568" y="5490972"/>
-            <a:ext cx="1783080" cy="379476"/>
-          </a:xfrm>
-          <a:prstGeom prst="rect">
-            <a:avLst/>
-          </a:prstGeom>
-          <a:noFill/>
-          <a:ln/>
-        </p:spPr>
-        <p:txBody>
-          <a:bodyPr wrap="square" lIns="0" tIns="0" rIns="0" bIns="0" rtlCol="0" anchor="ctr"/>
-          <a:lstStyle/>
-          <a:p>
-            <a:pPr indent="0" marL="0">
-              <a:buNone/>
-            </a:pPr>
-            <a:r>
-              <a:rPr lang="en-US" sz="1200" b="1" dirty="0">
-                <a:solidFill>
-                  <a:srgbClr val="1A1A1A"/>
-                </a:solidFill>
-                <a:latin typeface="Inter" pitchFamily="34" charset="0"/>
-                <a:ea typeface="Inter" pitchFamily="34" charset="-122"/>
-                <a:cs typeface="Inter" pitchFamily="34" charset="-120"/>
-              </a:rPr>
-              <a:t>TOYOTA FLAGSTAFF</a:t>
-            </a:r>
-            <a:endParaRPr lang="en-US" sz="1200" dirty="0"/>
-          </a:p>
-        </p:txBody>
-      </p:sp>
-      <p:sp>
-        <p:nvSpPr>
-          <p:cNvPr id="47" name="Text 45"/>
-          <p:cNvSpPr txBox="1"/>
-          <p:nvPr/>
-        </p:nvSpPr>
-        <p:spPr>
-          <a:xfrm>
-            <a:off x="2898648" y="5490972"/>
-            <a:ext cx="3108960" cy="379476"/>
-          </a:xfrm>
-          <a:prstGeom prst="rect">
-            <a:avLst/>
-          </a:prstGeom>
-          <a:noFill/>
-          <a:ln/>
-        </p:spPr>
-        <p:txBody>
-          <a:bodyPr wrap="square" lIns="0" tIns="0" rIns="0" bIns="0" rtlCol="0" anchor="ctr"/>
-          <a:lstStyle/>
-          <a:p>
-            <a:pPr indent="0" marL="0">
-              <a:buNone/>
-            </a:pPr>
-            <a:r>
-              <a:rPr lang="en-US" sz="1200" dirty="0">
-                <a:solidFill>
-                  <a:srgbClr val="595959"/>
-                </a:solidFill>
-                <a:latin typeface="Inter" pitchFamily="34" charset="0"/>
-                <a:ea typeface="Inter" pitchFamily="34" charset="-122"/>
-                <a:cs typeface="Inter" pitchFamily="34" charset="-120"/>
-              </a:rPr>
-              <a:t>Service: Mar, Apr, May  ·  Combined: Mar</a:t>
-            </a:r>
-            <a:endParaRPr lang="en-US" sz="1200" dirty="0"/>
-          </a:p>
-        </p:txBody>
-      </p:sp>
-      <p:sp>
-        <p:nvSpPr>
-          <p:cNvPr id="48" name="Shape 46"/>
-          <p:cNvSpPr/>
-          <p:nvPr/>
-        </p:nvSpPr>
-        <p:spPr>
-          <a:xfrm>
-            <a:off x="6163056" y="1316736"/>
-            <a:ext cx="5440680" cy="379476"/>
-          </a:xfrm>
-          <a:prstGeom prst="rect">
-            <a:avLst/>
-          </a:prstGeom>
-          <a:solidFill>
-            <a:srgbClr val="F7F7F7"/>
-          </a:solidFill>
-          <a:ln/>
-        </p:spPr>
-      </p:sp>
-      <p:sp>
-        <p:nvSpPr>
-          <p:cNvPr id="49" name="Text 47"/>
-          <p:cNvSpPr txBox="1"/>
-          <p:nvPr/>
-        </p:nvSpPr>
-        <p:spPr>
-          <a:xfrm>
-            <a:off x="6236208" y="1316736"/>
-            <a:ext cx="365760" cy="379476"/>
-          </a:xfrm>
-          <a:prstGeom prst="rect">
-            <a:avLst/>
-          </a:prstGeom>
-          <a:noFill/>
-          <a:ln/>
-        </p:spPr>
-        <p:txBody>
-          <a:bodyPr wrap="square" lIns="0" tIns="0" rIns="0" bIns="0" rtlCol="0" anchor="ctr"/>
-          <a:lstStyle/>
-          <a:p>
-            <a:pPr algn="r" indent="0" marL="0">
-              <a:buNone/>
-            </a:pPr>
-            <a:r>
-              <a:rPr lang="en-US" sz="1400" b="1" dirty="0">
-                <a:solidFill>
-                  <a:srgbClr val="0B7A4A"/>
-                </a:solidFill>
-                <a:latin typeface="Inter" pitchFamily="34" charset="0"/>
-                <a:ea typeface="Inter" pitchFamily="34" charset="-122"/>
-                <a:cs typeface="Inter" pitchFamily="34" charset="-120"/>
-              </a:rPr>
-              <a:t>4</a:t>
-            </a:r>
-            <a:endParaRPr lang="en-US" sz="1400" dirty="0"/>
-          </a:p>
-        </p:txBody>
-      </p:sp>
-      <p:sp>
-        <p:nvSpPr>
-          <p:cNvPr id="50" name="Text 48"/>
-          <p:cNvSpPr txBox="1"/>
-          <p:nvPr/>
-        </p:nvSpPr>
-        <p:spPr>
-          <a:xfrm>
-            <a:off x="6693408" y="1316736"/>
-            <a:ext cx="1783080" cy="379476"/>
-          </a:xfrm>
-          <a:prstGeom prst="rect">
-            <a:avLst/>
-          </a:prstGeom>
-          <a:noFill/>
-          <a:ln/>
-        </p:spPr>
-        <p:txBody>
-          <a:bodyPr wrap="square" lIns="0" tIns="0" rIns="0" bIns="0" rtlCol="0" anchor="ctr"/>
-          <a:lstStyle/>
-          <a:p>
-            <a:pPr indent="0" marL="0">
-              <a:buNone/>
-            </a:pPr>
-            <a:r>
-              <a:rPr lang="en-US" sz="1200" b="1" dirty="0">
-                <a:solidFill>
-                  <a:srgbClr val="1A1A1A"/>
-                </a:solidFill>
-                <a:latin typeface="Inter" pitchFamily="34" charset="0"/>
-                <a:ea typeface="Inter" pitchFamily="34" charset="-122"/>
-                <a:cs typeface="Inter" pitchFamily="34" charset="-120"/>
-              </a:rPr>
-              <a:t>TOYOTA PRESCOTT</a:t>
-            </a:r>
-            <a:endParaRPr lang="en-US" sz="1200" dirty="0"/>
-          </a:p>
-        </p:txBody>
-      </p:sp>
-      <p:sp>
-        <p:nvSpPr>
-          <p:cNvPr id="51" name="Text 49"/>
-          <p:cNvSpPr txBox="1"/>
-          <p:nvPr/>
-        </p:nvSpPr>
-        <p:spPr>
-          <a:xfrm>
-            <a:off x="8476488" y="1316736"/>
-            <a:ext cx="3108960" cy="379476"/>
-          </a:xfrm>
-          <a:prstGeom prst="rect">
-            <a:avLst/>
-          </a:prstGeom>
-          <a:noFill/>
-          <a:ln/>
-        </p:spPr>
-        <p:txBody>
-          <a:bodyPr wrap="square" lIns="0" tIns="0" rIns="0" bIns="0" rtlCol="0" anchor="ctr"/>
-          <a:lstStyle/>
-          <a:p>
-            <a:pPr indent="0" marL="0">
-              <a:buNone/>
-            </a:pPr>
-            <a:r>
-              <a:rPr lang="en-US" sz="1200" dirty="0">
-                <a:solidFill>
-                  <a:srgbClr val="595959"/>
-                </a:solidFill>
-                <a:latin typeface="Inter" pitchFamily="34" charset="0"/>
-                <a:ea typeface="Inter" pitchFamily="34" charset="-122"/>
-                <a:cs typeface="Inter" pitchFamily="34" charset="-120"/>
-              </a:rPr>
-              <a:t>Service: Mar, Apr  ·  Parts: Apr  ·  Combined: Apr</a:t>
-            </a:r>
-            <a:endParaRPr lang="en-US" sz="1200" dirty="0"/>
-          </a:p>
-        </p:txBody>
-      </p:sp>
-      <p:sp>
-        <p:nvSpPr>
-          <p:cNvPr id="52" name="Text 50"/>
-          <p:cNvSpPr txBox="1"/>
-          <p:nvPr/>
-        </p:nvSpPr>
-        <p:spPr>
-          <a:xfrm>
-            <a:off x="6236208" y="1696212"/>
-            <a:ext cx="365760" cy="379476"/>
-          </a:xfrm>
-          <a:prstGeom prst="rect">
-            <a:avLst/>
-          </a:prstGeom>
-          <a:noFill/>
-          <a:ln/>
-        </p:spPr>
-        <p:txBody>
-          <a:bodyPr wrap="square" lIns="0" tIns="0" rIns="0" bIns="0" rtlCol="0" anchor="ctr"/>
-          <a:lstStyle/>
-          <a:p>
-            <a:pPr algn="r" indent="0" marL="0">
-              <a:buNone/>
-            </a:pPr>
-            <a:r>
-              <a:rPr lang="en-US" sz="1400" b="1" dirty="0">
-                <a:solidFill>
-                  <a:srgbClr val="0B7A4A"/>
-                </a:solidFill>
-                <a:latin typeface="Inter" pitchFamily="34" charset="0"/>
-                <a:ea typeface="Inter" pitchFamily="34" charset="-122"/>
-                <a:cs typeface="Inter" pitchFamily="34" charset="-120"/>
-              </a:rPr>
-              <a:t>4</a:t>
-            </a:r>
-            <a:endParaRPr lang="en-US" sz="1400" dirty="0"/>
-          </a:p>
-        </p:txBody>
-      </p:sp>
-      <p:sp>
-        <p:nvSpPr>
-          <p:cNvPr id="53" name="Text 51"/>
-          <p:cNvSpPr txBox="1"/>
-          <p:nvPr/>
-        </p:nvSpPr>
-        <p:spPr>
-          <a:xfrm>
-            <a:off x="6693408" y="1696212"/>
-            <a:ext cx="1783080" cy="379476"/>
-          </a:xfrm>
-          <a:prstGeom prst="rect">
-            <a:avLst/>
-          </a:prstGeom>
-          <a:noFill/>
-          <a:ln/>
-        </p:spPr>
-        <p:txBody>
-          <a:bodyPr wrap="square" lIns="0" tIns="0" rIns="0" bIns="0" rtlCol="0" anchor="ctr"/>
-          <a:lstStyle/>
-          <a:p>
-            <a:pPr indent="0" marL="0">
-              <a:buNone/>
-            </a:pPr>
-            <a:r>
-              <a:rPr lang="en-US" sz="1200" b="1" dirty="0">
-                <a:solidFill>
-                  <a:srgbClr val="1A1A1A"/>
-                </a:solidFill>
-                <a:latin typeface="Inter" pitchFamily="34" charset="0"/>
-                <a:ea typeface="Inter" pitchFamily="34" charset="-122"/>
-                <a:cs typeface="Inter" pitchFamily="34" charset="-120"/>
-              </a:rPr>
-              <a:t>HYUNDAI ST GEORGE</a:t>
-            </a:r>
-            <a:endParaRPr lang="en-US" sz="1200" dirty="0"/>
-          </a:p>
-        </p:txBody>
-      </p:sp>
-      <p:sp>
-        <p:nvSpPr>
-          <p:cNvPr id="54" name="Text 52"/>
-          <p:cNvSpPr txBox="1"/>
-          <p:nvPr/>
-        </p:nvSpPr>
-        <p:spPr>
-          <a:xfrm>
-            <a:off x="8476488" y="1696212"/>
-            <a:ext cx="3108960" cy="379476"/>
-          </a:xfrm>
-          <a:prstGeom prst="rect">
-            <a:avLst/>
-          </a:prstGeom>
-          <a:noFill/>
-          <a:ln/>
-        </p:spPr>
-        <p:txBody>
-          <a:bodyPr wrap="square" lIns="0" tIns="0" rIns="0" bIns="0" rtlCol="0" anchor="ctr"/>
-          <a:lstStyle/>
-          <a:p>
-            <a:pPr indent="0" marL="0">
-              <a:buNone/>
-            </a:pPr>
-            <a:r>
-              <a:rPr lang="en-US" sz="1200" dirty="0">
-                <a:solidFill>
-                  <a:srgbClr val="595959"/>
-                </a:solidFill>
-                <a:latin typeface="Inter" pitchFamily="34" charset="0"/>
-                <a:ea typeface="Inter" pitchFamily="34" charset="-122"/>
-                <a:cs typeface="Inter" pitchFamily="34" charset="-120"/>
-              </a:rPr>
-              <a:t>Service: Jan, Mar, Jul, Sep</a:t>
-            </a:r>
-            <a:endParaRPr lang="en-US" sz="1200" dirty="0"/>
-          </a:p>
-        </p:txBody>
-      </p:sp>
-      <p:sp>
-        <p:nvSpPr>
-          <p:cNvPr id="55" name="Shape 53"/>
-          <p:cNvSpPr/>
-          <p:nvPr/>
-        </p:nvSpPr>
-        <p:spPr>
-          <a:xfrm>
-            <a:off x="6163056" y="2075688"/>
-            <a:ext cx="5440680" cy="379476"/>
-          </a:xfrm>
-          <a:prstGeom prst="rect">
-            <a:avLst/>
-          </a:prstGeom>
-          <a:solidFill>
-            <a:srgbClr val="F7F7F7"/>
-          </a:solidFill>
-          <a:ln/>
-        </p:spPr>
-      </p:sp>
-      <p:sp>
-        <p:nvSpPr>
-          <p:cNvPr id="56" name="Text 54"/>
-          <p:cNvSpPr txBox="1"/>
-          <p:nvPr/>
-        </p:nvSpPr>
-        <p:spPr>
-          <a:xfrm>
-            <a:off x="6236208" y="2075688"/>
-            <a:ext cx="365760" cy="379476"/>
-          </a:xfrm>
-          <a:prstGeom prst="rect">
-            <a:avLst/>
-          </a:prstGeom>
-          <a:noFill/>
-          <a:ln/>
-        </p:spPr>
-        <p:txBody>
-          <a:bodyPr wrap="square" lIns="0" tIns="0" rIns="0" bIns="0" rtlCol="0" anchor="ctr"/>
-          <a:lstStyle/>
-          <a:p>
-            <a:pPr algn="r" indent="0" marL="0">
-              <a:buNone/>
-            </a:pPr>
-            <a:r>
-              <a:rPr lang="en-US" sz="1400" b="1" dirty="0">
-                <a:solidFill>
-                  <a:srgbClr val="0B7A4A"/>
-                </a:solidFill>
-                <a:latin typeface="Inter" pitchFamily="34" charset="0"/>
-                <a:ea typeface="Inter" pitchFamily="34" charset="-122"/>
-                <a:cs typeface="Inter" pitchFamily="34" charset="-120"/>
-              </a:rPr>
-              <a:t>3</a:t>
-            </a:r>
-            <a:endParaRPr lang="en-US" sz="1400" dirty="0"/>
-          </a:p>
-        </p:txBody>
-      </p:sp>
-      <p:sp>
-        <p:nvSpPr>
-          <p:cNvPr id="57" name="Text 55"/>
-          <p:cNvSpPr txBox="1"/>
-          <p:nvPr/>
-        </p:nvSpPr>
-        <p:spPr>
-          <a:xfrm>
-            <a:off x="6693408" y="2075688"/>
-            <a:ext cx="1783080" cy="379476"/>
-          </a:xfrm>
-          <a:prstGeom prst="rect">
-            <a:avLst/>
-          </a:prstGeom>
-          <a:noFill/>
-          <a:ln/>
-        </p:spPr>
-        <p:txBody>
-          <a:bodyPr wrap="square" lIns="0" tIns="0" rIns="0" bIns="0" rtlCol="0" anchor="ctr"/>
-          <a:lstStyle/>
-          <a:p>
-            <a:pPr indent="0" marL="0">
-              <a:buNone/>
-            </a:pPr>
-            <a:r>
-              <a:rPr lang="en-US" sz="1200" b="1" dirty="0">
-                <a:solidFill>
-                  <a:srgbClr val="1A1A1A"/>
-                </a:solidFill>
-                <a:latin typeface="Inter" pitchFamily="34" charset="0"/>
-                <a:ea typeface="Inter" pitchFamily="34" charset="-122"/>
-                <a:cs typeface="Inter" pitchFamily="34" charset="-120"/>
-              </a:rPr>
-              <a:t>AUDI HENDERSON</a:t>
-            </a:r>
-            <a:endParaRPr lang="en-US" sz="1200" dirty="0"/>
-          </a:p>
-        </p:txBody>
-      </p:sp>
-      <p:sp>
-        <p:nvSpPr>
-          <p:cNvPr id="58" name="Text 56"/>
-          <p:cNvSpPr txBox="1"/>
-          <p:nvPr/>
-        </p:nvSpPr>
-        <p:spPr>
-          <a:xfrm>
-            <a:off x="8476488" y="2075688"/>
-            <a:ext cx="3108960" cy="379476"/>
-          </a:xfrm>
-          <a:prstGeom prst="rect">
-            <a:avLst/>
-          </a:prstGeom>
-          <a:noFill/>
-          <a:ln/>
-        </p:spPr>
-        <p:txBody>
-          <a:bodyPr wrap="square" lIns="0" tIns="0" rIns="0" bIns="0" rtlCol="0" anchor="ctr"/>
-          <a:lstStyle/>
-          <a:p>
-            <a:pPr indent="0" marL="0">
-              <a:buNone/>
-            </a:pPr>
-            <a:r>
-              <a:rPr lang="en-US" sz="1200" dirty="0">
-                <a:solidFill>
-                  <a:srgbClr val="595959"/>
-                </a:solidFill>
-                <a:latin typeface="Inter" pitchFamily="34" charset="0"/>
-                <a:ea typeface="Inter" pitchFamily="34" charset="-122"/>
-                <a:cs typeface="Inter" pitchFamily="34" charset="-120"/>
-              </a:rPr>
-              <a:t>Parts: Jul  ·  Combined: Apr, Jul</a:t>
-            </a:r>
-            <a:endParaRPr lang="en-US" sz="1200" dirty="0"/>
-          </a:p>
-        </p:txBody>
-      </p:sp>
-      <p:sp>
-        <p:nvSpPr>
-          <p:cNvPr id="59" name="Text 57"/>
-          <p:cNvSpPr txBox="1"/>
-          <p:nvPr/>
-        </p:nvSpPr>
-        <p:spPr>
-          <a:xfrm>
-            <a:off x="6236208" y="2455164"/>
-            <a:ext cx="365760" cy="379476"/>
-          </a:xfrm>
-          <a:prstGeom prst="rect">
-            <a:avLst/>
-          </a:prstGeom>
-          <a:noFill/>
-          <a:ln/>
-        </p:spPr>
-        <p:txBody>
-          <a:bodyPr wrap="square" lIns="0" tIns="0" rIns="0" bIns="0" rtlCol="0" anchor="ctr"/>
-          <a:lstStyle/>
-          <a:p>
-            <a:pPr algn="r" indent="0" marL="0">
-              <a:buNone/>
-            </a:pPr>
-            <a:r>
-              <a:rPr lang="en-US" sz="1400" b="1" dirty="0">
-                <a:solidFill>
-                  <a:srgbClr val="0B7A4A"/>
-                </a:solidFill>
-                <a:latin typeface="Inter" pitchFamily="34" charset="0"/>
-                <a:ea typeface="Inter" pitchFamily="34" charset="-122"/>
-                <a:cs typeface="Inter" pitchFamily="34" charset="-120"/>
-              </a:rPr>
-              <a:t>2</a:t>
-            </a:r>
-            <a:endParaRPr lang="en-US" sz="1400" dirty="0"/>
-          </a:p>
-        </p:txBody>
-      </p:sp>
-      <p:sp>
-        <p:nvSpPr>
-          <p:cNvPr id="60" name="Text 58"/>
-          <p:cNvSpPr txBox="1"/>
-          <p:nvPr/>
-        </p:nvSpPr>
-        <p:spPr>
-          <a:xfrm>
-            <a:off x="6693408" y="2455164"/>
-            <a:ext cx="1783080" cy="379476"/>
-          </a:xfrm>
-          <a:prstGeom prst="rect">
-            <a:avLst/>
-          </a:prstGeom>
-          <a:noFill/>
-          <a:ln/>
-        </p:spPr>
-        <p:txBody>
-          <a:bodyPr wrap="square" lIns="0" tIns="0" rIns="0" bIns="0" rtlCol="0" anchor="ctr"/>
-          <a:lstStyle/>
-          <a:p>
-            <a:pPr indent="0" marL="0">
-              <a:buNone/>
-            </a:pPr>
-            <a:r>
-              <a:rPr lang="en-US" sz="1200" b="1" dirty="0">
-                <a:solidFill>
-                  <a:srgbClr val="1A1A1A"/>
-                </a:solidFill>
-                <a:latin typeface="Inter" pitchFamily="34" charset="0"/>
-                <a:ea typeface="Inter" pitchFamily="34" charset="-122"/>
-                <a:cs typeface="Inter" pitchFamily="34" charset="-120"/>
-              </a:rPr>
-              <a:t>CDJR POST FALLS</a:t>
-            </a:r>
-            <a:endParaRPr lang="en-US" sz="1200" dirty="0"/>
-          </a:p>
-        </p:txBody>
-      </p:sp>
-      <p:sp>
-        <p:nvSpPr>
-          <p:cNvPr id="61" name="Text 59"/>
-          <p:cNvSpPr txBox="1"/>
-          <p:nvPr/>
-        </p:nvSpPr>
-        <p:spPr>
-          <a:xfrm>
-            <a:off x="8476488" y="2455164"/>
-            <a:ext cx="3108960" cy="379476"/>
-          </a:xfrm>
-          <a:prstGeom prst="rect">
-            <a:avLst/>
-          </a:prstGeom>
-          <a:noFill/>
-          <a:ln/>
-        </p:spPr>
-        <p:txBody>
-          <a:bodyPr wrap="square" lIns="0" tIns="0" rIns="0" bIns="0" rtlCol="0" anchor="ctr"/>
-          <a:lstStyle/>
-          <a:p>
-            <a:pPr indent="0" marL="0">
-              <a:buNone/>
-            </a:pPr>
-            <a:r>
-              <a:rPr lang="en-US" sz="1200" dirty="0">
-                <a:solidFill>
-                  <a:srgbClr val="595959"/>
-                </a:solidFill>
-                <a:latin typeface="Inter" pitchFamily="34" charset="0"/>
-                <a:ea typeface="Inter" pitchFamily="34" charset="-122"/>
-                <a:cs typeface="Inter" pitchFamily="34" charset="-120"/>
-              </a:rPr>
-              <a:t>Service: Jul  ·  Combined: Jul</a:t>
-            </a:r>
-            <a:endParaRPr lang="en-US" sz="1200" dirty="0"/>
-          </a:p>
-        </p:txBody>
-      </p:sp>
-      <p:sp>
-        <p:nvSpPr>
-          <p:cNvPr id="62" name="Shape 60"/>
-          <p:cNvSpPr/>
-          <p:nvPr/>
-        </p:nvSpPr>
-        <p:spPr>
-          <a:xfrm>
-            <a:off x="6163056" y="2834640"/>
-            <a:ext cx="5440680" cy="379476"/>
-          </a:xfrm>
-          <a:prstGeom prst="rect">
-            <a:avLst/>
-          </a:prstGeom>
-          <a:solidFill>
-            <a:srgbClr val="F7F7F7"/>
-          </a:solidFill>
-          <a:ln/>
-        </p:spPr>
-      </p:sp>
-      <p:sp>
-        <p:nvSpPr>
-          <p:cNvPr id="63" name="Text 61"/>
-          <p:cNvSpPr txBox="1"/>
-          <p:nvPr/>
-        </p:nvSpPr>
-        <p:spPr>
-          <a:xfrm>
-            <a:off x="6236208" y="2834640"/>
-            <a:ext cx="365760" cy="379476"/>
-          </a:xfrm>
-          <a:prstGeom prst="rect">
-            <a:avLst/>
-          </a:prstGeom>
-          <a:noFill/>
-          <a:ln/>
-        </p:spPr>
-        <p:txBody>
-          <a:bodyPr wrap="square" lIns="0" tIns="0" rIns="0" bIns="0" rtlCol="0" anchor="ctr"/>
-          <a:lstStyle/>
-          <a:p>
-            <a:pPr algn="r" indent="0" marL="0">
-              <a:buNone/>
-            </a:pPr>
-            <a:r>
-              <a:rPr lang="en-US" sz="1400" b="1" dirty="0">
-                <a:solidFill>
-                  <a:srgbClr val="0B7A4A"/>
-                </a:solidFill>
-                <a:latin typeface="Inter" pitchFamily="34" charset="0"/>
-                <a:ea typeface="Inter" pitchFamily="34" charset="-122"/>
-                <a:cs typeface="Inter" pitchFamily="34" charset="-120"/>
-              </a:rPr>
-              <a:t>2</a:t>
-            </a:r>
-            <a:endParaRPr lang="en-US" sz="1400" dirty="0"/>
-          </a:p>
-        </p:txBody>
-      </p:sp>
-      <p:sp>
-        <p:nvSpPr>
-          <p:cNvPr id="64" name="Text 62"/>
-          <p:cNvSpPr txBox="1"/>
-          <p:nvPr/>
-        </p:nvSpPr>
-        <p:spPr>
-          <a:xfrm>
-            <a:off x="6693408" y="2834640"/>
-            <a:ext cx="1783080" cy="379476"/>
-          </a:xfrm>
-          <a:prstGeom prst="rect">
-            <a:avLst/>
-          </a:prstGeom>
-          <a:noFill/>
-          <a:ln/>
-        </p:spPr>
-        <p:txBody>
-          <a:bodyPr wrap="square" lIns="0" tIns="0" rIns="0" bIns="0" rtlCol="0" anchor="ctr"/>
-          <a:lstStyle/>
-          <a:p>
-            <a:pPr indent="0" marL="0">
-              <a:buNone/>
-            </a:pPr>
-            <a:r>
-              <a:rPr lang="en-US" sz="1200" b="1" dirty="0">
-                <a:solidFill>
-                  <a:srgbClr val="1A1A1A"/>
-                </a:solidFill>
-                <a:latin typeface="Inter" pitchFamily="34" charset="0"/>
-                <a:ea typeface="Inter" pitchFamily="34" charset="-122"/>
-                <a:cs typeface="Inter" pitchFamily="34" charset="-120"/>
-              </a:rPr>
-              <a:t>GMC PRESCOTT</a:t>
-            </a:r>
-            <a:endParaRPr lang="en-US" sz="1200" dirty="0"/>
-          </a:p>
-        </p:txBody>
-      </p:sp>
-      <p:sp>
-        <p:nvSpPr>
-          <p:cNvPr id="65" name="Text 63"/>
-          <p:cNvSpPr txBox="1"/>
-          <p:nvPr/>
-        </p:nvSpPr>
-        <p:spPr>
-          <a:xfrm>
-            <a:off x="8476488" y="2834640"/>
-            <a:ext cx="3108960" cy="379476"/>
-          </a:xfrm>
-          <a:prstGeom prst="rect">
-            <a:avLst/>
-          </a:prstGeom>
-          <a:noFill/>
-          <a:ln/>
-        </p:spPr>
-        <p:txBody>
-          <a:bodyPr wrap="square" lIns="0" tIns="0" rIns="0" bIns="0" rtlCol="0" anchor="ctr"/>
-          <a:lstStyle/>
-          <a:p>
-            <a:pPr indent="0" marL="0">
-              <a:buNone/>
-            </a:pPr>
-            <a:r>
-              <a:rPr lang="en-US" sz="1200" dirty="0">
-                <a:solidFill>
-                  <a:srgbClr val="595959"/>
-                </a:solidFill>
-                <a:latin typeface="Inter" pitchFamily="34" charset="0"/>
-                <a:ea typeface="Inter" pitchFamily="34" charset="-122"/>
-                <a:cs typeface="Inter" pitchFamily="34" charset="-120"/>
-              </a:rPr>
-              <a:t>Parts: Apr  ·  Combined: Apr</a:t>
-            </a:r>
-            <a:endParaRPr lang="en-US" sz="1200" dirty="0"/>
-          </a:p>
-        </p:txBody>
-      </p:sp>
-      <p:sp>
-        <p:nvSpPr>
-          <p:cNvPr id="66" name="Text 64"/>
-          <p:cNvSpPr txBox="1"/>
-          <p:nvPr/>
-        </p:nvSpPr>
-        <p:spPr>
-          <a:xfrm>
-            <a:off x="6236208" y="3214116"/>
-            <a:ext cx="365760" cy="379476"/>
-          </a:xfrm>
-          <a:prstGeom prst="rect">
-            <a:avLst/>
-          </a:prstGeom>
-          <a:noFill/>
-          <a:ln/>
-        </p:spPr>
-        <p:txBody>
-          <a:bodyPr wrap="square" lIns="0" tIns="0" rIns="0" bIns="0" rtlCol="0" anchor="ctr"/>
-          <a:lstStyle/>
-          <a:p>
-            <a:pPr algn="r" indent="0" marL="0">
-              <a:buNone/>
-            </a:pPr>
-            <a:r>
-              <a:rPr lang="en-US" sz="1400" b="1" dirty="0">
-                <a:solidFill>
-                  <a:srgbClr val="0B7A4A"/>
-                </a:solidFill>
-                <a:latin typeface="Inter" pitchFamily="34" charset="0"/>
-                <a:ea typeface="Inter" pitchFamily="34" charset="-122"/>
-                <a:cs typeface="Inter" pitchFamily="34" charset="-120"/>
-              </a:rPr>
-              <a:t>2</a:t>
-            </a:r>
-            <a:endParaRPr lang="en-US" sz="1400" dirty="0"/>
-          </a:p>
-        </p:txBody>
-      </p:sp>
-      <p:sp>
-        <p:nvSpPr>
-          <p:cNvPr id="67" name="Text 65"/>
-          <p:cNvSpPr txBox="1"/>
-          <p:nvPr/>
-        </p:nvSpPr>
-        <p:spPr>
-          <a:xfrm>
-            <a:off x="6693408" y="3214116"/>
-            <a:ext cx="1783080" cy="379476"/>
-          </a:xfrm>
-          <a:prstGeom prst="rect">
-            <a:avLst/>
-          </a:prstGeom>
-          <a:noFill/>
-          <a:ln/>
-        </p:spPr>
-        <p:txBody>
-          <a:bodyPr wrap="square" lIns="0" tIns="0" rIns="0" bIns="0" rtlCol="0" anchor="ctr"/>
-          <a:lstStyle/>
-          <a:p>
-            <a:pPr indent="0" marL="0">
-              <a:buNone/>
-            </a:pPr>
-            <a:r>
-              <a:rPr lang="en-US" sz="1200" b="1" dirty="0">
-                <a:solidFill>
-                  <a:srgbClr val="1A1A1A"/>
-                </a:solidFill>
-                <a:latin typeface="Inter" pitchFamily="34" charset="0"/>
-                <a:ea typeface="Inter" pitchFamily="34" charset="-122"/>
-                <a:cs typeface="Inter" pitchFamily="34" charset="-120"/>
-              </a:rPr>
-              <a:t>LR LV</a:t>
-            </a:r>
-            <a:endParaRPr lang="en-US" sz="1200" dirty="0"/>
-          </a:p>
-        </p:txBody>
-      </p:sp>
-      <p:sp>
-        <p:nvSpPr>
-          <p:cNvPr id="68" name="Text 66"/>
-          <p:cNvSpPr txBox="1"/>
-          <p:nvPr/>
-        </p:nvSpPr>
-        <p:spPr>
-          <a:xfrm>
-            <a:off x="8476488" y="3214116"/>
-            <a:ext cx="3108960" cy="379476"/>
-          </a:xfrm>
-          <a:prstGeom prst="rect">
-            <a:avLst/>
-          </a:prstGeom>
-          <a:noFill/>
-          <a:ln/>
-        </p:spPr>
-        <p:txBody>
-          <a:bodyPr wrap="square" lIns="0" tIns="0" rIns="0" bIns="0" rtlCol="0" anchor="ctr"/>
-          <a:lstStyle/>
-          <a:p>
-            <a:pPr indent="0" marL="0">
-              <a:buNone/>
-            </a:pPr>
-            <a:r>
-              <a:rPr lang="en-US" sz="1200" dirty="0">
-                <a:solidFill>
-                  <a:srgbClr val="595959"/>
-                </a:solidFill>
-                <a:latin typeface="Inter" pitchFamily="34" charset="0"/>
-                <a:ea typeface="Inter" pitchFamily="34" charset="-122"/>
-                <a:cs typeface="Inter" pitchFamily="34" charset="-120"/>
-              </a:rPr>
-              <a:t>Service: Jul  ·  Combined: Jul</a:t>
-            </a:r>
-            <a:endParaRPr lang="en-US" sz="1200" dirty="0"/>
-          </a:p>
-        </p:txBody>
-      </p:sp>
-      <p:sp>
-        <p:nvSpPr>
-          <p:cNvPr id="69" name="Shape 67"/>
-          <p:cNvSpPr/>
-          <p:nvPr/>
-        </p:nvSpPr>
-        <p:spPr>
-          <a:xfrm>
-            <a:off x="6163056" y="3593592"/>
-            <a:ext cx="5440680" cy="379476"/>
-          </a:xfrm>
-          <a:prstGeom prst="rect">
-            <a:avLst/>
-          </a:prstGeom>
-          <a:solidFill>
-            <a:srgbClr val="F7F7F7"/>
-          </a:solidFill>
-          <a:ln/>
-        </p:spPr>
-      </p:sp>
-      <p:sp>
-        <p:nvSpPr>
-          <p:cNvPr id="70" name="Text 68"/>
-          <p:cNvSpPr txBox="1"/>
-          <p:nvPr/>
-        </p:nvSpPr>
-        <p:spPr>
-          <a:xfrm>
-            <a:off x="6236208" y="3593592"/>
-            <a:ext cx="365760" cy="379476"/>
-          </a:xfrm>
-          <a:prstGeom prst="rect">
-            <a:avLst/>
-          </a:prstGeom>
-          <a:noFill/>
-          <a:ln/>
-        </p:spPr>
-        <p:txBody>
-          <a:bodyPr wrap="square" lIns="0" tIns="0" rIns="0" bIns="0" rtlCol="0" anchor="ctr"/>
-          <a:lstStyle/>
-          <a:p>
-            <a:pPr algn="r" indent="0" marL="0">
-              <a:buNone/>
-            </a:pPr>
-            <a:r>
-              <a:rPr lang="en-US" sz="1400" b="1" dirty="0">
-                <a:solidFill>
-                  <a:srgbClr val="0B7A4A"/>
-                </a:solidFill>
-                <a:latin typeface="Inter" pitchFamily="34" charset="0"/>
-                <a:ea typeface="Inter" pitchFamily="34" charset="-122"/>
-                <a:cs typeface="Inter" pitchFamily="34" charset="-120"/>
-              </a:rPr>
-              <a:t>2</a:t>
-            </a:r>
-            <a:endParaRPr lang="en-US" sz="1400" dirty="0"/>
-          </a:p>
-        </p:txBody>
-      </p:sp>
-      <p:sp>
-        <p:nvSpPr>
-          <p:cNvPr id="71" name="Text 69"/>
-          <p:cNvSpPr txBox="1"/>
-          <p:nvPr/>
-        </p:nvSpPr>
-        <p:spPr>
-          <a:xfrm>
-            <a:off x="6693408" y="3593592"/>
-            <a:ext cx="1783080" cy="379476"/>
-          </a:xfrm>
-          <a:prstGeom prst="rect">
-            <a:avLst/>
-          </a:prstGeom>
-          <a:noFill/>
-          <a:ln/>
-        </p:spPr>
-        <p:txBody>
-          <a:bodyPr wrap="square" lIns="0" tIns="0" rIns="0" bIns="0" rtlCol="0" anchor="ctr"/>
-          <a:lstStyle/>
-          <a:p>
-            <a:pPr indent="0" marL="0">
-              <a:buNone/>
-            </a:pPr>
-            <a:r>
-              <a:rPr lang="en-US" sz="1200" b="1" dirty="0">
-                <a:solidFill>
-                  <a:srgbClr val="1A1A1A"/>
-                </a:solidFill>
-                <a:latin typeface="Inter" pitchFamily="34" charset="0"/>
-                <a:ea typeface="Inter" pitchFamily="34" charset="-122"/>
-                <a:cs typeface="Inter" pitchFamily="34" charset="-120"/>
-              </a:rPr>
-              <a:t>LR RENO</a:t>
-            </a:r>
-            <a:endParaRPr lang="en-US" sz="1200" dirty="0"/>
-          </a:p>
-        </p:txBody>
-      </p:sp>
-      <p:sp>
-        <p:nvSpPr>
-          <p:cNvPr id="72" name="Text 70"/>
-          <p:cNvSpPr txBox="1"/>
-          <p:nvPr/>
-        </p:nvSpPr>
-        <p:spPr>
-          <a:xfrm>
-            <a:off x="8476488" y="3593592"/>
-            <a:ext cx="3108960" cy="379476"/>
-          </a:xfrm>
-          <a:prstGeom prst="rect">
-            <a:avLst/>
-          </a:prstGeom>
-          <a:noFill/>
-          <a:ln/>
-        </p:spPr>
-        <p:txBody>
-          <a:bodyPr wrap="square" lIns="0" tIns="0" rIns="0" bIns="0" rtlCol="0" anchor="ctr"/>
-          <a:lstStyle/>
-          <a:p>
-            <a:pPr indent="0" marL="0">
-              <a:buNone/>
-            </a:pPr>
-            <a:r>
-              <a:rPr lang="en-US" sz="1200" dirty="0">
-                <a:solidFill>
-                  <a:srgbClr val="595959"/>
-                </a:solidFill>
-                <a:latin typeface="Inter" pitchFamily="34" charset="0"/>
-                <a:ea typeface="Inter" pitchFamily="34" charset="-122"/>
-                <a:cs typeface="Inter" pitchFamily="34" charset="-120"/>
-              </a:rPr>
-              <a:t>Service: Aug  ·  Combined: Aug</a:t>
-            </a:r>
-            <a:endParaRPr lang="en-US" sz="1200" dirty="0"/>
-          </a:p>
-        </p:txBody>
-      </p:sp>
-      <p:sp>
-        <p:nvSpPr>
-          <p:cNvPr id="73" name="Text 71"/>
-          <p:cNvSpPr txBox="1"/>
-          <p:nvPr/>
-        </p:nvSpPr>
-        <p:spPr>
-          <a:xfrm>
-            <a:off x="6236208" y="3973068"/>
-            <a:ext cx="365760" cy="379476"/>
-          </a:xfrm>
-          <a:prstGeom prst="rect">
-            <a:avLst/>
-          </a:prstGeom>
-          <a:noFill/>
-          <a:ln/>
-        </p:spPr>
-        <p:txBody>
-          <a:bodyPr wrap="square" lIns="0" tIns="0" rIns="0" bIns="0" rtlCol="0" anchor="ctr"/>
-          <a:lstStyle/>
-          <a:p>
-            <a:pPr algn="r" indent="0" marL="0">
-              <a:buNone/>
-            </a:pPr>
-            <a:r>
-              <a:rPr lang="en-US" sz="1400" b="1" dirty="0">
-                <a:solidFill>
-                  <a:srgbClr val="0B7A4A"/>
-                </a:solidFill>
-                <a:latin typeface="Inter" pitchFamily="34" charset="0"/>
-                <a:ea typeface="Inter" pitchFamily="34" charset="-122"/>
-                <a:cs typeface="Inter" pitchFamily="34" charset="-120"/>
-              </a:rPr>
-              <a:t>2</a:t>
-            </a:r>
-            <a:endParaRPr lang="en-US" sz="1400" dirty="0"/>
-          </a:p>
-        </p:txBody>
-      </p:sp>
-      <p:sp>
-        <p:nvSpPr>
-          <p:cNvPr id="74" name="Text 72"/>
-          <p:cNvSpPr txBox="1"/>
-          <p:nvPr/>
-        </p:nvSpPr>
-        <p:spPr>
-          <a:xfrm>
-            <a:off x="6693408" y="3973068"/>
-            <a:ext cx="1783080" cy="379476"/>
-          </a:xfrm>
-          <a:prstGeom prst="rect">
-            <a:avLst/>
-          </a:prstGeom>
-          <a:noFill/>
-          <a:ln/>
-        </p:spPr>
-        <p:txBody>
-          <a:bodyPr wrap="square" lIns="0" tIns="0" rIns="0" bIns="0" rtlCol="0" anchor="ctr"/>
-          <a:lstStyle/>
-          <a:p>
-            <a:pPr indent="0" marL="0">
-              <a:buNone/>
-            </a:pPr>
-            <a:r>
-              <a:rPr lang="en-US" sz="1200" b="1" dirty="0">
-                <a:solidFill>
-                  <a:srgbClr val="1A1A1A"/>
-                </a:solidFill>
-                <a:latin typeface="Inter" pitchFamily="34" charset="0"/>
-                <a:ea typeface="Inter" pitchFamily="34" charset="-122"/>
-                <a:cs typeface="Inter" pitchFamily="34" charset="-120"/>
-              </a:rPr>
-              <a:t>TOYOTA SPOKANE</a:t>
-            </a:r>
-            <a:endParaRPr lang="en-US" sz="1200" dirty="0"/>
-          </a:p>
-        </p:txBody>
-      </p:sp>
-      <p:sp>
-        <p:nvSpPr>
-          <p:cNvPr id="75" name="Text 73"/>
-          <p:cNvSpPr txBox="1"/>
-          <p:nvPr/>
-        </p:nvSpPr>
-        <p:spPr>
-          <a:xfrm>
-            <a:off x="8476488" y="3973068"/>
-            <a:ext cx="3108960" cy="379476"/>
-          </a:xfrm>
-          <a:prstGeom prst="rect">
-            <a:avLst/>
-          </a:prstGeom>
-          <a:noFill/>
-          <a:ln/>
-        </p:spPr>
-        <p:txBody>
-          <a:bodyPr wrap="square" lIns="0" tIns="0" rIns="0" bIns="0" rtlCol="0" anchor="ctr"/>
-          <a:lstStyle/>
-          <a:p>
-            <a:pPr indent="0" marL="0">
-              <a:buNone/>
-            </a:pPr>
-            <a:r>
-              <a:rPr lang="en-US" sz="1200" dirty="0">
-                <a:solidFill>
-                  <a:srgbClr val="595959"/>
-                </a:solidFill>
-                <a:latin typeface="Inter" pitchFamily="34" charset="0"/>
-                <a:ea typeface="Inter" pitchFamily="34" charset="-122"/>
-                <a:cs typeface="Inter" pitchFamily="34" charset="-120"/>
-              </a:rPr>
-              <a:t>Service: Jul  ·  Combined: Jul</a:t>
-            </a:r>
-            <a:endParaRPr lang="en-US" sz="1200" dirty="0"/>
-          </a:p>
-        </p:txBody>
-      </p:sp>
-      <p:sp>
-        <p:nvSpPr>
-          <p:cNvPr id="76" name="Shape 74"/>
-          <p:cNvSpPr/>
-          <p:nvPr/>
-        </p:nvSpPr>
-        <p:spPr>
-          <a:xfrm>
-            <a:off x="6163056" y="4352544"/>
-            <a:ext cx="5440680" cy="379476"/>
-          </a:xfrm>
-          <a:prstGeom prst="rect">
-            <a:avLst/>
-          </a:prstGeom>
-          <a:solidFill>
-            <a:srgbClr val="F7F7F7"/>
-          </a:solidFill>
-          <a:ln/>
-        </p:spPr>
-      </p:sp>
-      <p:sp>
-        <p:nvSpPr>
-          <p:cNvPr id="77" name="Text 75"/>
-          <p:cNvSpPr txBox="1"/>
-          <p:nvPr/>
-        </p:nvSpPr>
-        <p:spPr>
-          <a:xfrm>
-            <a:off x="6236208" y="4352544"/>
-            <a:ext cx="365760" cy="379476"/>
-          </a:xfrm>
-          <a:prstGeom prst="rect">
-            <a:avLst/>
-          </a:prstGeom>
-          <a:noFill/>
-          <a:ln/>
-        </p:spPr>
-        <p:txBody>
-          <a:bodyPr wrap="square" lIns="0" tIns="0" rIns="0" bIns="0" rtlCol="0" anchor="ctr"/>
-          <a:lstStyle/>
-          <a:p>
-            <a:pPr algn="r" indent="0" marL="0">
-              <a:buNone/>
-            </a:pPr>
-            <a:r>
-              <a:rPr lang="en-US" sz="1400" b="1" dirty="0">
-                <a:solidFill>
-                  <a:srgbClr val="0B7A4A"/>
-                </a:solidFill>
-                <a:latin typeface="Inter" pitchFamily="34" charset="0"/>
-                <a:ea typeface="Inter" pitchFamily="34" charset="-122"/>
-                <a:cs typeface="Inter" pitchFamily="34" charset="-120"/>
-              </a:rPr>
-              <a:t>2</a:t>
-            </a:r>
-            <a:endParaRPr lang="en-US" sz="1400" dirty="0"/>
-          </a:p>
-        </p:txBody>
-      </p:sp>
-      <p:sp>
-        <p:nvSpPr>
-          <p:cNvPr id="78" name="Text 76"/>
-          <p:cNvSpPr txBox="1"/>
-          <p:nvPr/>
-        </p:nvSpPr>
-        <p:spPr>
-          <a:xfrm>
-            <a:off x="6693408" y="4352544"/>
-            <a:ext cx="1783080" cy="379476"/>
-          </a:xfrm>
-          <a:prstGeom prst="rect">
-            <a:avLst/>
-          </a:prstGeom>
-          <a:noFill/>
-          <a:ln/>
-        </p:spPr>
-        <p:txBody>
-          <a:bodyPr wrap="square" lIns="0" tIns="0" rIns="0" bIns="0" rtlCol="0" anchor="ctr"/>
-          <a:lstStyle/>
-          <a:p>
-            <a:pPr indent="0" marL="0">
-              <a:buNone/>
-            </a:pPr>
-            <a:r>
-              <a:rPr lang="en-US" sz="1200" b="1" dirty="0">
-                <a:solidFill>
-                  <a:srgbClr val="1A1A1A"/>
-                </a:solidFill>
-                <a:latin typeface="Inter" pitchFamily="34" charset="0"/>
-                <a:ea typeface="Inter" pitchFamily="34" charset="-122"/>
-                <a:cs typeface="Inter" pitchFamily="34" charset="-120"/>
-              </a:rPr>
-              <a:t>VOLVO</a:t>
-            </a:r>
-            <a:endParaRPr lang="en-US" sz="1200" dirty="0"/>
-          </a:p>
-        </p:txBody>
-      </p:sp>
-      <p:sp>
-        <p:nvSpPr>
-          <p:cNvPr id="79" name="Text 77"/>
-          <p:cNvSpPr txBox="1"/>
-          <p:nvPr/>
-        </p:nvSpPr>
-        <p:spPr>
-          <a:xfrm>
-            <a:off x="8476488" y="4352544"/>
-            <a:ext cx="3108960" cy="379476"/>
-          </a:xfrm>
-          <a:prstGeom prst="rect">
-            <a:avLst/>
-          </a:prstGeom>
-          <a:noFill/>
-          <a:ln/>
-        </p:spPr>
-        <p:txBody>
-          <a:bodyPr wrap="square" lIns="0" tIns="0" rIns="0" bIns="0" rtlCol="0" anchor="ctr"/>
-          <a:lstStyle/>
-          <a:p>
-            <a:pPr indent="0" marL="0">
-              <a:buNone/>
-            </a:pPr>
-            <a:r>
-              <a:rPr lang="en-US" sz="1200" dirty="0">
-                <a:solidFill>
-                  <a:srgbClr val="595959"/>
-                </a:solidFill>
-                <a:latin typeface="Inter" pitchFamily="34" charset="0"/>
-                <a:ea typeface="Inter" pitchFamily="34" charset="-122"/>
-                <a:cs typeface="Inter" pitchFamily="34" charset="-120"/>
-              </a:rPr>
-              <a:t>Service: Apr, Jun</a:t>
-            </a:r>
-            <a:endParaRPr lang="en-US" sz="1200" dirty="0"/>
-          </a:p>
-        </p:txBody>
-      </p:sp>
-      <p:sp>
-        <p:nvSpPr>
-          <p:cNvPr id="80" name="Text 78"/>
-          <p:cNvSpPr txBox="1"/>
-          <p:nvPr/>
-        </p:nvSpPr>
-        <p:spPr>
-          <a:xfrm>
-            <a:off x="6236208" y="4732020"/>
-            <a:ext cx="365760" cy="379476"/>
-          </a:xfrm>
-          <a:prstGeom prst="rect">
-            <a:avLst/>
-          </a:prstGeom>
-          <a:noFill/>
-          <a:ln/>
-        </p:spPr>
-        <p:txBody>
-          <a:bodyPr wrap="square" lIns="0" tIns="0" rIns="0" bIns="0" rtlCol="0" anchor="ctr"/>
-          <a:lstStyle/>
-          <a:p>
-            <a:pPr algn="r" indent="0" marL="0">
-              <a:buNone/>
-            </a:pPr>
-            <a:r>
-              <a:rPr lang="en-US" sz="1400" b="1" dirty="0">
-                <a:solidFill>
-                  <a:srgbClr val="0B7A4A"/>
-                </a:solidFill>
-                <a:latin typeface="Inter" pitchFamily="34" charset="0"/>
-                <a:ea typeface="Inter" pitchFamily="34" charset="-122"/>
-                <a:cs typeface="Inter" pitchFamily="34" charset="-120"/>
-              </a:rPr>
-              <a:t>1</a:t>
-            </a:r>
-            <a:endParaRPr lang="en-US" sz="1400" dirty="0"/>
-          </a:p>
-        </p:txBody>
-      </p:sp>
-      <p:sp>
-        <p:nvSpPr>
-          <p:cNvPr id="81" name="Text 79"/>
-          <p:cNvSpPr txBox="1"/>
-          <p:nvPr/>
-        </p:nvSpPr>
-        <p:spPr>
-          <a:xfrm>
-            <a:off x="6693408" y="4732020"/>
-            <a:ext cx="1783080" cy="379476"/>
-          </a:xfrm>
-          <a:prstGeom prst="rect">
-            <a:avLst/>
-          </a:prstGeom>
-          <a:noFill/>
-          <a:ln/>
-        </p:spPr>
-        <p:txBody>
-          <a:bodyPr wrap="square" lIns="0" tIns="0" rIns="0" bIns="0" rtlCol="0" anchor="ctr"/>
-          <a:lstStyle/>
-          <a:p>
-            <a:pPr indent="0" marL="0">
-              <a:buNone/>
-            </a:pPr>
-            <a:r>
-              <a:rPr lang="en-US" sz="1200" b="1" dirty="0">
-                <a:solidFill>
-                  <a:srgbClr val="1A1A1A"/>
-                </a:solidFill>
-                <a:latin typeface="Inter" pitchFamily="34" charset="0"/>
-                <a:ea typeface="Inter" pitchFamily="34" charset="-122"/>
-                <a:cs typeface="Inter" pitchFamily="34" charset="-120"/>
-              </a:rPr>
-              <a:t>SUBARU PRESCOTT</a:t>
-            </a:r>
-            <a:endParaRPr lang="en-US" sz="1200" dirty="0"/>
-          </a:p>
-        </p:txBody>
-      </p:sp>
-      <p:sp>
-        <p:nvSpPr>
-          <p:cNvPr id="82" name="Text 80"/>
-          <p:cNvSpPr txBox="1"/>
-          <p:nvPr/>
-        </p:nvSpPr>
-        <p:spPr>
-          <a:xfrm>
-            <a:off x="8476488" y="4732020"/>
-            <a:ext cx="3108960" cy="379476"/>
-          </a:xfrm>
-          <a:prstGeom prst="rect">
-            <a:avLst/>
-          </a:prstGeom>
-          <a:noFill/>
-          <a:ln/>
-        </p:spPr>
-        <p:txBody>
-          <a:bodyPr wrap="square" lIns="0" tIns="0" rIns="0" bIns="0" rtlCol="0" anchor="ctr"/>
-          <a:lstStyle/>
-          <a:p>
-            <a:pPr indent="0" marL="0">
-              <a:buNone/>
-            </a:pPr>
-            <a:r>
-              <a:rPr lang="en-US" sz="1200" dirty="0">
-                <a:solidFill>
-                  <a:srgbClr val="595959"/>
-                </a:solidFill>
-                <a:latin typeface="Inter" pitchFamily="34" charset="0"/>
-                <a:ea typeface="Inter" pitchFamily="34" charset="-122"/>
-                <a:cs typeface="Inter" pitchFamily="34" charset="-120"/>
-              </a:rPr>
-              <a:t>Combined: Apr</a:t>
-            </a:r>
-            <a:endParaRPr lang="en-US" sz="1200" dirty="0"/>
-          </a:p>
-        </p:txBody>
-      </p:sp>
-      <p:sp>
-        <p:nvSpPr>
-          <p:cNvPr id="83" name="Shape 81"/>
-          <p:cNvSpPr/>
-          <p:nvPr/>
-        </p:nvSpPr>
-        <p:spPr>
-          <a:xfrm>
-            <a:off x="6163056" y="5111496"/>
-            <a:ext cx="5440680" cy="379476"/>
-          </a:xfrm>
-          <a:prstGeom prst="rect">
-            <a:avLst/>
-          </a:prstGeom>
-          <a:solidFill>
-            <a:srgbClr val="F7F7F7"/>
-          </a:solidFill>
-          <a:ln/>
-        </p:spPr>
-      </p:sp>
-      <p:sp>
-        <p:nvSpPr>
-          <p:cNvPr id="84" name="Text 82"/>
-          <p:cNvSpPr txBox="1"/>
-          <p:nvPr/>
-        </p:nvSpPr>
-        <p:spPr>
-          <a:xfrm>
-            <a:off x="6236208" y="5111496"/>
-            <a:ext cx="365760" cy="379476"/>
-          </a:xfrm>
-          <a:prstGeom prst="rect">
-            <a:avLst/>
-          </a:prstGeom>
-          <a:noFill/>
-          <a:ln/>
-        </p:spPr>
-        <p:txBody>
-          <a:bodyPr wrap="square" lIns="0" tIns="0" rIns="0" bIns="0" rtlCol="0" anchor="ctr"/>
-          <a:lstStyle/>
-          <a:p>
-            <a:pPr algn="r" indent="0" marL="0">
-              <a:buNone/>
-            </a:pPr>
-            <a:r>
-              <a:rPr lang="en-US" sz="1400" b="1" dirty="0">
-                <a:solidFill>
-                  <a:srgbClr val="0B7A4A"/>
-                </a:solidFill>
-                <a:latin typeface="Inter" pitchFamily="34" charset="0"/>
-                <a:ea typeface="Inter" pitchFamily="34" charset="-122"/>
-                <a:cs typeface="Inter" pitchFamily="34" charset="-120"/>
-              </a:rPr>
-              <a:t>1</a:t>
-            </a:r>
-            <a:endParaRPr lang="en-US" sz="1400" dirty="0"/>
-          </a:p>
-        </p:txBody>
-      </p:sp>
-      <p:sp>
-        <p:nvSpPr>
-          <p:cNvPr id="85" name="Text 83"/>
-          <p:cNvSpPr txBox="1"/>
-          <p:nvPr/>
-        </p:nvSpPr>
-        <p:spPr>
-          <a:xfrm>
-            <a:off x="6693408" y="5111496"/>
-            <a:ext cx="1783080" cy="379476"/>
-          </a:xfrm>
-          <a:prstGeom prst="rect">
-            <a:avLst/>
-          </a:prstGeom>
-          <a:noFill/>
-          <a:ln/>
-        </p:spPr>
-        <p:txBody>
-          <a:bodyPr wrap="square" lIns="0" tIns="0" rIns="0" bIns="0" rtlCol="0" anchor="ctr"/>
-          <a:lstStyle/>
-          <a:p>
-            <a:pPr indent="0" marL="0">
-              <a:buNone/>
-            </a:pPr>
-            <a:r>
-              <a:rPr lang="en-US" sz="1200" b="1" dirty="0">
-                <a:solidFill>
-                  <a:srgbClr val="1A1A1A"/>
-                </a:solidFill>
-                <a:latin typeface="Inter" pitchFamily="34" charset="0"/>
-                <a:ea typeface="Inter" pitchFamily="34" charset="-122"/>
-                <a:cs typeface="Inter" pitchFamily="34" charset="-120"/>
-              </a:rPr>
-              <a:t>KIA LV</a:t>
-            </a:r>
-            <a:endParaRPr lang="en-US" sz="1200" dirty="0"/>
-          </a:p>
-        </p:txBody>
-      </p:sp>
-      <p:sp>
-        <p:nvSpPr>
-          <p:cNvPr id="86" name="Text 84"/>
-          <p:cNvSpPr txBox="1"/>
-          <p:nvPr/>
-        </p:nvSpPr>
-        <p:spPr>
-          <a:xfrm>
-            <a:off x="8476488" y="5111496"/>
-            <a:ext cx="3108960" cy="379476"/>
-          </a:xfrm>
-          <a:prstGeom prst="rect">
-            <a:avLst/>
-          </a:prstGeom>
-          <a:noFill/>
-          <a:ln/>
-        </p:spPr>
-        <p:txBody>
-          <a:bodyPr wrap="square" lIns="0" tIns="0" rIns="0" bIns="0" rtlCol="0" anchor="ctr"/>
-          <a:lstStyle/>
-          <a:p>
-            <a:pPr indent="0" marL="0">
-              <a:buNone/>
-            </a:pPr>
-            <a:r>
-              <a:rPr lang="en-US" sz="1200" dirty="0">
-                <a:solidFill>
-                  <a:srgbClr val="595959"/>
-                </a:solidFill>
-                <a:latin typeface="Inter" pitchFamily="34" charset="0"/>
-                <a:ea typeface="Inter" pitchFamily="34" charset="-122"/>
-                <a:cs typeface="Inter" pitchFamily="34" charset="-120"/>
-              </a:rPr>
-              <a:t>Service: Sep</a:t>
-            </a:r>
-            <a:endParaRPr lang="en-US" sz="1200" dirty="0"/>
-          </a:p>
-        </p:txBody>
-      </p:sp>
-      <p:sp>
-        <p:nvSpPr>
-          <p:cNvPr id="87" name="Shape 85"/>
-          <p:cNvSpPr/>
-          <p:nvPr/>
-        </p:nvSpPr>
-        <p:spPr>
-          <a:xfrm>
-            <a:off x="457200" y="6126480"/>
-            <a:ext cx="11274552" cy="371856"/>
-          </a:xfrm>
-          <a:prstGeom prst="rect">
-            <a:avLst/>
-          </a:prstGeom>
-          <a:solidFill>
-            <a:srgbClr val="E6F6EE"/>
-          </a:solidFill>
-          <a:ln/>
-        </p:spPr>
-      </p:sp>
-      <p:sp>
-        <p:nvSpPr>
-          <p:cNvPr id="88" name="Text 86"/>
-          <p:cNvSpPr txBox="1"/>
-          <p:nvPr/>
-        </p:nvSpPr>
-        <p:spPr>
-          <a:xfrm>
-            <a:off x="658368" y="6144768"/>
-            <a:ext cx="10927080" cy="335280"/>
-          </a:xfrm>
-          <a:prstGeom prst="rect">
-            <a:avLst/>
-          </a:prstGeom>
-          <a:noFill/>
-          <a:ln/>
-        </p:spPr>
-        <p:txBody>
-          <a:bodyPr wrap="square" lIns="0" tIns="0" rIns="0" bIns="0" rtlCol="0" anchor="ctr"/>
-          <a:lstStyle/>
-          <a:p>
-            <a:pPr indent="0" marL="0">
-              <a:buNone/>
-            </a:pPr>
-            <a:r>
-              <a:rPr lang="en-US" sz="1600" b="1" dirty="0">
-                <a:solidFill>
-                  <a:srgbClr val="0B7A4A"/>
-                </a:solidFill>
-                <a:latin typeface="Inter" pitchFamily="34" charset="0"/>
-                <a:ea typeface="Inter" pitchFamily="34" charset="-122"/>
-                <a:cs typeface="Inter" pitchFamily="34" charset="-120"/>
-              </a:rPr>
-              <a:t>23 stores set 98 records. Honda Spokane and Nissan set 9 each.</a:t>
-            </a:r>
-            <a:endParaRPr lang="en-US" sz="1600" dirty="0"/>
-          </a:p>
-        </p:txBody>
-      </p:sp>
-    </p:spTree>
-  </p:cSld>
-  <p:clrMapOvr>
-    <a:masterClrMapping/>
-  </p:clrMapOvr>
-</p:sld>
-</file>
-
-<file path=ppt/slides/slide4.xml><?xml version="1.0" encoding="utf-8"?>
-<p:sld xmlns:a="http://schemas.openxmlformats.org/drawingml/2006/main" xmlns:r="http://schemas.openxmlformats.org/officeDocument/2006/relationships" xmlns:p="http://schemas.openxmlformats.org/presentationml/2006/main">
-  <p:cSld name="Slide 4">
-    <p:bg>
-      <p:bgPr>
-        <a:solidFill>
-          <a:srgbClr val="EDEDED"/>
-        </a:solidFill>
-      </p:bgPr>
-    </p:bg>
-    <p:spTree>
-      <p:nvGrpSpPr>
-        <p:cNvPr id="1" name=""/>
-        <p:cNvGrpSpPr/>
-        <p:nvPr/>
-      </p:nvGrpSpPr>
-      <p:grpSpPr>
-        <a:xfrm>
-          <a:off x="0" y="0"/>
-          <a:ext cx="0" cy="0"/>
-          <a:chOff x="0" y="0"/>
-          <a:chExt cx="0" cy="0"/>
-        </a:xfrm>
-      </p:grpSpPr>
-      <p:sp>
-        <p:nvSpPr>
-          <p:cNvPr id="2" name="Shape 0"/>
-          <p:cNvSpPr/>
-          <p:nvPr/>
-        </p:nvSpPr>
-        <p:spPr>
-          <a:xfrm>
-            <a:off x="457200" y="402336"/>
-            <a:ext cx="50292" cy="192024"/>
-          </a:xfrm>
-          <a:prstGeom prst="rect">
-            <a:avLst/>
-          </a:prstGeom>
-          <a:solidFill>
-            <a:srgbClr val="2587C5"/>
-          </a:solidFill>
-          <a:ln/>
-        </p:spPr>
-      </p:sp>
-      <p:sp>
-        <p:nvSpPr>
-          <p:cNvPr id="3" name="Text 1"/>
-          <p:cNvSpPr txBox="1"/>
-          <p:nvPr/>
-        </p:nvSpPr>
-        <p:spPr>
-          <a:xfrm>
-            <a:off x="621792" y="338328"/>
-            <a:ext cx="8229600" cy="274320"/>
-          </a:xfrm>
-          <a:prstGeom prst="rect">
-            <a:avLst/>
-          </a:prstGeom>
-          <a:noFill/>
-          <a:ln/>
-        </p:spPr>
-        <p:txBody>
-          <a:bodyPr wrap="square" lIns="0" tIns="0" rIns="0" bIns="0" rtlCol="0" anchor="ctr"/>
-          <a:lstStyle/>
-          <a:p>
-            <a:pPr indent="0" marL="0">
-              <a:buNone/>
-            </a:pPr>
-            <a:r>
-              <a:rPr lang="en-US" sz="1400" b="1" spc="110" kern="0" dirty="0">
-                <a:solidFill>
-                  <a:srgbClr val="595959"/>
-                </a:solidFill>
-                <a:latin typeface="Inter" pitchFamily="34" charset="0"/>
-                <a:ea typeface="Inter" pitchFamily="34" charset="-122"/>
-                <a:cs typeface="Inter" pitchFamily="34" charset="-120"/>
-              </a:rPr>
-              <a:t>FIXED OPS RECORDS</a:t>
-            </a:r>
-            <a:endParaRPr lang="en-US" sz="1400" dirty="0"/>
-          </a:p>
-        </p:txBody>
-      </p:sp>
-      <p:sp>
-        <p:nvSpPr>
-          <p:cNvPr id="4" name="Text 2"/>
-          <p:cNvSpPr txBox="1"/>
-          <p:nvPr/>
-        </p:nvSpPr>
-        <p:spPr>
-          <a:xfrm>
-            <a:off x="457200" y="640080"/>
-            <a:ext cx="11338560" cy="502920"/>
-          </a:xfrm>
-          <a:prstGeom prst="rect">
-            <a:avLst/>
-          </a:prstGeom>
-          <a:noFill/>
-          <a:ln/>
-        </p:spPr>
-        <p:txBody>
-          <a:bodyPr wrap="square" lIns="0" tIns="0" rIns="0" bIns="0" rtlCol="0" anchor="ctr"/>
-          <a:lstStyle/>
-          <a:p>
-            <a:pPr indent="0" marL="0">
-              <a:buNone/>
-            </a:pPr>
-            <a:r>
-              <a:rPr lang="en-US" sz="2800" dirty="0">
-                <a:solidFill>
-                  <a:srgbClr val="1A1A1A"/>
-                </a:solidFill>
-                <a:latin typeface="Inter" pitchFamily="34" charset="0"/>
-                <a:ea typeface="Inter" pitchFamily="34" charset="-122"/>
-                <a:cs typeface="Inter" pitchFamily="34" charset="-120"/>
-              </a:rPr>
-              <a:t>Record Setters</a:t>
-            </a:r>
-            <a:endParaRPr lang="en-US" sz="2800" dirty="0"/>
-          </a:p>
-        </p:txBody>
-      </p:sp>
-      <p:sp>
-        <p:nvSpPr>
-          <p:cNvPr id="5" name="Shape 3"/>
-          <p:cNvSpPr/>
-          <p:nvPr/>
-        </p:nvSpPr>
-        <p:spPr>
-          <a:xfrm>
-            <a:off x="457200" y="1207008"/>
-            <a:ext cx="11274552" cy="4782312"/>
-          </a:xfrm>
-          <a:prstGeom prst="rect">
-            <a:avLst/>
-          </a:prstGeom>
-          <a:solidFill>
-            <a:srgbClr val="FFFFFF"/>
-          </a:solidFill>
-          <a:ln/>
-        </p:spPr>
-      </p:sp>
-      <p:sp>
-        <p:nvSpPr>
-          <p:cNvPr id="6" name="Shape 4"/>
-          <p:cNvSpPr/>
-          <p:nvPr/>
-        </p:nvSpPr>
-        <p:spPr>
-          <a:xfrm>
-            <a:off x="658368" y="1371600"/>
-            <a:ext cx="3526536" cy="1746504"/>
-          </a:xfrm>
-          <a:prstGeom prst="rect">
-            <a:avLst/>
-          </a:prstGeom>
-          <a:solidFill>
-            <a:srgbClr val="F7F7F7"/>
-          </a:solidFill>
-          <a:ln/>
-        </p:spPr>
-      </p:sp>
-      <p:sp>
-        <p:nvSpPr>
-          <p:cNvPr id="7" name="Shape 5"/>
-          <p:cNvSpPr/>
-          <p:nvPr/>
-        </p:nvSpPr>
-        <p:spPr>
-          <a:xfrm>
-            <a:off x="658368" y="1371600"/>
-            <a:ext cx="54864" cy="1746504"/>
-          </a:xfrm>
-          <a:prstGeom prst="rect">
-            <a:avLst/>
-          </a:prstGeom>
-          <a:solidFill>
-            <a:srgbClr val="12A566"/>
-          </a:solidFill>
-          <a:ln/>
-        </p:spPr>
-      </p:sp>
-      <p:sp>
-        <p:nvSpPr>
-          <p:cNvPr id="8" name="Text 6"/>
-          <p:cNvSpPr txBox="1"/>
-          <p:nvPr/>
-        </p:nvSpPr>
-        <p:spPr>
-          <a:xfrm>
-            <a:off x="841248" y="1463040"/>
-            <a:ext cx="3252216" cy="329184"/>
-          </a:xfrm>
-          <a:prstGeom prst="rect">
-            <a:avLst/>
-          </a:prstGeom>
-          <a:noFill/>
-          <a:ln/>
-        </p:spPr>
-        <p:txBody>
-          <a:bodyPr wrap="square" lIns="0" tIns="0" rIns="0" bIns="0" rtlCol="0" anchor="ctr"/>
-          <a:lstStyle/>
-          <a:p>
-            <a:pPr indent="0" marL="0">
-              <a:buNone/>
-            </a:pPr>
-            <a:r>
-              <a:rPr lang="en-US" sz="1700" b="1" dirty="0">
-                <a:solidFill>
-                  <a:srgbClr val="1A1A1A"/>
-                </a:solidFill>
-                <a:latin typeface="Inter" pitchFamily="34" charset="0"/>
-                <a:ea typeface="Inter" pitchFamily="34" charset="-122"/>
-                <a:cs typeface="Inter" pitchFamily="34" charset="-120"/>
-              </a:rPr>
-              <a:t>Honda Spokane   </a:t>
-            </a:r>
-            <a:pPr indent="0" marL="0">
-              <a:buNone/>
-            </a:pPr>
-            <a:r>
-              <a:rPr lang="en-US" sz="1500" b="1" dirty="0">
-                <a:solidFill>
-                  <a:srgbClr val="0B7A4A"/>
-                </a:solidFill>
-                <a:latin typeface="Inter" pitchFamily="34" charset="0"/>
-                <a:ea typeface="Inter" pitchFamily="34" charset="-122"/>
-                <a:cs typeface="Inter" pitchFamily="34" charset="-120"/>
-              </a:rPr>
-              <a:t>9 records</a:t>
-            </a:r>
-            <a:endParaRPr lang="en-US" sz="1700" dirty="0"/>
-          </a:p>
-        </p:txBody>
-      </p:sp>
-      <p:sp>
-        <p:nvSpPr>
-          <p:cNvPr id="9" name="Text 7"/>
-          <p:cNvSpPr txBox="1"/>
-          <p:nvPr/>
-        </p:nvSpPr>
-        <p:spPr>
-          <a:xfrm>
-            <a:off x="841248" y="1828800"/>
-            <a:ext cx="3252216" cy="1197864"/>
-          </a:xfrm>
-          <a:prstGeom prst="rect">
-            <a:avLst/>
-          </a:prstGeom>
-          <a:noFill/>
-          <a:ln/>
-        </p:spPr>
-        <p:txBody>
-          <a:bodyPr wrap="square" lIns="0" tIns="0" rIns="0" bIns="0" rtlCol="0" anchor="t"/>
-          <a:lstStyle/>
-          <a:p>
-            <a:pPr indent="0" marL="0">
-              <a:buNone/>
-            </a:pPr>
-            <a:r>
-              <a:rPr lang="en-US" sz="1400" dirty="0">
-                <a:solidFill>
-                  <a:srgbClr val="595959"/>
-                </a:solidFill>
-                <a:latin typeface="Inter" pitchFamily="34" charset="0"/>
-                <a:ea typeface="Inter" pitchFamily="34" charset="-122"/>
-                <a:cs typeface="Inter" pitchFamily="34" charset="-120"/>
-              </a:rPr>
-              <a:t>Best combined month ever 4 times (Mar, Apr, Jun, Jul), now $542K. Service record 4 times. Parts record in Jul.</a:t>
-            </a:r>
-            <a:endParaRPr lang="en-US" sz="1400" dirty="0"/>
-          </a:p>
-        </p:txBody>
-      </p:sp>
-      <p:sp>
-        <p:nvSpPr>
-          <p:cNvPr id="10" name="Shape 8"/>
-          <p:cNvSpPr/>
-          <p:nvPr/>
-        </p:nvSpPr>
-        <p:spPr>
-          <a:xfrm>
-            <a:off x="4331208" y="1371600"/>
-            <a:ext cx="3526536" cy="1746504"/>
-          </a:xfrm>
-          <a:prstGeom prst="rect">
-            <a:avLst/>
-          </a:prstGeom>
-          <a:solidFill>
-            <a:srgbClr val="F7F7F7"/>
-          </a:solidFill>
-          <a:ln/>
-        </p:spPr>
-      </p:sp>
-      <p:sp>
-        <p:nvSpPr>
-          <p:cNvPr id="11" name="Shape 9"/>
-          <p:cNvSpPr/>
-          <p:nvPr/>
-        </p:nvSpPr>
-        <p:spPr>
-          <a:xfrm>
-            <a:off x="4331208" y="1371600"/>
-            <a:ext cx="54864" cy="1746504"/>
-          </a:xfrm>
-          <a:prstGeom prst="rect">
-            <a:avLst/>
-          </a:prstGeom>
-          <a:solidFill>
-            <a:srgbClr val="12A566"/>
-          </a:solidFill>
-          <a:ln/>
-        </p:spPr>
-      </p:sp>
-      <p:sp>
-        <p:nvSpPr>
-          <p:cNvPr id="12" name="Text 10"/>
-          <p:cNvSpPr txBox="1"/>
-          <p:nvPr/>
-        </p:nvSpPr>
-        <p:spPr>
-          <a:xfrm>
-            <a:off x="4514088" y="1463040"/>
-            <a:ext cx="3252216" cy="329184"/>
-          </a:xfrm>
-          <a:prstGeom prst="rect">
-            <a:avLst/>
-          </a:prstGeom>
-          <a:noFill/>
-          <a:ln/>
-        </p:spPr>
-        <p:txBody>
-          <a:bodyPr wrap="square" lIns="0" tIns="0" rIns="0" bIns="0" rtlCol="0" anchor="ctr"/>
-          <a:lstStyle/>
-          <a:p>
-            <a:pPr indent="0" marL="0">
-              <a:buNone/>
-            </a:pPr>
-            <a:r>
-              <a:rPr lang="en-US" sz="1700" b="1" dirty="0">
-                <a:solidFill>
-                  <a:srgbClr val="1A1A1A"/>
-                </a:solidFill>
-                <a:latin typeface="Inter" pitchFamily="34" charset="0"/>
-                <a:ea typeface="Inter" pitchFamily="34" charset="-122"/>
-                <a:cs typeface="Inter" pitchFamily="34" charset="-120"/>
-              </a:rPr>
-              <a:t>Nissan   </a:t>
-            </a:r>
-            <a:pPr indent="0" marL="0">
-              <a:buNone/>
-            </a:pPr>
-            <a:r>
-              <a:rPr lang="en-US" sz="1500" b="1" dirty="0">
-                <a:solidFill>
-                  <a:srgbClr val="0B7A4A"/>
-                </a:solidFill>
-                <a:latin typeface="Inter" pitchFamily="34" charset="0"/>
-                <a:ea typeface="Inter" pitchFamily="34" charset="-122"/>
-                <a:cs typeface="Inter" pitchFamily="34" charset="-120"/>
-              </a:rPr>
-              <a:t>9 records</a:t>
-            </a:r>
-            <a:endParaRPr lang="en-US" sz="1700" dirty="0"/>
-          </a:p>
-        </p:txBody>
-      </p:sp>
-      <p:sp>
-        <p:nvSpPr>
-          <p:cNvPr id="13" name="Text 11"/>
-          <p:cNvSpPr txBox="1"/>
-          <p:nvPr/>
-        </p:nvSpPr>
-        <p:spPr>
-          <a:xfrm>
-            <a:off x="4514088" y="1828800"/>
-            <a:ext cx="3252216" cy="1197864"/>
-          </a:xfrm>
-          <a:prstGeom prst="rect">
-            <a:avLst/>
-          </a:prstGeom>
-          <a:noFill/>
-          <a:ln/>
-        </p:spPr>
-        <p:txBody>
-          <a:bodyPr wrap="square" lIns="0" tIns="0" rIns="0" bIns="0" rtlCol="0" anchor="t"/>
-          <a:lstStyle/>
-          <a:p>
-            <a:pPr indent="0" marL="0">
-              <a:buNone/>
-            </a:pPr>
-            <a:r>
-              <a:rPr lang="en-US" sz="1400" dirty="0">
-                <a:solidFill>
-                  <a:srgbClr val="595959"/>
-                </a:solidFill>
-                <a:latin typeface="Inter" pitchFamily="34" charset="0"/>
-                <a:ea typeface="Inter" pitchFamily="34" charset="-122"/>
-                <a:cs typeface="Inter" pitchFamily="34" charset="-120"/>
-              </a:rPr>
-              <a:t>Best combined month ever 4 times (Mar, Jun, Jul, Sep), now $593K. Service record 3 times. Parts record 2 times.</a:t>
-            </a:r>
-            <a:endParaRPr lang="en-US" sz="1400" dirty="0"/>
-          </a:p>
-        </p:txBody>
-      </p:sp>
-      <p:sp>
-        <p:nvSpPr>
-          <p:cNvPr id="14" name="Shape 12"/>
-          <p:cNvSpPr/>
-          <p:nvPr/>
-        </p:nvSpPr>
-        <p:spPr>
-          <a:xfrm>
-            <a:off x="8004048" y="1371600"/>
-            <a:ext cx="3526536" cy="1746504"/>
-          </a:xfrm>
-          <a:prstGeom prst="rect">
-            <a:avLst/>
-          </a:prstGeom>
-          <a:solidFill>
-            <a:srgbClr val="F7F7F7"/>
-          </a:solidFill>
-          <a:ln/>
-        </p:spPr>
-      </p:sp>
-      <p:sp>
-        <p:nvSpPr>
-          <p:cNvPr id="15" name="Shape 13"/>
-          <p:cNvSpPr/>
-          <p:nvPr/>
-        </p:nvSpPr>
-        <p:spPr>
-          <a:xfrm>
-            <a:off x="8004048" y="1371600"/>
-            <a:ext cx="54864" cy="1746504"/>
-          </a:xfrm>
-          <a:prstGeom prst="rect">
-            <a:avLst/>
-          </a:prstGeom>
-          <a:solidFill>
-            <a:srgbClr val="12A566"/>
-          </a:solidFill>
-          <a:ln/>
-        </p:spPr>
-      </p:sp>
-      <p:sp>
-        <p:nvSpPr>
-          <p:cNvPr id="16" name="Text 14"/>
-          <p:cNvSpPr txBox="1"/>
-          <p:nvPr/>
-        </p:nvSpPr>
-        <p:spPr>
-          <a:xfrm>
-            <a:off x="8186928" y="1463040"/>
-            <a:ext cx="3252216" cy="329184"/>
-          </a:xfrm>
-          <a:prstGeom prst="rect">
-            <a:avLst/>
-          </a:prstGeom>
-          <a:noFill/>
-          <a:ln/>
-        </p:spPr>
-        <p:txBody>
-          <a:bodyPr wrap="square" lIns="0" tIns="0" rIns="0" bIns="0" rtlCol="0" anchor="ctr"/>
-          <a:lstStyle/>
-          <a:p>
-            <a:pPr indent="0" marL="0">
-              <a:buNone/>
-            </a:pPr>
-            <a:r>
-              <a:rPr lang="en-US" sz="1700" b="1" dirty="0">
-                <a:solidFill>
-                  <a:srgbClr val="1A1A1A"/>
-                </a:solidFill>
-                <a:latin typeface="Inter" pitchFamily="34" charset="0"/>
-                <a:ea typeface="Inter" pitchFamily="34" charset="-122"/>
-                <a:cs typeface="Inter" pitchFamily="34" charset="-120"/>
-              </a:rPr>
-              <a:t>Toyota Henderson   </a:t>
-            </a:r>
-            <a:pPr indent="0" marL="0">
-              <a:buNone/>
-            </a:pPr>
-            <a:r>
-              <a:rPr lang="en-US" sz="1500" b="1" dirty="0">
-                <a:solidFill>
-                  <a:srgbClr val="0B7A4A"/>
-                </a:solidFill>
-                <a:latin typeface="Inter" pitchFamily="34" charset="0"/>
-                <a:ea typeface="Inter" pitchFamily="34" charset="-122"/>
-                <a:cs typeface="Inter" pitchFamily="34" charset="-120"/>
-              </a:rPr>
-              <a:t>8 records</a:t>
-            </a:r>
-            <a:endParaRPr lang="en-US" sz="1700" dirty="0"/>
-          </a:p>
-        </p:txBody>
-      </p:sp>
-      <p:sp>
-        <p:nvSpPr>
-          <p:cNvPr id="17" name="Text 15"/>
-          <p:cNvSpPr txBox="1"/>
-          <p:nvPr/>
-        </p:nvSpPr>
-        <p:spPr>
-          <a:xfrm>
-            <a:off x="8186928" y="1828800"/>
-            <a:ext cx="3252216" cy="1197864"/>
-          </a:xfrm>
-          <a:prstGeom prst="rect">
-            <a:avLst/>
-          </a:prstGeom>
-          <a:noFill/>
-          <a:ln/>
-        </p:spPr>
-        <p:txBody>
-          <a:bodyPr wrap="square" lIns="0" tIns="0" rIns="0" bIns="0" rtlCol="0" anchor="t"/>
-          <a:lstStyle/>
-          <a:p>
-            <a:pPr indent="0" marL="0">
-              <a:buNone/>
-            </a:pPr>
-            <a:r>
-              <a:rPr lang="en-US" sz="1400" dirty="0">
-                <a:solidFill>
-                  <a:srgbClr val="595959"/>
-                </a:solidFill>
-                <a:latin typeface="Inter" pitchFamily="34" charset="0"/>
-                <a:ea typeface="Inter" pitchFamily="34" charset="-122"/>
-                <a:cs typeface="Inter" pitchFamily="34" charset="-120"/>
-              </a:rPr>
-              <a:t>Best combined month ever 3 times (Apr, Jun, Jul), now $2.72M. Service record 2 times. Parts record 3 times.</a:t>
-            </a:r>
-            <a:endParaRPr lang="en-US" sz="1400" dirty="0"/>
-          </a:p>
-        </p:txBody>
-      </p:sp>
-      <p:sp>
-        <p:nvSpPr>
-          <p:cNvPr id="18" name="Shape 16"/>
-          <p:cNvSpPr/>
-          <p:nvPr/>
-        </p:nvSpPr>
-        <p:spPr>
-          <a:xfrm>
-            <a:off x="658368" y="3264408"/>
-            <a:ext cx="3526536" cy="1746504"/>
-          </a:xfrm>
-          <a:prstGeom prst="rect">
-            <a:avLst/>
-          </a:prstGeom>
-          <a:solidFill>
-            <a:srgbClr val="F7F7F7"/>
-          </a:solidFill>
-          <a:ln/>
-        </p:spPr>
-      </p:sp>
-      <p:sp>
-        <p:nvSpPr>
-          <p:cNvPr id="19" name="Shape 17"/>
-          <p:cNvSpPr/>
-          <p:nvPr/>
-        </p:nvSpPr>
-        <p:spPr>
-          <a:xfrm>
-            <a:off x="658368" y="3264408"/>
-            <a:ext cx="54864" cy="1746504"/>
-          </a:xfrm>
-          <a:prstGeom prst="rect">
-            <a:avLst/>
-          </a:prstGeom>
-          <a:solidFill>
-            <a:srgbClr val="12A566"/>
-          </a:solidFill>
-          <a:ln/>
-        </p:spPr>
-      </p:sp>
-      <p:sp>
-        <p:nvSpPr>
-          <p:cNvPr id="20" name="Text 18"/>
-          <p:cNvSpPr txBox="1"/>
-          <p:nvPr/>
-        </p:nvSpPr>
-        <p:spPr>
-          <a:xfrm>
-            <a:off x="841248" y="3355848"/>
-            <a:ext cx="3252216" cy="329184"/>
-          </a:xfrm>
-          <a:prstGeom prst="rect">
-            <a:avLst/>
-          </a:prstGeom>
-          <a:noFill/>
-          <a:ln/>
-        </p:spPr>
-        <p:txBody>
-          <a:bodyPr wrap="square" lIns="0" tIns="0" rIns="0" bIns="0" rtlCol="0" anchor="ctr"/>
-          <a:lstStyle/>
-          <a:p>
-            <a:pPr indent="0" marL="0">
-              <a:buNone/>
-            </a:pPr>
-            <a:r>
-              <a:rPr lang="en-US" sz="1700" b="1" dirty="0">
-                <a:solidFill>
-                  <a:srgbClr val="1A1A1A"/>
-                </a:solidFill>
-                <a:latin typeface="Inter" pitchFamily="34" charset="0"/>
-                <a:ea typeface="Inter" pitchFamily="34" charset="-122"/>
-                <a:cs typeface="Inter" pitchFamily="34" charset="-120"/>
-              </a:rPr>
-              <a:t>Honda Henderson   </a:t>
-            </a:r>
-            <a:pPr indent="0" marL="0">
-              <a:buNone/>
-            </a:pPr>
-            <a:r>
-              <a:rPr lang="en-US" sz="1500" b="1" dirty="0">
-                <a:solidFill>
-                  <a:srgbClr val="0B7A4A"/>
-                </a:solidFill>
-                <a:latin typeface="Inter" pitchFamily="34" charset="0"/>
-                <a:ea typeface="Inter" pitchFamily="34" charset="-122"/>
-                <a:cs typeface="Inter" pitchFamily="34" charset="-120"/>
-              </a:rPr>
-              <a:t>7 records</a:t>
-            </a:r>
-            <a:endParaRPr lang="en-US" sz="1700" dirty="0"/>
-          </a:p>
-        </p:txBody>
-      </p:sp>
-      <p:sp>
-        <p:nvSpPr>
-          <p:cNvPr id="21" name="Text 19"/>
-          <p:cNvSpPr txBox="1"/>
-          <p:nvPr/>
-        </p:nvSpPr>
-        <p:spPr>
-          <a:xfrm>
-            <a:off x="841248" y="3721608"/>
-            <a:ext cx="3252216" cy="1197864"/>
-          </a:xfrm>
-          <a:prstGeom prst="rect">
-            <a:avLst/>
-          </a:prstGeom>
-          <a:noFill/>
-          <a:ln/>
-        </p:spPr>
-        <p:txBody>
-          <a:bodyPr wrap="square" lIns="0" tIns="0" rIns="0" bIns="0" rtlCol="0" anchor="t"/>
-          <a:lstStyle/>
-          <a:p>
-            <a:pPr indent="0" marL="0">
-              <a:buNone/>
-            </a:pPr>
-            <a:r>
-              <a:rPr lang="en-US" sz="1400" dirty="0">
-                <a:solidFill>
-                  <a:srgbClr val="595959"/>
-                </a:solidFill>
-                <a:latin typeface="Inter" pitchFamily="34" charset="0"/>
-                <a:ea typeface="Inter" pitchFamily="34" charset="-122"/>
-                <a:cs typeface="Inter" pitchFamily="34" charset="-120"/>
-              </a:rPr>
-              <a:t>Best combined month ever 3 times (Mar, Jun, Jul), now $1.79M. Service record 3 times. Parts record in Jul.</a:t>
-            </a:r>
-            <a:endParaRPr lang="en-US" sz="1400" dirty="0"/>
-          </a:p>
-        </p:txBody>
-      </p:sp>
-      <p:sp>
-        <p:nvSpPr>
-          <p:cNvPr id="22" name="Shape 20"/>
-          <p:cNvSpPr/>
-          <p:nvPr/>
-        </p:nvSpPr>
-        <p:spPr>
-          <a:xfrm>
-            <a:off x="4331208" y="3264408"/>
-            <a:ext cx="3526536" cy="1746504"/>
-          </a:xfrm>
-          <a:prstGeom prst="rect">
-            <a:avLst/>
-          </a:prstGeom>
-          <a:solidFill>
-            <a:srgbClr val="F7F7F7"/>
-          </a:solidFill>
-          <a:ln/>
-        </p:spPr>
-      </p:sp>
-      <p:sp>
-        <p:nvSpPr>
-          <p:cNvPr id="23" name="Shape 21"/>
-          <p:cNvSpPr/>
-          <p:nvPr/>
-        </p:nvSpPr>
-        <p:spPr>
-          <a:xfrm>
-            <a:off x="4331208" y="3264408"/>
-            <a:ext cx="54864" cy="1746504"/>
-          </a:xfrm>
-          <a:prstGeom prst="rect">
-            <a:avLst/>
-          </a:prstGeom>
-          <a:solidFill>
-            <a:srgbClr val="12A566"/>
-          </a:solidFill>
-          <a:ln/>
-        </p:spPr>
-      </p:sp>
-      <p:sp>
-        <p:nvSpPr>
-          <p:cNvPr id="24" name="Text 22"/>
-          <p:cNvSpPr txBox="1"/>
-          <p:nvPr/>
-        </p:nvSpPr>
-        <p:spPr>
-          <a:xfrm>
-            <a:off x="4514088" y="3355848"/>
-            <a:ext cx="3252216" cy="329184"/>
-          </a:xfrm>
-          <a:prstGeom prst="rect">
-            <a:avLst/>
-          </a:prstGeom>
-          <a:noFill/>
-          <a:ln/>
-        </p:spPr>
-        <p:txBody>
-          <a:bodyPr wrap="square" lIns="0" tIns="0" rIns="0" bIns="0" rtlCol="0" anchor="ctr"/>
-          <a:lstStyle/>
-          <a:p>
-            <a:pPr indent="0" marL="0">
-              <a:buNone/>
-            </a:pPr>
-            <a:r>
-              <a:rPr lang="en-US" sz="1700" b="1" dirty="0">
-                <a:solidFill>
-                  <a:srgbClr val="1A1A1A"/>
-                </a:solidFill>
-                <a:latin typeface="Inter" pitchFamily="34" charset="0"/>
-                <a:ea typeface="Inter" pitchFamily="34" charset="-122"/>
-                <a:cs typeface="Inter" pitchFamily="34" charset="-120"/>
-              </a:rPr>
-              <a:t>Subaru St George   </a:t>
-            </a:r>
-            <a:pPr indent="0" marL="0">
-              <a:buNone/>
-            </a:pPr>
-            <a:r>
-              <a:rPr lang="en-US" sz="1500" b="1" dirty="0">
-                <a:solidFill>
-                  <a:srgbClr val="0B7A4A"/>
-                </a:solidFill>
-                <a:latin typeface="Inter" pitchFamily="34" charset="0"/>
-                <a:ea typeface="Inter" pitchFamily="34" charset="-122"/>
-                <a:cs typeface="Inter" pitchFamily="34" charset="-120"/>
-              </a:rPr>
-              <a:t>7 records</a:t>
-            </a:r>
-            <a:endParaRPr lang="en-US" sz="1700" dirty="0"/>
-          </a:p>
-        </p:txBody>
-      </p:sp>
-      <p:sp>
-        <p:nvSpPr>
-          <p:cNvPr id="25" name="Text 23"/>
-          <p:cNvSpPr txBox="1"/>
-          <p:nvPr/>
-        </p:nvSpPr>
-        <p:spPr>
-          <a:xfrm>
-            <a:off x="4514088" y="3721608"/>
-            <a:ext cx="3252216" cy="1197864"/>
-          </a:xfrm>
-          <a:prstGeom prst="rect">
-            <a:avLst/>
-          </a:prstGeom>
-          <a:noFill/>
-          <a:ln/>
-        </p:spPr>
-        <p:txBody>
-          <a:bodyPr wrap="square" lIns="0" tIns="0" rIns="0" bIns="0" rtlCol="0" anchor="t"/>
-          <a:lstStyle/>
-          <a:p>
-            <a:pPr indent="0" marL="0">
-              <a:buNone/>
-            </a:pPr>
-            <a:r>
-              <a:rPr lang="en-US" sz="1400" dirty="0">
-                <a:solidFill>
-                  <a:srgbClr val="595959"/>
-                </a:solidFill>
-                <a:latin typeface="Inter" pitchFamily="34" charset="0"/>
-                <a:ea typeface="Inter" pitchFamily="34" charset="-122"/>
-                <a:cs typeface="Inter" pitchFamily="34" charset="-120"/>
-              </a:rPr>
-              <a:t>Best combined month ever 2 times (Mar, Jun), now $438K. Service record 2 times. Parts record 3 times.</a:t>
-            </a:r>
-            <a:endParaRPr lang="en-US" sz="1400" dirty="0"/>
-          </a:p>
-        </p:txBody>
-      </p:sp>
-      <p:sp>
-        <p:nvSpPr>
-          <p:cNvPr id="26" name="Shape 24"/>
-          <p:cNvSpPr/>
-          <p:nvPr/>
-        </p:nvSpPr>
-        <p:spPr>
-          <a:xfrm>
-            <a:off x="8004048" y="3264408"/>
-            <a:ext cx="3526536" cy="1746504"/>
-          </a:xfrm>
-          <a:prstGeom prst="rect">
-            <a:avLst/>
-          </a:prstGeom>
-          <a:solidFill>
-            <a:srgbClr val="F7F7F7"/>
-          </a:solidFill>
-          <a:ln/>
-        </p:spPr>
-      </p:sp>
-      <p:sp>
-        <p:nvSpPr>
-          <p:cNvPr id="27" name="Shape 25"/>
-          <p:cNvSpPr/>
-          <p:nvPr/>
-        </p:nvSpPr>
-        <p:spPr>
-          <a:xfrm>
-            <a:off x="8004048" y="3264408"/>
-            <a:ext cx="54864" cy="1746504"/>
-          </a:xfrm>
-          <a:prstGeom prst="rect">
-            <a:avLst/>
-          </a:prstGeom>
-          <a:solidFill>
-            <a:srgbClr val="12A566"/>
-          </a:solidFill>
-          <a:ln/>
-        </p:spPr>
-      </p:sp>
-      <p:sp>
-        <p:nvSpPr>
-          <p:cNvPr id="28" name="Text 26"/>
-          <p:cNvSpPr txBox="1"/>
-          <p:nvPr/>
-        </p:nvSpPr>
-        <p:spPr>
-          <a:xfrm>
-            <a:off x="8186928" y="3355848"/>
-            <a:ext cx="3252216" cy="329184"/>
-          </a:xfrm>
-          <a:prstGeom prst="rect">
-            <a:avLst/>
-          </a:prstGeom>
-          <a:noFill/>
-          <a:ln/>
-        </p:spPr>
-        <p:txBody>
-          <a:bodyPr wrap="square" lIns="0" tIns="0" rIns="0" bIns="0" rtlCol="0" anchor="ctr"/>
-          <a:lstStyle/>
-          <a:p>
-            <a:pPr indent="0" marL="0">
-              <a:buNone/>
-            </a:pPr>
-            <a:r>
-              <a:rPr lang="en-US" sz="1700" b="1" dirty="0">
-                <a:solidFill>
-                  <a:srgbClr val="1A1A1A"/>
-                </a:solidFill>
-                <a:latin typeface="Inter" pitchFamily="34" charset="0"/>
-                <a:ea typeface="Inter" pitchFamily="34" charset="-122"/>
-                <a:cs typeface="Inter" pitchFamily="34" charset="-120"/>
-              </a:rPr>
-              <a:t>Hyundai Prescott   </a:t>
-            </a:r>
-            <a:pPr indent="0" marL="0">
-              <a:buNone/>
-            </a:pPr>
-            <a:r>
-              <a:rPr lang="en-US" sz="1500" b="1" dirty="0">
-                <a:solidFill>
-                  <a:srgbClr val="0B7A4A"/>
-                </a:solidFill>
-                <a:latin typeface="Inter" pitchFamily="34" charset="0"/>
-                <a:ea typeface="Inter" pitchFamily="34" charset="-122"/>
-                <a:cs typeface="Inter" pitchFamily="34" charset="-120"/>
-              </a:rPr>
-              <a:t>6 records</a:t>
-            </a:r>
-            <a:endParaRPr lang="en-US" sz="1700" dirty="0"/>
-          </a:p>
-        </p:txBody>
-      </p:sp>
-      <p:sp>
-        <p:nvSpPr>
-          <p:cNvPr id="29" name="Text 27"/>
-          <p:cNvSpPr txBox="1"/>
-          <p:nvPr/>
-        </p:nvSpPr>
-        <p:spPr>
-          <a:xfrm>
-            <a:off x="8186928" y="3721608"/>
-            <a:ext cx="3252216" cy="1197864"/>
-          </a:xfrm>
-          <a:prstGeom prst="rect">
-            <a:avLst/>
-          </a:prstGeom>
-          <a:noFill/>
-          <a:ln/>
-        </p:spPr>
-        <p:txBody>
-          <a:bodyPr wrap="square" lIns="0" tIns="0" rIns="0" bIns="0" rtlCol="0" anchor="t"/>
-          <a:lstStyle/>
-          <a:p>
-            <a:pPr indent="0" marL="0">
-              <a:buNone/>
-            </a:pPr>
-            <a:r>
-              <a:rPr lang="en-US" sz="1400" dirty="0">
-                <a:solidFill>
-                  <a:srgbClr val="595959"/>
-                </a:solidFill>
-                <a:latin typeface="Inter" pitchFamily="34" charset="0"/>
-                <a:ea typeface="Inter" pitchFamily="34" charset="-122"/>
-                <a:cs typeface="Inter" pitchFamily="34" charset="-120"/>
-              </a:rPr>
-              <a:t>Best combined month ever 3 times (Feb, Mar, Jul), now $206K. Service record 2 times. Parts record in Feb.</a:t>
-            </a:r>
-            <a:endParaRPr lang="en-US" sz="1400" dirty="0"/>
-          </a:p>
-        </p:txBody>
-      </p:sp>
-      <p:sp>
-        <p:nvSpPr>
-          <p:cNvPr id="30" name="Text 28"/>
-          <p:cNvSpPr txBox="1"/>
-          <p:nvPr/>
-        </p:nvSpPr>
-        <p:spPr>
-          <a:xfrm>
-            <a:off x="658368" y="5202936"/>
-            <a:ext cx="10881360" cy="713232"/>
-          </a:xfrm>
-          <a:prstGeom prst="rect">
-            <a:avLst/>
-          </a:prstGeom>
-          <a:noFill/>
-          <a:ln/>
-        </p:spPr>
-        <p:txBody>
-          <a:bodyPr wrap="square" lIns="0" tIns="0" rIns="0" bIns="0" rtlCol="0" anchor="ctr"/>
-          <a:lstStyle/>
-          <a:p>
-            <a:pPr indent="0" marL="0">
-              <a:buNone/>
-            </a:pPr>
-            <a:r>
-              <a:rPr lang="en-US" sz="1400" b="1" dirty="0">
-                <a:solidFill>
-                  <a:srgbClr val="1A1A1A"/>
-                </a:solidFill>
-                <a:latin typeface="Inter" pitchFamily="34" charset="0"/>
-                <a:ea typeface="Inter" pitchFamily="34" charset="-122"/>
-                <a:cs typeface="Inter" pitchFamily="34" charset="-120"/>
-              </a:rPr>
-              <a:t>Also set records: </a:t>
-            </a:r>
-            <a:pPr indent="0" marL="0">
-              <a:buNone/>
-            </a:pPr>
-            <a:r>
-              <a:rPr lang="en-US" sz="1400" dirty="0">
-                <a:solidFill>
-                  <a:srgbClr val="595959"/>
-                </a:solidFill>
-                <a:latin typeface="Inter" pitchFamily="34" charset="0"/>
-                <a:ea typeface="Inter" pitchFamily="34" charset="-122"/>
-                <a:cs typeface="Inter" pitchFamily="34" charset="-120"/>
-              </a:rPr>
-              <a:t>Lincoln (6), Mazda (5), Kia St George (4), Lexus (4), LR Henderson (4), Toyota Flagstaff (4), Toyota Prescott (4), Hyundai St George (4), Audi Henderson (3), CDJR Post Falls (2), GMC Prescott (2), LR LV (2), LR Reno (2), Toyota Spokane (2), Volvo (2), Subaru Prescott (1), Kia LV (1)</a:t>
-            </a:r>
-            <a:endParaRPr lang="en-US" sz="1400" dirty="0"/>
-          </a:p>
-        </p:txBody>
-      </p:sp>
-      <p:sp>
-        <p:nvSpPr>
-          <p:cNvPr id="31" name="Shape 29"/>
-          <p:cNvSpPr/>
-          <p:nvPr/>
-        </p:nvSpPr>
-        <p:spPr>
-          <a:xfrm>
-            <a:off x="457200" y="6126480"/>
-            <a:ext cx="11274552" cy="371856"/>
-          </a:xfrm>
-          <a:prstGeom prst="rect">
-            <a:avLst/>
-          </a:prstGeom>
-          <a:solidFill>
-            <a:srgbClr val="E6F6EE"/>
-          </a:solidFill>
-          <a:ln/>
-        </p:spPr>
-      </p:sp>
-      <p:sp>
-        <p:nvSpPr>
-          <p:cNvPr id="32" name="Text 30"/>
-          <p:cNvSpPr txBox="1"/>
-          <p:nvPr/>
-        </p:nvSpPr>
-        <p:spPr>
-          <a:xfrm>
-            <a:off x="658368" y="6144768"/>
-            <a:ext cx="10927080" cy="335280"/>
-          </a:xfrm>
-          <a:prstGeom prst="rect">
-            <a:avLst/>
-          </a:prstGeom>
-          <a:noFill/>
-          <a:ln/>
-        </p:spPr>
-        <p:txBody>
-          <a:bodyPr wrap="square" lIns="0" tIns="0" rIns="0" bIns="0" rtlCol="0" anchor="ctr"/>
-          <a:lstStyle/>
-          <a:p>
-            <a:pPr indent="0" marL="0">
-              <a:buNone/>
-            </a:pPr>
-            <a:r>
-              <a:rPr lang="en-US" sz="1600" b="1" dirty="0">
-                <a:solidFill>
-                  <a:srgbClr val="0B7A4A"/>
-                </a:solidFill>
-                <a:latin typeface="Inter" pitchFamily="34" charset="0"/>
-                <a:ea typeface="Inter" pitchFamily="34" charset="-122"/>
-                <a:cs typeface="Inter" pitchFamily="34" charset="-120"/>
-              </a:rPr>
-              <a:t>Ask Honda Spokane, Nissan and Toyota Henderson what changed this year.</a:t>
-            </a:r>
-            <a:endParaRPr lang="en-US" sz="1600" dirty="0"/>
-          </a:p>
-        </p:txBody>
-      </p:sp>
-    </p:spTree>
-  </p:cSld>
-  <p:clrMapOvr>
-    <a:masterClrMapping/>
-  </p:clrMapOvr>
-</p:sld>
-</file>
-
 <file path=ppt/theme/theme1.xml><?xml version="1.0" encoding="utf-8"?>
 <a:theme xmlns:a="http://schemas.openxmlformats.org/drawingml/2006/main" name="Office Theme">
   <a:themeElements>

</xml_diff>

<commit_message>
Records with net profit in the deck (three slides)
Co-Authored-By: Claude Opus 5.5 <noreply@anthropic.com>
Claude-Session: https://claude.ai/code/session_01Xa4nFVxuQGXmHARGph9WhS
</commit_message>
<xml_diff>
--- a/day2-deck/decks/Store Records - Opening.pptx
+++ b/day2-deck/decks/Store Records - Opening.pptx
@@ -7,9 +7,10 @@
   <p:sldIdLst>
     <p:sldId id="256" r:id="rId2"/>
     <p:sldId id="257" r:id="rId3"/>
+    <p:sldId id="258" r:id="rId4"/>
   </p:sldIdLst>
   <p:notesMasterIdLst>
-    <p:notesMasterId r:id="rId4"/>
+    <p:notesMasterId r:id="rId5"/>
   </p:notesMasterIdLst>
   <p:sldSz cx="12192000" cy="6858000"/>
   <p:notesSz cx="6858000" cy="12192000"/>
@@ -503,7 +504,7 @@
           <a:p>
             <a:r>
               <a:rPr lang="en-US" dirty="0"/>
-              <a:t>Source: Qlik - Fixed Ops Accounting TB, fixed gross (service and parts), monthly by store, January 2021 - September 2026. A record = the store's highest month on file; months before a store opened are ignored. GMC Prescott service on the TB includes body shop gross.</a:t>
+              <a:t>Source: Qlik - Fixed Ops Accounting TB, fixed gross (service and parts), monthly by store, January 2021 - September 2026. A record = the store's highest month on file; months before a store opened are ignored. GMC Prescott service on the TB includes body shop gross. Net: best January–September fixed ops net profit ever = service + parts department profit (Qlik - Profit &amp; Loss, Detail statement), Jan-Sep 2026 above every Jan-Sep 2021-2025 on file; Honda Spokane and Nissan from 2024.</a:t>
             </a:r>
             <a:endParaRPr lang="en-US" dirty="0"/>
           </a:p>
@@ -638,6 +639,115 @@
             <a:fld id="{F7021451-1387-4CA6-816F-3879F97B5CBC}" type="slidenum">
               <a:rPr lang="en-US"/>
               <a:t>2</a:t>
+            </a:fld>
+            <a:endParaRPr lang="en-US"/>
+          </a:p>
+        </p:txBody>
+      </p:sp>
+    </p:spTree>
+    <p:extLst>
+      <p:ext uri="{BB962C8B-B14F-4D97-AF65-F5344CB8AC3E}">
+        <p14:creationId xmlns:p14="http://schemas.microsoft.com/office/powerpoint/2010/main" val="1024086991"/>
+      </p:ext>
+    </p:extLst>
+  </p:cSld>
+  <p:clrMapOvr>
+    <a:masterClrMapping/>
+  </p:clrMapOvr>
+</p:notes>
+</file>
+
+<file path=ppt/notesSlides/notesSlide3.xml><?xml version="1.0" encoding="utf-8"?>
+<p:notes xmlns:a="http://schemas.openxmlformats.org/drawingml/2006/main" xmlns:r="http://schemas.openxmlformats.org/officeDocument/2006/relationships" xmlns:p="http://schemas.openxmlformats.org/presentationml/2006/main">
+  <p:cSld>
+    <p:spTree>
+      <p:nvGrpSpPr>
+        <p:cNvPr id="1" name=""/>
+        <p:cNvGrpSpPr/>
+        <p:nvPr/>
+      </p:nvGrpSpPr>
+      <p:grpSpPr>
+        <a:xfrm>
+          <a:off x="0" y="0"/>
+          <a:ext cx="0" cy="0"/>
+          <a:chOff x="0" y="0"/>
+          <a:chExt cx="0" cy="0"/>
+        </a:xfrm>
+      </p:grpSpPr>
+      <p:sp>
+        <p:nvSpPr>
+          <p:cNvPr id="2" name="Slide Image Placeholder 1"/>
+          <p:cNvSpPr>
+            <a:spLocks noGrp="1" noRot="1" noChangeAspect="1"/>
+          </p:cNvSpPr>
+          <p:nvPr>
+            <p:ph type="sldImg"/>
+          </p:nvPr>
+        </p:nvSpPr>
+        <p:spPr/>
+      </p:sp>
+      <p:sp>
+        <p:nvSpPr>
+          <p:cNvPr id="3" name="Notes Placeholder 2"/>
+          <p:cNvSpPr>
+            <a:spLocks noGrp="1"/>
+          </p:cNvSpPr>
+          <p:nvPr>
+            <p:ph type="body" idx="1"/>
+          </p:nvPr>
+        </p:nvSpPr>
+        <p:spPr/>
+        <p:txBody>
+          <a:bodyPr/>
+          <a:lstStyle/>
+          <a:p>
+            <a:r>
+              <a:rPr lang="en-US" dirty="0"/>
+              <a:t>Source: Gross: Qlik - Fixed Ops Accounting TB, combined service + parts fixed gross, Jan-Sep 2026 above every Jan-Sep on file (2021-2025). Net: best January–September fixed ops net profit ever = service + parts department profit (Qlik - Profit &amp; Loss, Detail statement), Jan-Sep 2026 above every Jan-Sep 2021-2025 on file; Honda Spokane and Nissan from 2024.Net profit, Jan-Sep 2026 vs the best prior Jan-Sep:
+Acura: $476K vs $259K (2025)
+Audi Henderson: $4.94M vs $4.11M (2025)
+Cadillac: $2.60M vs $1.83M (2025)
+CDJR Post Falls: $800K vs $747K (2025)
+Chevy GMC Bullhead: $1.12M vs $784K (2025)
+Honda Henderson: $6.08M vs $5.84M (2024)
+Honda Spokane: $1.32M vs $1.32M (2025)
+Kia LV: $1.80M vs $1.38M (2025)
+Lexus: $1.20M vs $993K (2025)
+Lincoln: $94K vs −$61K (2023)
+LR Henderson: $705K vs $607K (2025)
+LR LV: $2.04M vs $1.89M (2025)
+LR Reno: $428K vs $244K (2023)
+Nissan: $677K vs $543K (2025)
+Subaru LV: $2.94M vs $2.93M (2025)
+Subaru Prescott: $129K vs $110K (2023)
+Subaru St George: $1.17M vs $1.06M (2025)
+Toyota Flagstaff: $902K vs $771K (2025)
+Toyota Henderson: $7.83M vs $6.41M (2025)
+Toyota Prescott: $1.17M vs $881K (2025)
+Volvo: $1.33M vs $1.18M (2025)</a:t>
+            </a:r>
+            <a:endParaRPr lang="en-US" dirty="0"/>
+          </a:p>
+        </p:txBody>
+      </p:sp>
+      <p:sp>
+        <p:nvSpPr>
+          <p:cNvPr id="4" name="Slide Number Placeholder 3"/>
+          <p:cNvSpPr>
+            <a:spLocks noGrp="1"/>
+          </p:cNvSpPr>
+          <p:nvPr>
+            <p:ph type="sldNum" sz="quarter" idx="10"/>
+          </p:nvPr>
+        </p:nvSpPr>
+        <p:spPr/>
+        <p:txBody>
+          <a:bodyPr/>
+          <a:lstStyle/>
+          <a:p>
+            <a:fld id="{F7021451-1387-4CA6-816F-3879F97B5CBC}" type="slidenum">
+              <a:rPr lang="en-US"/>
+              <a:t>3</a:t>
             </a:fld>
             <a:endParaRPr lang="en-US"/>
           </a:p>
@@ -1114,7 +1224,7 @@
         <p:spPr>
           <a:xfrm>
             <a:off x="713232" y="1481328"/>
-            <a:ext cx="2539746" cy="3017520"/>
+            <a:ext cx="1991563" cy="3017520"/>
           </a:xfrm>
           <a:prstGeom prst="rect">
             <a:avLst/>
@@ -1134,7 +1244,7 @@
         <p:spPr>
           <a:xfrm>
             <a:off x="713232" y="1481328"/>
-            <a:ext cx="2539746" cy="64008"/>
+            <a:ext cx="1991563" cy="64008"/>
           </a:xfrm>
           <a:prstGeom prst="rect">
             <a:avLst/>
@@ -1154,7 +1264,7 @@
         <p:spPr>
           <a:xfrm>
             <a:off x="896112" y="1691640"/>
-            <a:ext cx="2173986" cy="566928"/>
+            <a:ext cx="1625803" cy="566928"/>
           </a:xfrm>
           <a:prstGeom prst="rect">
             <a:avLst/>
@@ -1178,7 +1288,7 @@
                 <a:ea typeface="Inter" pitchFamily="34" charset="-122"/>
                 <a:cs typeface="Inter" pitchFamily="34" charset="-120"/>
               </a:rPr>
-              <a:t>STORES WITH ALL-TIME RECORD MONTHS</a:t>
+              <a:t>STORES WITH A RECORD MONTH</a:t>
             </a:r>
             <a:endParaRPr lang="en-US" sz="1400" dirty="0"/>
           </a:p>
@@ -1193,7 +1303,7 @@
         <p:spPr>
           <a:xfrm>
             <a:off x="896112" y="2286000"/>
-            <a:ext cx="2173986" cy="868680"/>
+            <a:ext cx="1625803" cy="868680"/>
           </a:xfrm>
           <a:prstGeom prst="rect">
             <a:avLst/>
@@ -1234,7 +1344,7 @@
         <p:spPr>
           <a:xfrm>
             <a:off x="896112" y="3200400"/>
-            <a:ext cx="2173986" cy="1188720"/>
+            <a:ext cx="1625803" cy="1188720"/>
           </a:xfrm>
           <a:prstGeom prst="rect">
             <a:avLst/>
@@ -1258,7 +1368,7 @@
                 <a:ea typeface="Inter" pitchFamily="34" charset="-122"/>
                 <a:cs typeface="Inter" pitchFamily="34" charset="-120"/>
               </a:rPr>
-              <a:t>of 33 set their best month ever in service, parts or combined during 2026.</a:t>
+              <a:t>of 33 had their best gross profit month ever in 2026.</a:t>
             </a:r>
             <a:endParaRPr lang="en-US" sz="1500" dirty="0"/>
           </a:p>
@@ -1272,8 +1382,8 @@
         </p:nvSpPr>
         <p:spPr>
           <a:xfrm>
-            <a:off x="3454146" y="1481328"/>
-            <a:ext cx="2539746" cy="3017520"/>
+            <a:off x="2905963" y="1481328"/>
+            <a:ext cx="1991563" cy="3017520"/>
           </a:xfrm>
           <a:prstGeom prst="rect">
             <a:avLst/>
@@ -1292,8 +1402,8 @@
         </p:nvSpPr>
         <p:spPr>
           <a:xfrm>
-            <a:off x="3454146" y="1481328"/>
-            <a:ext cx="2539746" cy="64008"/>
+            <a:off x="2905963" y="1481328"/>
+            <a:ext cx="1991563" cy="64008"/>
           </a:xfrm>
           <a:prstGeom prst="rect">
             <a:avLst/>
@@ -1312,8 +1422,8 @@
         </p:nvSpPr>
         <p:spPr>
           <a:xfrm>
-            <a:off x="3637026" y="1691640"/>
-            <a:ext cx="2173986" cy="566928"/>
+            <a:off x="3088843" y="1691640"/>
+            <a:ext cx="1625803" cy="566928"/>
           </a:xfrm>
           <a:prstGeom prst="rect">
             <a:avLst/>
@@ -1337,7 +1447,7 @@
                 <a:ea typeface="Inter" pitchFamily="34" charset="-122"/>
                 <a:cs typeface="Inter" pitchFamily="34" charset="-120"/>
               </a:rPr>
-              <a:t>STORE RECORDS SET</a:t>
+              <a:t>RECORDS SET</a:t>
             </a:r>
             <a:endParaRPr lang="en-US" sz="1400" dirty="0"/>
           </a:p>
@@ -1351,8 +1461,8 @@
         </p:nvSpPr>
         <p:spPr>
           <a:xfrm>
-            <a:off x="3637026" y="2286000"/>
-            <a:ext cx="2173986" cy="868680"/>
+            <a:off x="3088843" y="2286000"/>
+            <a:ext cx="1625803" cy="868680"/>
           </a:xfrm>
           <a:prstGeom prst="rect">
             <a:avLst/>
@@ -1392,8 +1502,8 @@
         </p:nvSpPr>
         <p:spPr>
           <a:xfrm>
-            <a:off x="3637026" y="3200400"/>
-            <a:ext cx="2173986" cy="1188720"/>
+            <a:off x="3088843" y="3200400"/>
+            <a:ext cx="1625803" cy="1188720"/>
           </a:xfrm>
           <a:prstGeom prst="rect">
             <a:avLst/>
@@ -1417,7 +1527,7 @@
                 <a:ea typeface="Inter" pitchFamily="34" charset="-122"/>
                 <a:cs typeface="Inter" pitchFamily="34" charset="-120"/>
               </a:rPr>
-              <a:t>all-time monthly records across those stores: service, parts and combined counted separately.</a:t>
+              <a:t>gross profit records in service, parts and combined.</a:t>
             </a:r>
             <a:endParaRPr lang="en-US" sz="1500" dirty="0"/>
           </a:p>
@@ -1431,8 +1541,8 @@
         </p:nvSpPr>
         <p:spPr>
           <a:xfrm>
-            <a:off x="6195060" y="1481328"/>
-            <a:ext cx="2539746" cy="3017520"/>
+            <a:off x="5098694" y="1481328"/>
+            <a:ext cx="1991563" cy="3017520"/>
           </a:xfrm>
           <a:prstGeom prst="rect">
             <a:avLst/>
@@ -1451,8 +1561,8 @@
         </p:nvSpPr>
         <p:spPr>
           <a:xfrm>
-            <a:off x="6195060" y="1481328"/>
-            <a:ext cx="2539746" cy="64008"/>
+            <a:off x="5098694" y="1481328"/>
+            <a:ext cx="1991563" cy="64008"/>
           </a:xfrm>
           <a:prstGeom prst="rect">
             <a:avLst/>
@@ -1471,8 +1581,8 @@
         </p:nvSpPr>
         <p:spPr>
           <a:xfrm>
-            <a:off x="6377940" y="1691640"/>
-            <a:ext cx="2173986" cy="566928"/>
+            <a:off x="5281574" y="1691640"/>
+            <a:ext cx="1625803" cy="566928"/>
           </a:xfrm>
           <a:prstGeom prst="rect">
             <a:avLst/>
@@ -1496,7 +1606,7 @@
                 <a:ea typeface="Inter" pitchFamily="34" charset="-122"/>
                 <a:cs typeface="Inter" pitchFamily="34" charset="-120"/>
               </a:rPr>
-              <a:t>BEST JANUARY–SEPTEMBER EVER</a:t>
+              <a:t>BEST JAN–SEP GROSS PROFIT EVER</a:t>
             </a:r>
             <a:endParaRPr lang="en-US" sz="1400" dirty="0"/>
           </a:p>
@@ -1510,8 +1620,8 @@
         </p:nvSpPr>
         <p:spPr>
           <a:xfrm>
-            <a:off x="6377940" y="2286000"/>
-            <a:ext cx="2173986" cy="868680"/>
+            <a:off x="5281574" y="2286000"/>
+            <a:ext cx="1625803" cy="868680"/>
           </a:xfrm>
           <a:prstGeom prst="rect">
             <a:avLst/>
@@ -1551,8 +1661,8 @@
         </p:nvSpPr>
         <p:spPr>
           <a:xfrm>
-            <a:off x="6377940" y="3200400"/>
-            <a:ext cx="2173986" cy="1188720"/>
+            <a:off x="5281574" y="3200400"/>
+            <a:ext cx="1625803" cy="1188720"/>
           </a:xfrm>
           <a:prstGeom prst="rect">
             <a:avLst/>
@@ -1576,7 +1686,7 @@
                 <a:ea typeface="Inter" pitchFamily="34" charset="-122"/>
                 <a:cs typeface="Inter" pitchFamily="34" charset="-120"/>
               </a:rPr>
-              <a:t>stores had their best January–September ever in combined fixed gross.</a:t>
+              <a:t>stores, service and parts combined.</a:t>
             </a:r>
             <a:endParaRPr lang="en-US" sz="1500" dirty="0"/>
           </a:p>
@@ -1590,8 +1700,8 @@
         </p:nvSpPr>
         <p:spPr>
           <a:xfrm>
-            <a:off x="8935974" y="1481328"/>
-            <a:ext cx="2539746" cy="3017520"/>
+            <a:off x="7291426" y="1481328"/>
+            <a:ext cx="1991563" cy="3017520"/>
           </a:xfrm>
           <a:prstGeom prst="rect">
             <a:avLst/>
@@ -1610,8 +1720,8 @@
         </p:nvSpPr>
         <p:spPr>
           <a:xfrm>
-            <a:off x="8935974" y="1481328"/>
-            <a:ext cx="2539746" cy="64008"/>
+            <a:off x="7291426" y="1481328"/>
+            <a:ext cx="1991563" cy="64008"/>
           </a:xfrm>
           <a:prstGeom prst="rect">
             <a:avLst/>
@@ -1630,8 +1740,8 @@
         </p:nvSpPr>
         <p:spPr>
           <a:xfrm>
-            <a:off x="9118854" y="1691640"/>
-            <a:ext cx="2173986" cy="566928"/>
+            <a:off x="7474306" y="1691640"/>
+            <a:ext cx="1625803" cy="566928"/>
           </a:xfrm>
           <a:prstGeom prst="rect">
             <a:avLst/>
@@ -1655,7 +1765,7 @@
                 <a:ea typeface="Inter" pitchFamily="34" charset="-122"/>
                 <a:cs typeface="Inter" pitchFamily="34" charset="-120"/>
               </a:rPr>
-              <a:t>STORES WHO SET A RECORD AND THEN RESET IT</a:t>
+              <a:t>RECORDS BROKEN TWICE</a:t>
             </a:r>
             <a:endParaRPr lang="en-US" sz="1400" dirty="0"/>
           </a:p>
@@ -1669,8 +1779,8 @@
         </p:nvSpPr>
         <p:spPr>
           <a:xfrm>
-            <a:off x="9118854" y="2286000"/>
-            <a:ext cx="2173986" cy="868680"/>
+            <a:off x="7474306" y="2286000"/>
+            <a:ext cx="1625803" cy="868680"/>
           </a:xfrm>
           <a:prstGeom prst="rect">
             <a:avLst/>
@@ -1710,8 +1820,8 @@
         </p:nvSpPr>
         <p:spPr>
           <a:xfrm>
-            <a:off x="9118854" y="3200400"/>
-            <a:ext cx="2173986" cy="1188720"/>
+            <a:off x="7474306" y="3200400"/>
+            <a:ext cx="1625803" cy="1188720"/>
           </a:xfrm>
           <a:prstGeom prst="rect">
             <a:avLst/>
@@ -1735,7 +1845,7 @@
                 <a:ea typeface="Inter" pitchFamily="34" charset="-122"/>
                 <a:cs typeface="Inter" pitchFamily="34" charset="-120"/>
               </a:rPr>
-              <a:t>stores set a record and then topped it again later in the year.</a:t>
+              <a:t>stores set a gross profit record, then beat it again.</a:t>
             </a:r>
             <a:endParaRPr lang="en-US" sz="1500" dirty="0"/>
           </a:p>
@@ -1743,7 +1853,166 @@
       </p:sp>
       <p:sp>
         <p:nvSpPr>
-          <p:cNvPr id="26" name="Text 24"/>
+          <p:cNvPr id="26" name="Shape 24"/>
+          <p:cNvSpPr/>
+          <p:nvPr/>
+        </p:nvSpPr>
+        <p:spPr>
+          <a:xfrm>
+            <a:off x="9484157" y="1481328"/>
+            <a:ext cx="1991563" cy="3017520"/>
+          </a:xfrm>
+          <a:prstGeom prst="rect">
+            <a:avLst/>
+          </a:prstGeom>
+          <a:solidFill>
+            <a:srgbClr val="F7F7F7"/>
+          </a:solidFill>
+          <a:ln/>
+        </p:spPr>
+      </p:sp>
+      <p:sp>
+        <p:nvSpPr>
+          <p:cNvPr id="27" name="Shape 25"/>
+          <p:cNvSpPr/>
+          <p:nvPr/>
+        </p:nvSpPr>
+        <p:spPr>
+          <a:xfrm>
+            <a:off x="9484157" y="1481328"/>
+            <a:ext cx="1991563" cy="64008"/>
+          </a:xfrm>
+          <a:prstGeom prst="rect">
+            <a:avLst/>
+          </a:prstGeom>
+          <a:solidFill>
+            <a:srgbClr val="12A566"/>
+          </a:solidFill>
+          <a:ln/>
+        </p:spPr>
+      </p:sp>
+      <p:sp>
+        <p:nvSpPr>
+          <p:cNvPr id="28" name="Text 26"/>
+          <p:cNvSpPr txBox="1"/>
+          <p:nvPr/>
+        </p:nvSpPr>
+        <p:spPr>
+          <a:xfrm>
+            <a:off x="9667037" y="1691640"/>
+            <a:ext cx="1625803" cy="566928"/>
+          </a:xfrm>
+          <a:prstGeom prst="rect">
+            <a:avLst/>
+          </a:prstGeom>
+          <a:noFill/>
+          <a:ln/>
+        </p:spPr>
+        <p:txBody>
+          <a:bodyPr wrap="square" lIns="0" tIns="0" rIns="0" bIns="0" rtlCol="0" anchor="t"/>
+          <a:lstStyle/>
+          <a:p>
+            <a:pPr indent="0" marL="0">
+              <a:buNone/>
+            </a:pPr>
+            <a:r>
+              <a:rPr lang="en-US" sz="1400" b="1" spc="80" kern="0" dirty="0">
+                <a:solidFill>
+                  <a:srgbClr val="595959"/>
+                </a:solidFill>
+                <a:latin typeface="Inter" pitchFamily="34" charset="0"/>
+                <a:ea typeface="Inter" pitchFamily="34" charset="-122"/>
+                <a:cs typeface="Inter" pitchFamily="34" charset="-120"/>
+              </a:rPr>
+              <a:t>BEST JAN–SEP NET PROFIT EVER</a:t>
+            </a:r>
+            <a:endParaRPr lang="en-US" sz="1400" dirty="0"/>
+          </a:p>
+        </p:txBody>
+      </p:sp>
+      <p:sp>
+        <p:nvSpPr>
+          <p:cNvPr id="29" name="Text 27"/>
+          <p:cNvSpPr txBox="1"/>
+          <p:nvPr/>
+        </p:nvSpPr>
+        <p:spPr>
+          <a:xfrm>
+            <a:off x="9667037" y="2286000"/>
+            <a:ext cx="1625803" cy="868680"/>
+          </a:xfrm>
+          <a:prstGeom prst="rect">
+            <a:avLst/>
+          </a:prstGeom>
+          <a:noFill/>
+          <a:ln/>
+        </p:spPr>
+        <p:txBody>
+          <a:bodyPr wrap="square" lIns="0" tIns="0" rIns="0" bIns="0" rtlCol="0" anchor="ctr">
+            <a:normAutofit/>
+          </a:bodyPr>
+          <a:lstStyle/>
+          <a:p>
+            <a:pPr indent="0" marL="0">
+              <a:buNone/>
+            </a:pPr>
+            <a:r>
+              <a:rPr lang="en-US" sz="4000" b="1" dirty="0">
+                <a:solidFill>
+                  <a:srgbClr val="0B7A4A"/>
+                </a:solidFill>
+                <a:latin typeface="Inter" pitchFamily="34" charset="0"/>
+                <a:ea typeface="Inter" pitchFamily="34" charset="-122"/>
+                <a:cs typeface="Inter" pitchFamily="34" charset="-120"/>
+              </a:rPr>
+              <a:t>21</a:t>
+            </a:r>
+            <a:endParaRPr lang="en-US" sz="4000" dirty="0"/>
+          </a:p>
+        </p:txBody>
+      </p:sp>
+      <p:sp>
+        <p:nvSpPr>
+          <p:cNvPr id="30" name="Text 28"/>
+          <p:cNvSpPr txBox="1"/>
+          <p:nvPr/>
+        </p:nvSpPr>
+        <p:spPr>
+          <a:xfrm>
+            <a:off x="9667037" y="3200400"/>
+            <a:ext cx="1625803" cy="1188720"/>
+          </a:xfrm>
+          <a:prstGeom prst="rect">
+            <a:avLst/>
+          </a:prstGeom>
+          <a:noFill/>
+          <a:ln/>
+        </p:spPr>
+        <p:txBody>
+          <a:bodyPr wrap="square" lIns="0" tIns="0" rIns="0" bIns="0" rtlCol="0" anchor="t"/>
+          <a:lstStyle/>
+          <a:p>
+            <a:pPr indent="0" marL="0">
+              <a:buNone/>
+            </a:pPr>
+            <a:r>
+              <a:rPr lang="en-US" sz="1500" dirty="0">
+                <a:solidFill>
+                  <a:srgbClr val="1A1A1A"/>
+                </a:solidFill>
+                <a:latin typeface="Inter" pitchFamily="34" charset="0"/>
+                <a:ea typeface="Inter" pitchFamily="34" charset="-122"/>
+                <a:cs typeface="Inter" pitchFamily="34" charset="-120"/>
+              </a:rPr>
+              <a:t>stores; 18 also set the gross profit record.</a:t>
+            </a:r>
+            <a:endParaRPr lang="en-US" sz="1500" dirty="0"/>
+          </a:p>
+        </p:txBody>
+      </p:sp>
+      <p:sp>
+        <p:nvSpPr>
+          <p:cNvPr id="31" name="Text 29"/>
           <p:cNvSpPr txBox="1"/>
           <p:nvPr/>
         </p:nvSpPr>
@@ -1782,7 +2051,7 @@
       </p:sp>
       <p:sp>
         <p:nvSpPr>
-          <p:cNvPr id="27" name="Shape 25"/>
+          <p:cNvPr id="32" name="Shape 30"/>
           <p:cNvSpPr/>
           <p:nvPr/>
         </p:nvSpPr>
@@ -1802,7 +2071,7 @@
       </p:sp>
       <p:sp>
         <p:nvSpPr>
-          <p:cNvPr id="28" name="Text 26"/>
+          <p:cNvPr id="33" name="Text 31"/>
           <p:cNvSpPr txBox="1"/>
           <p:nvPr/>
         </p:nvSpPr>
@@ -1963,7 +2232,7 @@
                 <a:ea typeface="Inter" pitchFamily="34" charset="-122"/>
                 <a:cs typeface="Inter" pitchFamily="34" charset="-120"/>
               </a:rPr>
-              <a:t>Records Set in 2026</a:t>
+              <a:t>Records Set in 2026: Gross Profit</a:t>
             </a:r>
             <a:endParaRPr lang="en-US" sz="2800" dirty="0"/>
           </a:p>
@@ -8217,6 +8486,1203 @@
                 <a:cs typeface="Inter" pitchFamily="34" charset="-120"/>
               </a:rPr>
               <a:t>23 stores set 98 all-time monthly records in 2026.</a:t>
+            </a:r>
+            <a:endParaRPr lang="en-US" sz="1600" dirty="0"/>
+          </a:p>
+        </p:txBody>
+      </p:sp>
+    </p:spTree>
+  </p:cSld>
+  <p:clrMapOvr>
+    <a:masterClrMapping/>
+  </p:clrMapOvr>
+</p:sld>
+</file>
+
+<file path=ppt/slides/slide3.xml><?xml version="1.0" encoding="utf-8"?>
+<p:sld xmlns:a="http://schemas.openxmlformats.org/drawingml/2006/main" xmlns:r="http://schemas.openxmlformats.org/officeDocument/2006/relationships" xmlns:p="http://schemas.openxmlformats.org/presentationml/2006/main">
+  <p:cSld name="Slide 3">
+    <p:bg>
+      <p:bgPr>
+        <a:solidFill>
+          <a:srgbClr val="EDEDED"/>
+        </a:solidFill>
+      </p:bgPr>
+    </p:bg>
+    <p:spTree>
+      <p:nvGrpSpPr>
+        <p:cNvPr id="1" name=""/>
+        <p:cNvGrpSpPr/>
+        <p:nvPr/>
+      </p:nvGrpSpPr>
+      <p:grpSpPr>
+        <a:xfrm>
+          <a:off x="0" y="0"/>
+          <a:ext cx="0" cy="0"/>
+          <a:chOff x="0" y="0"/>
+          <a:chExt cx="0" cy="0"/>
+        </a:xfrm>
+      </p:grpSpPr>
+      <p:sp>
+        <p:nvSpPr>
+          <p:cNvPr id="2" name="Shape 0"/>
+          <p:cNvSpPr/>
+          <p:nvPr/>
+        </p:nvSpPr>
+        <p:spPr>
+          <a:xfrm>
+            <a:off x="457200" y="402336"/>
+            <a:ext cx="50292" cy="192024"/>
+          </a:xfrm>
+          <a:prstGeom prst="rect">
+            <a:avLst/>
+          </a:prstGeom>
+          <a:solidFill>
+            <a:srgbClr val="2587C5"/>
+          </a:solidFill>
+          <a:ln/>
+        </p:spPr>
+      </p:sp>
+      <p:sp>
+        <p:nvSpPr>
+          <p:cNvPr id="3" name="Text 1"/>
+          <p:cNvSpPr txBox="1"/>
+          <p:nvPr/>
+        </p:nvSpPr>
+        <p:spPr>
+          <a:xfrm>
+            <a:off x="621792" y="338328"/>
+            <a:ext cx="8229600" cy="274320"/>
+          </a:xfrm>
+          <a:prstGeom prst="rect">
+            <a:avLst/>
+          </a:prstGeom>
+          <a:noFill/>
+          <a:ln/>
+        </p:spPr>
+        <p:txBody>
+          <a:bodyPr wrap="square" lIns="0" tIns="0" rIns="0" bIns="0" rtlCol="0" anchor="ctr"/>
+          <a:lstStyle/>
+          <a:p>
+            <a:pPr indent="0" marL="0">
+              <a:buNone/>
+            </a:pPr>
+            <a:r>
+              <a:rPr lang="en-US" sz="1400" b="1" spc="110" kern="0" dirty="0">
+                <a:solidFill>
+                  <a:srgbClr val="595959"/>
+                </a:solidFill>
+                <a:latin typeface="Inter" pitchFamily="34" charset="0"/>
+                <a:ea typeface="Inter" pitchFamily="34" charset="-122"/>
+                <a:cs typeface="Inter" pitchFamily="34" charset="-120"/>
+              </a:rPr>
+              <a:t>FIXED OPS RECORDS</a:t>
+            </a:r>
+            <a:endParaRPr lang="en-US" sz="1400" dirty="0"/>
+          </a:p>
+        </p:txBody>
+      </p:sp>
+      <p:sp>
+        <p:nvSpPr>
+          <p:cNvPr id="4" name="Text 2"/>
+          <p:cNvSpPr txBox="1"/>
+          <p:nvPr/>
+        </p:nvSpPr>
+        <p:spPr>
+          <a:xfrm>
+            <a:off x="457200" y="640080"/>
+            <a:ext cx="11338560" cy="502920"/>
+          </a:xfrm>
+          <a:prstGeom prst="rect">
+            <a:avLst/>
+          </a:prstGeom>
+          <a:noFill/>
+          <a:ln/>
+        </p:spPr>
+        <p:txBody>
+          <a:bodyPr wrap="square" lIns="0" tIns="0" rIns="0" bIns="0" rtlCol="0" anchor="ctr"/>
+          <a:lstStyle/>
+          <a:p>
+            <a:pPr indent="0" marL="0">
+              <a:buNone/>
+            </a:pPr>
+            <a:r>
+              <a:rPr lang="en-US" sz="2800" dirty="0">
+                <a:solidFill>
+                  <a:srgbClr val="1A1A1A"/>
+                </a:solidFill>
+                <a:latin typeface="Inter" pitchFamily="34" charset="0"/>
+                <a:ea typeface="Inter" pitchFamily="34" charset="-122"/>
+                <a:cs typeface="Inter" pitchFamily="34" charset="-120"/>
+              </a:rPr>
+              <a:t>Best January–September Ever</a:t>
+            </a:r>
+            <a:endParaRPr lang="en-US" sz="2800" dirty="0"/>
+          </a:p>
+        </p:txBody>
+      </p:sp>
+      <p:sp>
+        <p:nvSpPr>
+          <p:cNvPr id="5" name="Shape 3"/>
+          <p:cNvSpPr/>
+          <p:nvPr/>
+        </p:nvSpPr>
+        <p:spPr>
+          <a:xfrm>
+            <a:off x="457200" y="1207008"/>
+            <a:ext cx="11274552" cy="4782312"/>
+          </a:xfrm>
+          <a:prstGeom prst="rect">
+            <a:avLst/>
+          </a:prstGeom>
+          <a:solidFill>
+            <a:srgbClr val="FFFFFF"/>
+          </a:solidFill>
+          <a:ln/>
+        </p:spPr>
+      </p:sp>
+      <p:sp>
+        <p:nvSpPr>
+          <p:cNvPr id="6" name="Shape 4"/>
+          <p:cNvSpPr/>
+          <p:nvPr/>
+        </p:nvSpPr>
+        <p:spPr>
+          <a:xfrm>
+            <a:off x="658368" y="1371600"/>
+            <a:ext cx="5234940" cy="45720"/>
+          </a:xfrm>
+          <a:prstGeom prst="rect">
+            <a:avLst/>
+          </a:prstGeom>
+          <a:solidFill>
+            <a:srgbClr val="12A566"/>
+          </a:solidFill>
+          <a:ln/>
+        </p:spPr>
+      </p:sp>
+      <p:sp>
+        <p:nvSpPr>
+          <p:cNvPr id="7" name="Text 5"/>
+          <p:cNvSpPr txBox="1"/>
+          <p:nvPr/>
+        </p:nvSpPr>
+        <p:spPr>
+          <a:xfrm>
+            <a:off x="749808" y="1463040"/>
+            <a:ext cx="4549140" cy="292608"/>
+          </a:xfrm>
+          <a:prstGeom prst="rect">
+            <a:avLst/>
+          </a:prstGeom>
+          <a:noFill/>
+          <a:ln/>
+        </p:spPr>
+        <p:txBody>
+          <a:bodyPr wrap="none" lIns="0" tIns="0" rIns="0" bIns="0" rtlCol="0" anchor="ctr"/>
+          <a:lstStyle/>
+          <a:p>
+            <a:pPr indent="0" marL="0">
+              <a:buNone/>
+            </a:pPr>
+            <a:r>
+              <a:rPr lang="en-US" sz="1500" b="1" spc="40" kern="0" dirty="0">
+                <a:solidFill>
+                  <a:srgbClr val="0B7A4A"/>
+                </a:solidFill>
+                <a:latin typeface="Inter" pitchFamily="34" charset="0"/>
+                <a:ea typeface="Inter" pitchFamily="34" charset="-122"/>
+                <a:cs typeface="Inter" pitchFamily="34" charset="-120"/>
+              </a:rPr>
+              <a:t>GROSS AND NET PROFIT</a:t>
+            </a:r>
+            <a:endParaRPr lang="en-US" sz="1500" dirty="0"/>
+          </a:p>
+        </p:txBody>
+      </p:sp>
+      <p:sp>
+        <p:nvSpPr>
+          <p:cNvPr id="8" name="Text 6"/>
+          <p:cNvSpPr txBox="1"/>
+          <p:nvPr/>
+        </p:nvSpPr>
+        <p:spPr>
+          <a:xfrm>
+            <a:off x="5326380" y="1408176"/>
+            <a:ext cx="502920" cy="402336"/>
+          </a:xfrm>
+          <a:prstGeom prst="rect">
+            <a:avLst/>
+          </a:prstGeom>
+          <a:noFill/>
+          <a:ln/>
+        </p:spPr>
+        <p:txBody>
+          <a:bodyPr wrap="square" lIns="0" tIns="0" rIns="0" bIns="0" rtlCol="0" anchor="ctr"/>
+          <a:lstStyle/>
+          <a:p>
+            <a:pPr algn="r" indent="0" marL="0">
+              <a:buNone/>
+            </a:pPr>
+            <a:r>
+              <a:rPr lang="en-US" sz="2600" b="1" dirty="0">
+                <a:solidFill>
+                  <a:srgbClr val="0B7A4A"/>
+                </a:solidFill>
+                <a:latin typeface="Inter" pitchFamily="34" charset="0"/>
+                <a:ea typeface="Inter" pitchFamily="34" charset="-122"/>
+                <a:cs typeface="Inter" pitchFamily="34" charset="-120"/>
+              </a:rPr>
+              <a:t>18</a:t>
+            </a:r>
+            <a:endParaRPr lang="en-US" sz="2600" dirty="0"/>
+          </a:p>
+        </p:txBody>
+      </p:sp>
+      <p:sp>
+        <p:nvSpPr>
+          <p:cNvPr id="9" name="Text 7"/>
+          <p:cNvSpPr txBox="1"/>
+          <p:nvPr/>
+        </p:nvSpPr>
+        <p:spPr>
+          <a:xfrm>
+            <a:off x="749808" y="1920240"/>
+            <a:ext cx="2526030" cy="3977640"/>
+          </a:xfrm>
+          <a:prstGeom prst="rect">
+            <a:avLst/>
+          </a:prstGeom>
+          <a:noFill/>
+          <a:ln/>
+        </p:spPr>
+        <p:txBody>
+          <a:bodyPr wrap="square" lIns="0" tIns="0" rIns="0" bIns="0" rtlCol="0" anchor="t"/>
+          <a:lstStyle/>
+          <a:p>
+            <a:pPr indent="0" marL="0">
+              <a:spcAft>
+                <a:spcPts val="300"/>
+              </a:spcAft>
+              <a:buNone/>
+            </a:pPr>
+            <a:r>
+              <a:rPr lang="en-US" sz="1400" dirty="0">
+                <a:solidFill>
+                  <a:srgbClr val="1A1A1A"/>
+                </a:solidFill>
+                <a:latin typeface="Inter" pitchFamily="34" charset="0"/>
+                <a:ea typeface="Inter" pitchFamily="34" charset="-122"/>
+                <a:cs typeface="Inter" pitchFamily="34" charset="-120"/>
+              </a:rPr>
+              <a:t>AUDI HENDERSON</a:t>
+            </a:r>
+            <a:endParaRPr lang="en-US" sz="1400" dirty="0"/>
+          </a:p>
+          <a:p>
+            <a:pPr indent="0" marL="0">
+              <a:spcAft>
+                <a:spcPts val="300"/>
+              </a:spcAft>
+              <a:buNone/>
+            </a:pPr>
+            <a:r>
+              <a:rPr lang="en-US" sz="1400" dirty="0">
+                <a:solidFill>
+                  <a:srgbClr val="1A1A1A"/>
+                </a:solidFill>
+                <a:latin typeface="Inter" pitchFamily="34" charset="0"/>
+                <a:ea typeface="Inter" pitchFamily="34" charset="-122"/>
+                <a:cs typeface="Inter" pitchFamily="34" charset="-120"/>
+              </a:rPr>
+              <a:t>CADILLAC</a:t>
+            </a:r>
+            <a:endParaRPr lang="en-US" sz="1400" dirty="0"/>
+          </a:p>
+          <a:p>
+            <a:pPr indent="0" marL="0">
+              <a:spcAft>
+                <a:spcPts val="300"/>
+              </a:spcAft>
+              <a:buNone/>
+            </a:pPr>
+            <a:r>
+              <a:rPr lang="en-US" sz="1400" dirty="0">
+                <a:solidFill>
+                  <a:srgbClr val="1A1A1A"/>
+                </a:solidFill>
+                <a:latin typeface="Inter" pitchFamily="34" charset="0"/>
+                <a:ea typeface="Inter" pitchFamily="34" charset="-122"/>
+                <a:cs typeface="Inter" pitchFamily="34" charset="-120"/>
+              </a:rPr>
+              <a:t>CHEVY GMC BULLHEAD</a:t>
+            </a:r>
+            <a:endParaRPr lang="en-US" sz="1400" dirty="0"/>
+          </a:p>
+          <a:p>
+            <a:pPr indent="0" marL="0">
+              <a:spcAft>
+                <a:spcPts val="300"/>
+              </a:spcAft>
+              <a:buNone/>
+            </a:pPr>
+            <a:r>
+              <a:rPr lang="en-US" sz="1400" dirty="0">
+                <a:solidFill>
+                  <a:srgbClr val="1A1A1A"/>
+                </a:solidFill>
+                <a:latin typeface="Inter" pitchFamily="34" charset="0"/>
+                <a:ea typeface="Inter" pitchFamily="34" charset="-122"/>
+                <a:cs typeface="Inter" pitchFamily="34" charset="-120"/>
+              </a:rPr>
+              <a:t>HONDA HENDERSON</a:t>
+            </a:r>
+            <a:endParaRPr lang="en-US" sz="1400" dirty="0"/>
+          </a:p>
+          <a:p>
+            <a:pPr indent="0" marL="0">
+              <a:spcAft>
+                <a:spcPts val="300"/>
+              </a:spcAft>
+              <a:buNone/>
+            </a:pPr>
+            <a:r>
+              <a:rPr lang="en-US" sz="1400" dirty="0">
+                <a:solidFill>
+                  <a:srgbClr val="1A1A1A"/>
+                </a:solidFill>
+                <a:latin typeface="Inter" pitchFamily="34" charset="0"/>
+                <a:ea typeface="Inter" pitchFamily="34" charset="-122"/>
+                <a:cs typeface="Inter" pitchFamily="34" charset="-120"/>
+              </a:rPr>
+              <a:t>HONDA SPOKANE</a:t>
+            </a:r>
+            <a:endParaRPr lang="en-US" sz="1400" dirty="0"/>
+          </a:p>
+          <a:p>
+            <a:pPr indent="0" marL="0">
+              <a:spcAft>
+                <a:spcPts val="300"/>
+              </a:spcAft>
+              <a:buNone/>
+            </a:pPr>
+            <a:r>
+              <a:rPr lang="en-US" sz="1400" dirty="0">
+                <a:solidFill>
+                  <a:srgbClr val="1A1A1A"/>
+                </a:solidFill>
+                <a:latin typeface="Inter" pitchFamily="34" charset="0"/>
+                <a:ea typeface="Inter" pitchFamily="34" charset="-122"/>
+                <a:cs typeface="Inter" pitchFamily="34" charset="-120"/>
+              </a:rPr>
+              <a:t>KIA LV</a:t>
+            </a:r>
+            <a:endParaRPr lang="en-US" sz="1400" dirty="0"/>
+          </a:p>
+          <a:p>
+            <a:pPr indent="0" marL="0">
+              <a:spcAft>
+                <a:spcPts val="300"/>
+              </a:spcAft>
+              <a:buNone/>
+            </a:pPr>
+            <a:r>
+              <a:rPr lang="en-US" sz="1400" dirty="0">
+                <a:solidFill>
+                  <a:srgbClr val="1A1A1A"/>
+                </a:solidFill>
+                <a:latin typeface="Inter" pitchFamily="34" charset="0"/>
+                <a:ea typeface="Inter" pitchFamily="34" charset="-122"/>
+                <a:cs typeface="Inter" pitchFamily="34" charset="-120"/>
+              </a:rPr>
+              <a:t>LEXUS</a:t>
+            </a:r>
+            <a:endParaRPr lang="en-US" sz="1400" dirty="0"/>
+          </a:p>
+          <a:p>
+            <a:pPr indent="0" marL="0">
+              <a:spcAft>
+                <a:spcPts val="300"/>
+              </a:spcAft>
+              <a:buNone/>
+            </a:pPr>
+            <a:r>
+              <a:rPr lang="en-US" sz="1400" dirty="0">
+                <a:solidFill>
+                  <a:srgbClr val="1A1A1A"/>
+                </a:solidFill>
+                <a:latin typeface="Inter" pitchFamily="34" charset="0"/>
+                <a:ea typeface="Inter" pitchFamily="34" charset="-122"/>
+                <a:cs typeface="Inter" pitchFamily="34" charset="-120"/>
+              </a:rPr>
+              <a:t>LINCOLN</a:t>
+            </a:r>
+            <a:endParaRPr lang="en-US" sz="1400" dirty="0"/>
+          </a:p>
+          <a:p>
+            <a:pPr indent="0" marL="0">
+              <a:spcAft>
+                <a:spcPts val="300"/>
+              </a:spcAft>
+              <a:buNone/>
+            </a:pPr>
+            <a:r>
+              <a:rPr lang="en-US" sz="1400" dirty="0">
+                <a:solidFill>
+                  <a:srgbClr val="1A1A1A"/>
+                </a:solidFill>
+                <a:latin typeface="Inter" pitchFamily="34" charset="0"/>
+                <a:ea typeface="Inter" pitchFamily="34" charset="-122"/>
+                <a:cs typeface="Inter" pitchFamily="34" charset="-120"/>
+              </a:rPr>
+              <a:t>LR HENDERSON</a:t>
+            </a:r>
+            <a:endParaRPr lang="en-US" sz="1400" dirty="0"/>
+          </a:p>
+        </p:txBody>
+      </p:sp>
+      <p:sp>
+        <p:nvSpPr>
+          <p:cNvPr id="10" name="Text 8"/>
+          <p:cNvSpPr txBox="1"/>
+          <p:nvPr/>
+        </p:nvSpPr>
+        <p:spPr>
+          <a:xfrm>
+            <a:off x="3275838" y="1920240"/>
+            <a:ext cx="2526030" cy="3977640"/>
+          </a:xfrm>
+          <a:prstGeom prst="rect">
+            <a:avLst/>
+          </a:prstGeom>
+          <a:noFill/>
+          <a:ln/>
+        </p:spPr>
+        <p:txBody>
+          <a:bodyPr wrap="square" lIns="0" tIns="0" rIns="0" bIns="0" rtlCol="0" anchor="t"/>
+          <a:lstStyle/>
+          <a:p>
+            <a:pPr indent="0" marL="0">
+              <a:spcAft>
+                <a:spcPts val="300"/>
+              </a:spcAft>
+              <a:buNone/>
+            </a:pPr>
+            <a:r>
+              <a:rPr lang="en-US" sz="1400" dirty="0">
+                <a:solidFill>
+                  <a:srgbClr val="1A1A1A"/>
+                </a:solidFill>
+                <a:latin typeface="Inter" pitchFamily="34" charset="0"/>
+                <a:ea typeface="Inter" pitchFamily="34" charset="-122"/>
+                <a:cs typeface="Inter" pitchFamily="34" charset="-120"/>
+              </a:rPr>
+              <a:t>LR LV</a:t>
+            </a:r>
+            <a:endParaRPr lang="en-US" sz="1400" dirty="0"/>
+          </a:p>
+          <a:p>
+            <a:pPr indent="0" marL="0">
+              <a:spcAft>
+                <a:spcPts val="300"/>
+              </a:spcAft>
+              <a:buNone/>
+            </a:pPr>
+            <a:r>
+              <a:rPr lang="en-US" sz="1400" dirty="0">
+                <a:solidFill>
+                  <a:srgbClr val="1A1A1A"/>
+                </a:solidFill>
+                <a:latin typeface="Inter" pitchFamily="34" charset="0"/>
+                <a:ea typeface="Inter" pitchFamily="34" charset="-122"/>
+                <a:cs typeface="Inter" pitchFamily="34" charset="-120"/>
+              </a:rPr>
+              <a:t>LR RENO</a:t>
+            </a:r>
+            <a:endParaRPr lang="en-US" sz="1400" dirty="0"/>
+          </a:p>
+          <a:p>
+            <a:pPr indent="0" marL="0">
+              <a:spcAft>
+                <a:spcPts val="300"/>
+              </a:spcAft>
+              <a:buNone/>
+            </a:pPr>
+            <a:r>
+              <a:rPr lang="en-US" sz="1400" dirty="0">
+                <a:solidFill>
+                  <a:srgbClr val="1A1A1A"/>
+                </a:solidFill>
+                <a:latin typeface="Inter" pitchFamily="34" charset="0"/>
+                <a:ea typeface="Inter" pitchFamily="34" charset="-122"/>
+                <a:cs typeface="Inter" pitchFamily="34" charset="-120"/>
+              </a:rPr>
+              <a:t>NISSAN</a:t>
+            </a:r>
+            <a:endParaRPr lang="en-US" sz="1400" dirty="0"/>
+          </a:p>
+          <a:p>
+            <a:pPr indent="0" marL="0">
+              <a:spcAft>
+                <a:spcPts val="300"/>
+              </a:spcAft>
+              <a:buNone/>
+            </a:pPr>
+            <a:r>
+              <a:rPr lang="en-US" sz="1400" dirty="0">
+                <a:solidFill>
+                  <a:srgbClr val="1A1A1A"/>
+                </a:solidFill>
+                <a:latin typeface="Inter" pitchFamily="34" charset="0"/>
+                <a:ea typeface="Inter" pitchFamily="34" charset="-122"/>
+                <a:cs typeface="Inter" pitchFamily="34" charset="-120"/>
+              </a:rPr>
+              <a:t>SUBARU PRESCOTT</a:t>
+            </a:r>
+            <a:endParaRPr lang="en-US" sz="1400" dirty="0"/>
+          </a:p>
+          <a:p>
+            <a:pPr indent="0" marL="0">
+              <a:spcAft>
+                <a:spcPts val="300"/>
+              </a:spcAft>
+              <a:buNone/>
+            </a:pPr>
+            <a:r>
+              <a:rPr lang="en-US" sz="1400" dirty="0">
+                <a:solidFill>
+                  <a:srgbClr val="1A1A1A"/>
+                </a:solidFill>
+                <a:latin typeface="Inter" pitchFamily="34" charset="0"/>
+                <a:ea typeface="Inter" pitchFamily="34" charset="-122"/>
+                <a:cs typeface="Inter" pitchFamily="34" charset="-120"/>
+              </a:rPr>
+              <a:t>SUBARU ST GEORGE</a:t>
+            </a:r>
+            <a:endParaRPr lang="en-US" sz="1400" dirty="0"/>
+          </a:p>
+          <a:p>
+            <a:pPr indent="0" marL="0">
+              <a:spcAft>
+                <a:spcPts val="300"/>
+              </a:spcAft>
+              <a:buNone/>
+            </a:pPr>
+            <a:r>
+              <a:rPr lang="en-US" sz="1400" dirty="0">
+                <a:solidFill>
+                  <a:srgbClr val="1A1A1A"/>
+                </a:solidFill>
+                <a:latin typeface="Inter" pitchFamily="34" charset="0"/>
+                <a:ea typeface="Inter" pitchFamily="34" charset="-122"/>
+                <a:cs typeface="Inter" pitchFamily="34" charset="-120"/>
+              </a:rPr>
+              <a:t>TOYOTA FLAGSTAFF</a:t>
+            </a:r>
+            <a:endParaRPr lang="en-US" sz="1400" dirty="0"/>
+          </a:p>
+          <a:p>
+            <a:pPr indent="0" marL="0">
+              <a:spcAft>
+                <a:spcPts val="300"/>
+              </a:spcAft>
+              <a:buNone/>
+            </a:pPr>
+            <a:r>
+              <a:rPr lang="en-US" sz="1400" dirty="0">
+                <a:solidFill>
+                  <a:srgbClr val="1A1A1A"/>
+                </a:solidFill>
+                <a:latin typeface="Inter" pitchFamily="34" charset="0"/>
+                <a:ea typeface="Inter" pitchFamily="34" charset="-122"/>
+                <a:cs typeface="Inter" pitchFamily="34" charset="-120"/>
+              </a:rPr>
+              <a:t>TOYOTA HENDERSON</a:t>
+            </a:r>
+            <a:endParaRPr lang="en-US" sz="1400" dirty="0"/>
+          </a:p>
+          <a:p>
+            <a:pPr indent="0" marL="0">
+              <a:spcAft>
+                <a:spcPts val="300"/>
+              </a:spcAft>
+              <a:buNone/>
+            </a:pPr>
+            <a:r>
+              <a:rPr lang="en-US" sz="1400" dirty="0">
+                <a:solidFill>
+                  <a:srgbClr val="1A1A1A"/>
+                </a:solidFill>
+                <a:latin typeface="Inter" pitchFamily="34" charset="0"/>
+                <a:ea typeface="Inter" pitchFamily="34" charset="-122"/>
+                <a:cs typeface="Inter" pitchFamily="34" charset="-120"/>
+              </a:rPr>
+              <a:t>TOYOTA PRESCOTT</a:t>
+            </a:r>
+            <a:endParaRPr lang="en-US" sz="1400" dirty="0"/>
+          </a:p>
+          <a:p>
+            <a:pPr indent="0" marL="0">
+              <a:spcAft>
+                <a:spcPts val="300"/>
+              </a:spcAft>
+              <a:buNone/>
+            </a:pPr>
+            <a:r>
+              <a:rPr lang="en-US" sz="1400" dirty="0">
+                <a:solidFill>
+                  <a:srgbClr val="1A1A1A"/>
+                </a:solidFill>
+                <a:latin typeface="Inter" pitchFamily="34" charset="0"/>
+                <a:ea typeface="Inter" pitchFamily="34" charset="-122"/>
+                <a:cs typeface="Inter" pitchFamily="34" charset="-120"/>
+              </a:rPr>
+              <a:t>VOLVO</a:t>
+            </a:r>
+            <a:endParaRPr lang="en-US" sz="1400" dirty="0"/>
+          </a:p>
+        </p:txBody>
+      </p:sp>
+      <p:sp>
+        <p:nvSpPr>
+          <p:cNvPr id="11" name="Shape 9"/>
+          <p:cNvSpPr/>
+          <p:nvPr/>
+        </p:nvSpPr>
+        <p:spPr>
+          <a:xfrm>
+            <a:off x="6094476" y="1371600"/>
+            <a:ext cx="2617470" cy="45720"/>
+          </a:xfrm>
+          <a:prstGeom prst="rect">
+            <a:avLst/>
+          </a:prstGeom>
+          <a:solidFill>
+            <a:srgbClr val="2587C5"/>
+          </a:solidFill>
+          <a:ln/>
+        </p:spPr>
+      </p:sp>
+      <p:sp>
+        <p:nvSpPr>
+          <p:cNvPr id="12" name="Text 10"/>
+          <p:cNvSpPr txBox="1"/>
+          <p:nvPr/>
+        </p:nvSpPr>
+        <p:spPr>
+          <a:xfrm>
+            <a:off x="6185916" y="1463040"/>
+            <a:ext cx="1931670" cy="292608"/>
+          </a:xfrm>
+          <a:prstGeom prst="rect">
+            <a:avLst/>
+          </a:prstGeom>
+          <a:noFill/>
+          <a:ln/>
+        </p:spPr>
+        <p:txBody>
+          <a:bodyPr wrap="none" lIns="0" tIns="0" rIns="0" bIns="0" rtlCol="0" anchor="ctr"/>
+          <a:lstStyle/>
+          <a:p>
+            <a:pPr indent="0" marL="0">
+              <a:buNone/>
+            </a:pPr>
+            <a:r>
+              <a:rPr lang="en-US" sz="1500" b="1" spc="40" kern="0" dirty="0">
+                <a:solidFill>
+                  <a:srgbClr val="0B2C4A"/>
+                </a:solidFill>
+                <a:latin typeface="Inter" pitchFamily="34" charset="0"/>
+                <a:ea typeface="Inter" pitchFamily="34" charset="-122"/>
+                <a:cs typeface="Inter" pitchFamily="34" charset="-120"/>
+              </a:rPr>
+              <a:t>GROSS PROFIT ONLY</a:t>
+            </a:r>
+            <a:endParaRPr lang="en-US" sz="1500" dirty="0"/>
+          </a:p>
+        </p:txBody>
+      </p:sp>
+      <p:sp>
+        <p:nvSpPr>
+          <p:cNvPr id="13" name="Shape 11"/>
+          <p:cNvSpPr/>
+          <p:nvPr/>
+        </p:nvSpPr>
+        <p:spPr>
+          <a:xfrm>
+            <a:off x="5993892" y="1371600"/>
+            <a:ext cx="0" cy="4526280"/>
+          </a:xfrm>
+          <a:prstGeom prst="line">
+            <a:avLst/>
+          </a:prstGeom>
+          <a:noFill/>
+          <a:ln w="9525">
+            <a:solidFill>
+              <a:srgbClr val="BFBFBF"/>
+            </a:solidFill>
+            <a:prstDash val="solid"/>
+          </a:ln>
+        </p:spPr>
+      </p:sp>
+      <p:sp>
+        <p:nvSpPr>
+          <p:cNvPr id="14" name="Text 12"/>
+          <p:cNvSpPr txBox="1"/>
+          <p:nvPr/>
+        </p:nvSpPr>
+        <p:spPr>
+          <a:xfrm>
+            <a:off x="8145018" y="1408176"/>
+            <a:ext cx="502920" cy="402336"/>
+          </a:xfrm>
+          <a:prstGeom prst="rect">
+            <a:avLst/>
+          </a:prstGeom>
+          <a:noFill/>
+          <a:ln/>
+        </p:spPr>
+        <p:txBody>
+          <a:bodyPr wrap="square" lIns="0" tIns="0" rIns="0" bIns="0" rtlCol="0" anchor="ctr"/>
+          <a:lstStyle/>
+          <a:p>
+            <a:pPr algn="r" indent="0" marL="0">
+              <a:buNone/>
+            </a:pPr>
+            <a:r>
+              <a:rPr lang="en-US" sz="2600" b="1" dirty="0">
+                <a:solidFill>
+                  <a:srgbClr val="0B2C4A"/>
+                </a:solidFill>
+                <a:latin typeface="Inter" pitchFamily="34" charset="0"/>
+                <a:ea typeface="Inter" pitchFamily="34" charset="-122"/>
+                <a:cs typeface="Inter" pitchFamily="34" charset="-120"/>
+              </a:rPr>
+              <a:t>7</a:t>
+            </a:r>
+            <a:endParaRPr lang="en-US" sz="2600" dirty="0"/>
+          </a:p>
+        </p:txBody>
+      </p:sp>
+      <p:sp>
+        <p:nvSpPr>
+          <p:cNvPr id="15" name="Text 13"/>
+          <p:cNvSpPr txBox="1"/>
+          <p:nvPr/>
+        </p:nvSpPr>
+        <p:spPr>
+          <a:xfrm>
+            <a:off x="6185916" y="1920240"/>
+            <a:ext cx="2434590" cy="3977640"/>
+          </a:xfrm>
+          <a:prstGeom prst="rect">
+            <a:avLst/>
+          </a:prstGeom>
+          <a:noFill/>
+          <a:ln/>
+        </p:spPr>
+        <p:txBody>
+          <a:bodyPr wrap="square" lIns="0" tIns="0" rIns="0" bIns="0" rtlCol="0" anchor="t"/>
+          <a:lstStyle/>
+          <a:p>
+            <a:pPr indent="0" marL="0">
+              <a:spcAft>
+                <a:spcPts val="300"/>
+              </a:spcAft>
+              <a:buNone/>
+            </a:pPr>
+            <a:r>
+              <a:rPr lang="en-US" sz="1400" dirty="0">
+                <a:solidFill>
+                  <a:srgbClr val="1A1A1A"/>
+                </a:solidFill>
+                <a:latin typeface="Inter" pitchFamily="34" charset="0"/>
+                <a:ea typeface="Inter" pitchFamily="34" charset="-122"/>
+                <a:cs typeface="Inter" pitchFamily="34" charset="-120"/>
+              </a:rPr>
+              <a:t>GMC PRESCOTT</a:t>
+            </a:r>
+            <a:endParaRPr lang="en-US" sz="1400" dirty="0"/>
+          </a:p>
+          <a:p>
+            <a:pPr indent="0" marL="0">
+              <a:spcAft>
+                <a:spcPts val="300"/>
+              </a:spcAft>
+              <a:buNone/>
+            </a:pPr>
+            <a:r>
+              <a:rPr lang="en-US" sz="1400" dirty="0">
+                <a:solidFill>
+                  <a:srgbClr val="1A1A1A"/>
+                </a:solidFill>
+                <a:latin typeface="Inter" pitchFamily="34" charset="0"/>
+                <a:ea typeface="Inter" pitchFamily="34" charset="-122"/>
+                <a:cs typeface="Inter" pitchFamily="34" charset="-120"/>
+              </a:rPr>
+              <a:t>HONDA FLAGSTAFF</a:t>
+            </a:r>
+            <a:endParaRPr lang="en-US" sz="1400" dirty="0"/>
+          </a:p>
+          <a:p>
+            <a:pPr indent="0" marL="0">
+              <a:spcAft>
+                <a:spcPts val="300"/>
+              </a:spcAft>
+              <a:buNone/>
+            </a:pPr>
+            <a:r>
+              <a:rPr lang="en-US" sz="1400" dirty="0">
+                <a:solidFill>
+                  <a:srgbClr val="1A1A1A"/>
+                </a:solidFill>
+                <a:latin typeface="Inter" pitchFamily="34" charset="0"/>
+                <a:ea typeface="Inter" pitchFamily="34" charset="-122"/>
+                <a:cs typeface="Inter" pitchFamily="34" charset="-120"/>
+              </a:rPr>
+              <a:t>HYUNDAI PRESCOTT</a:t>
+            </a:r>
+            <a:endParaRPr lang="en-US" sz="1400" dirty="0"/>
+          </a:p>
+          <a:p>
+            <a:pPr indent="0" marL="0">
+              <a:spcAft>
+                <a:spcPts val="300"/>
+              </a:spcAft>
+              <a:buNone/>
+            </a:pPr>
+            <a:r>
+              <a:rPr lang="en-US" sz="1400" dirty="0">
+                <a:solidFill>
+                  <a:srgbClr val="1A1A1A"/>
+                </a:solidFill>
+                <a:latin typeface="Inter" pitchFamily="34" charset="0"/>
+                <a:ea typeface="Inter" pitchFamily="34" charset="-122"/>
+                <a:cs typeface="Inter" pitchFamily="34" charset="-120"/>
+              </a:rPr>
+              <a:t>HYUNDAI ST GEORGE</a:t>
+            </a:r>
+            <a:endParaRPr lang="en-US" sz="1400" dirty="0"/>
+          </a:p>
+          <a:p>
+            <a:pPr indent="0" marL="0">
+              <a:spcAft>
+                <a:spcPts val="300"/>
+              </a:spcAft>
+              <a:buNone/>
+            </a:pPr>
+            <a:r>
+              <a:rPr lang="en-US" sz="1400" dirty="0">
+                <a:solidFill>
+                  <a:srgbClr val="1A1A1A"/>
+                </a:solidFill>
+                <a:latin typeface="Inter" pitchFamily="34" charset="0"/>
+                <a:ea typeface="Inter" pitchFamily="34" charset="-122"/>
+                <a:cs typeface="Inter" pitchFamily="34" charset="-120"/>
+              </a:rPr>
+              <a:t>KIA ST GEORGE</a:t>
+            </a:r>
+            <a:endParaRPr lang="en-US" sz="1400" dirty="0"/>
+          </a:p>
+          <a:p>
+            <a:pPr indent="0" marL="0">
+              <a:spcAft>
+                <a:spcPts val="300"/>
+              </a:spcAft>
+              <a:buNone/>
+            </a:pPr>
+            <a:r>
+              <a:rPr lang="en-US" sz="1400" dirty="0">
+                <a:solidFill>
+                  <a:srgbClr val="1A1A1A"/>
+                </a:solidFill>
+                <a:latin typeface="Inter" pitchFamily="34" charset="0"/>
+                <a:ea typeface="Inter" pitchFamily="34" charset="-122"/>
+                <a:cs typeface="Inter" pitchFamily="34" charset="-120"/>
+              </a:rPr>
+              <a:t>MAZDA</a:t>
+            </a:r>
+            <a:endParaRPr lang="en-US" sz="1400" dirty="0"/>
+          </a:p>
+          <a:p>
+            <a:pPr indent="0" marL="0">
+              <a:spcAft>
+                <a:spcPts val="300"/>
+              </a:spcAft>
+              <a:buNone/>
+            </a:pPr>
+            <a:r>
+              <a:rPr lang="en-US" sz="1400" dirty="0">
+                <a:solidFill>
+                  <a:srgbClr val="1A1A1A"/>
+                </a:solidFill>
+                <a:latin typeface="Inter" pitchFamily="34" charset="0"/>
+                <a:ea typeface="Inter" pitchFamily="34" charset="-122"/>
+                <a:cs typeface="Inter" pitchFamily="34" charset="-120"/>
+              </a:rPr>
+              <a:t>TOYOTA SPOKANE</a:t>
+            </a:r>
+            <a:endParaRPr lang="en-US" sz="1400" dirty="0"/>
+          </a:p>
+        </p:txBody>
+      </p:sp>
+      <p:sp>
+        <p:nvSpPr>
+          <p:cNvPr id="16" name="Shape 14"/>
+          <p:cNvSpPr/>
+          <p:nvPr/>
+        </p:nvSpPr>
+        <p:spPr>
+          <a:xfrm>
+            <a:off x="8913114" y="1371600"/>
+            <a:ext cx="2617470" cy="45720"/>
+          </a:xfrm>
+          <a:prstGeom prst="rect">
+            <a:avLst/>
+          </a:prstGeom>
+          <a:solidFill>
+            <a:srgbClr val="2587C5"/>
+          </a:solidFill>
+          <a:ln/>
+        </p:spPr>
+      </p:sp>
+      <p:sp>
+        <p:nvSpPr>
+          <p:cNvPr id="17" name="Text 15"/>
+          <p:cNvSpPr txBox="1"/>
+          <p:nvPr/>
+        </p:nvSpPr>
+        <p:spPr>
+          <a:xfrm>
+            <a:off x="9004554" y="1463040"/>
+            <a:ext cx="1931670" cy="292608"/>
+          </a:xfrm>
+          <a:prstGeom prst="rect">
+            <a:avLst/>
+          </a:prstGeom>
+          <a:noFill/>
+          <a:ln/>
+        </p:spPr>
+        <p:txBody>
+          <a:bodyPr wrap="none" lIns="0" tIns="0" rIns="0" bIns="0" rtlCol="0" anchor="ctr"/>
+          <a:lstStyle/>
+          <a:p>
+            <a:pPr indent="0" marL="0">
+              <a:buNone/>
+            </a:pPr>
+            <a:r>
+              <a:rPr lang="en-US" sz="1500" b="1" spc="40" kern="0" dirty="0">
+                <a:solidFill>
+                  <a:srgbClr val="0B2C4A"/>
+                </a:solidFill>
+                <a:latin typeface="Inter" pitchFamily="34" charset="0"/>
+                <a:ea typeface="Inter" pitchFamily="34" charset="-122"/>
+                <a:cs typeface="Inter" pitchFamily="34" charset="-120"/>
+              </a:rPr>
+              <a:t>NET PROFIT ONLY</a:t>
+            </a:r>
+            <a:endParaRPr lang="en-US" sz="1500" dirty="0"/>
+          </a:p>
+        </p:txBody>
+      </p:sp>
+      <p:sp>
+        <p:nvSpPr>
+          <p:cNvPr id="18" name="Shape 16"/>
+          <p:cNvSpPr/>
+          <p:nvPr/>
+        </p:nvSpPr>
+        <p:spPr>
+          <a:xfrm>
+            <a:off x="8812530" y="1371600"/>
+            <a:ext cx="0" cy="4526280"/>
+          </a:xfrm>
+          <a:prstGeom prst="line">
+            <a:avLst/>
+          </a:prstGeom>
+          <a:noFill/>
+          <a:ln w="9525">
+            <a:solidFill>
+              <a:srgbClr val="BFBFBF"/>
+            </a:solidFill>
+            <a:prstDash val="solid"/>
+          </a:ln>
+        </p:spPr>
+      </p:sp>
+      <p:sp>
+        <p:nvSpPr>
+          <p:cNvPr id="19" name="Text 17"/>
+          <p:cNvSpPr txBox="1"/>
+          <p:nvPr/>
+        </p:nvSpPr>
+        <p:spPr>
+          <a:xfrm>
+            <a:off x="10963656" y="1408176"/>
+            <a:ext cx="502920" cy="402336"/>
+          </a:xfrm>
+          <a:prstGeom prst="rect">
+            <a:avLst/>
+          </a:prstGeom>
+          <a:noFill/>
+          <a:ln/>
+        </p:spPr>
+        <p:txBody>
+          <a:bodyPr wrap="square" lIns="0" tIns="0" rIns="0" bIns="0" rtlCol="0" anchor="ctr"/>
+          <a:lstStyle/>
+          <a:p>
+            <a:pPr algn="r" indent="0" marL="0">
+              <a:buNone/>
+            </a:pPr>
+            <a:r>
+              <a:rPr lang="en-US" sz="2600" b="1" dirty="0">
+                <a:solidFill>
+                  <a:srgbClr val="0B2C4A"/>
+                </a:solidFill>
+                <a:latin typeface="Inter" pitchFamily="34" charset="0"/>
+                <a:ea typeface="Inter" pitchFamily="34" charset="-122"/>
+                <a:cs typeface="Inter" pitchFamily="34" charset="-120"/>
+              </a:rPr>
+              <a:t>3</a:t>
+            </a:r>
+            <a:endParaRPr lang="en-US" sz="2600" dirty="0"/>
+          </a:p>
+        </p:txBody>
+      </p:sp>
+      <p:sp>
+        <p:nvSpPr>
+          <p:cNvPr id="20" name="Text 18"/>
+          <p:cNvSpPr txBox="1"/>
+          <p:nvPr/>
+        </p:nvSpPr>
+        <p:spPr>
+          <a:xfrm>
+            <a:off x="9004554" y="1920240"/>
+            <a:ext cx="2434590" cy="3977640"/>
+          </a:xfrm>
+          <a:prstGeom prst="rect">
+            <a:avLst/>
+          </a:prstGeom>
+          <a:noFill/>
+          <a:ln/>
+        </p:spPr>
+        <p:txBody>
+          <a:bodyPr wrap="square" lIns="0" tIns="0" rIns="0" bIns="0" rtlCol="0" anchor="t"/>
+          <a:lstStyle/>
+          <a:p>
+            <a:pPr indent="0" marL="0">
+              <a:spcAft>
+                <a:spcPts val="300"/>
+              </a:spcAft>
+              <a:buNone/>
+            </a:pPr>
+            <a:r>
+              <a:rPr lang="en-US" sz="1400" dirty="0">
+                <a:solidFill>
+                  <a:srgbClr val="1A1A1A"/>
+                </a:solidFill>
+                <a:latin typeface="Inter" pitchFamily="34" charset="0"/>
+                <a:ea typeface="Inter" pitchFamily="34" charset="-122"/>
+                <a:cs typeface="Inter" pitchFamily="34" charset="-120"/>
+              </a:rPr>
+              <a:t>ACURA</a:t>
+            </a:r>
+            <a:endParaRPr lang="en-US" sz="1400" dirty="0"/>
+          </a:p>
+          <a:p>
+            <a:pPr indent="0" marL="0">
+              <a:spcAft>
+                <a:spcPts val="300"/>
+              </a:spcAft>
+              <a:buNone/>
+            </a:pPr>
+            <a:r>
+              <a:rPr lang="en-US" sz="1400" dirty="0">
+                <a:solidFill>
+                  <a:srgbClr val="1A1A1A"/>
+                </a:solidFill>
+                <a:latin typeface="Inter" pitchFamily="34" charset="0"/>
+                <a:ea typeface="Inter" pitchFamily="34" charset="-122"/>
+                <a:cs typeface="Inter" pitchFamily="34" charset="-120"/>
+              </a:rPr>
+              <a:t>CDJR POST FALLS</a:t>
+            </a:r>
+            <a:endParaRPr lang="en-US" sz="1400" dirty="0"/>
+          </a:p>
+          <a:p>
+            <a:pPr indent="0" marL="0">
+              <a:spcAft>
+                <a:spcPts val="300"/>
+              </a:spcAft>
+              <a:buNone/>
+            </a:pPr>
+            <a:r>
+              <a:rPr lang="en-US" sz="1400" dirty="0">
+                <a:solidFill>
+                  <a:srgbClr val="1A1A1A"/>
+                </a:solidFill>
+                <a:latin typeface="Inter" pitchFamily="34" charset="0"/>
+                <a:ea typeface="Inter" pitchFamily="34" charset="-122"/>
+                <a:cs typeface="Inter" pitchFamily="34" charset="-120"/>
+              </a:rPr>
+              <a:t>SUBARU LV</a:t>
+            </a:r>
+            <a:endParaRPr lang="en-US" sz="1400" dirty="0"/>
+          </a:p>
+        </p:txBody>
+      </p:sp>
+      <p:sp>
+        <p:nvSpPr>
+          <p:cNvPr id="21" name="Shape 19"/>
+          <p:cNvSpPr/>
+          <p:nvPr/>
+        </p:nvSpPr>
+        <p:spPr>
+          <a:xfrm>
+            <a:off x="457200" y="6126480"/>
+            <a:ext cx="11274552" cy="371856"/>
+          </a:xfrm>
+          <a:prstGeom prst="rect">
+            <a:avLst/>
+          </a:prstGeom>
+          <a:solidFill>
+            <a:srgbClr val="E6F6EE"/>
+          </a:solidFill>
+          <a:ln/>
+        </p:spPr>
+      </p:sp>
+      <p:sp>
+        <p:nvSpPr>
+          <p:cNvPr id="22" name="Text 20"/>
+          <p:cNvSpPr txBox="1"/>
+          <p:nvPr/>
+        </p:nvSpPr>
+        <p:spPr>
+          <a:xfrm>
+            <a:off x="658368" y="6144768"/>
+            <a:ext cx="10927080" cy="335280"/>
+          </a:xfrm>
+          <a:prstGeom prst="rect">
+            <a:avLst/>
+          </a:prstGeom>
+          <a:noFill/>
+          <a:ln/>
+        </p:spPr>
+        <p:txBody>
+          <a:bodyPr wrap="square" lIns="0" tIns="0" rIns="0" bIns="0" rtlCol="0" anchor="ctr"/>
+          <a:lstStyle/>
+          <a:p>
+            <a:pPr indent="0" marL="0">
+              <a:buNone/>
+            </a:pPr>
+            <a:r>
+              <a:rPr lang="en-US" sz="1600" b="1" dirty="0">
+                <a:solidFill>
+                  <a:srgbClr val="0B7A4A"/>
+                </a:solidFill>
+                <a:latin typeface="Inter" pitchFamily="34" charset="0"/>
+                <a:ea typeface="Inter" pitchFamily="34" charset="-122"/>
+                <a:cs typeface="Inter" pitchFamily="34" charset="-120"/>
+              </a:rPr>
+              <a:t>25 stores set a January–September record in gross profit and 21 in net profit; 18 did both.</a:t>
             </a:r>
             <a:endParaRPr lang="en-US" sz="1600" dirty="0"/>
           </a:p>

</xml_diff>